<commit_message>
Capability security slide update
</commit_message>
<xml_diff>
--- a/docs/graffiticode-capability-security-spacing.pptx
+++ b/docs/graffiticode-capability-security-spacing.pptx
@@ -442,12 +442,33 @@
           </p:nvPr>
         </p:nvSpPr>
         <p:spPr/>
-        <p:txBody>
-          <a:bodyPr xmlns:a="http://schemas.openxmlformats.org/drawingml/2006/main"/>
-          <a:lstStyle xmlns:a="http://schemas.openxmlformats.org/drawingml/2006/main"/>
-          <a:p xmlns:a="http://schemas.openxmlformats.org/drawingml/2006/main">
-            <a:r>
-              <a:t>Scope: delegated external API permissions. “Standard” means the classic object-capability model, not identity/role-based IAM. The design explicitly calls itself owner-managed delegated authorization with scoped execution tokens. Sources: /Users/jeffdyer/work/graffiticode/console/docs/graffiticode_capability_policy_spec.md, Goal and terminology; /Users/jeffdyer/work/graffiticode/graffiticode/packages/policy/src/policy.js; /Users/jeffdyer/work/graffiticode/graffiticode/packages/broker/src/broker.js. Prepared 2026-09-30.</a:t>
+        <p:txBody xmlns:a="http://schemas.openxmlformats.org/drawingml/2006/main">
+          <a:bodyPr wrap="square">
+            <a:noAutofit/>
+          </a:bodyPr>
+          <a:lstStyle/>
+          <a:p>
+            <a:pPr>
+              <a:buNone/>
+              <a:defRPr sz="1200" b="0">
+                <a:solidFill>
+                  <a:srgbClr val="000000"/>
+                </a:solidFill>
+                <a:latin typeface="Helvetica Neue"/>
+                <a:ea typeface="Helvetica Neue"/>
+                <a:cs typeface="Helvetica Neue"/>
+              </a:defRPr>
+            </a:pPr>
+            <a:r>
+              <a:rPr sz="1200" b="0">
+                <a:solidFill>
+                  <a:srgbClr val="000000"/>
+                </a:solidFill>
+                <a:latin typeface="Helvetica Neue"/>
+                <a:ea typeface="Helvetica Neue"/>
+                <a:cs typeface="Helvetica Neue"/>
+              </a:rPr>
+              <a:t>Scope: owner-managed delegated authorization with scoped execution tokens, a hybrid of identity policy and capability-style execution. Chain admission and Broker execution-time authorization are intended requirements. Source: docs/graffiticode_capability_policy_spec.md, revision 2026-10-02, contract v2. Implementation evidence: docs/capability-policy-as-built.md. This deck describes required behavior, not deployed conformance. Requirements MODEL-01 through MODEL-03.</a:t>
             </a:r>
           </a:p>
         </p:txBody>
@@ -512,12 +533,33 @@
           </p:nvPr>
         </p:nvSpPr>
         <p:spPr/>
-        <p:txBody>
-          <a:bodyPr xmlns:a="http://schemas.openxmlformats.org/drawingml/2006/main"/>
-          <a:lstStyle xmlns:a="http://schemas.openxmlformats.org/drawingml/2006/main"/>
-          <a:p xmlns:a="http://schemas.openxmlformats.org/drawingml/2006/main">
-            <a:r>
-              <a:t>Interaction diagram for the authenticated brokered run path. Setup: Console authenticates the user through Auth; Auth supplies the user token. Console manages connections and grants through Policy. When creating or rotating a connection, Policy passes the credential to Broker for sealed storage; Policy does not persist the secret. A grant-only change does not provision a credential. Run: Console sends a compile request and selected connection to API. API requests a signed invocation from Policy, then routes compilation with invocation and user context to Compiler. Compiler requests an admission snapshot from Policy, checks all protected calls, and asks Policy to mint a token at each protected call. The diagram labels token issuance at step 7; the separate admission snapshot request is omitted for readability. Step 9 shows Broker making the external service call using the stored credential. Policy rechecks live access on mint. Compiler sends the token and bound payload to Broker. Broker verifies caller, registry, operation, digest and single-use token, then calls the external provider with the stored credential and returns the result. The arrows show requests only; responses are omitted to keep the diagram readable. User tokens propagate in trusted request context; Auth is not a mandatory live network hop for every policy decision. Service identity is separately verified using Google ID tokens. Sources: /Users/jeffdyer/work/graffiticode/console/docs/graffiticode_capability_policy_spec.md, Protected compile and call and Credentials; /Users/jeffdyer/work/graffiticode/console/docs/capability-policy-as-built.md, How it works and Trust boundaries; /Users/jeffdyer/work/graffiticode/graffiticode/packages/api/src/data.js; /Users/jeffdyer/work/graffiticode/graffiticode/packages/policy/src/app.js; /Users/jeffdyer/work/graffiticode/graffiticode/packages/policy/src/main.js; /Users/jeffdyer/work/graffiticode/graffiticode/packages/broker/src/broker.js.</a:t>
+        <p:txBody xmlns:a="http://schemas.openxmlformats.org/drawingml/2006/main">
+          <a:bodyPr wrap="square">
+            <a:noAutofit/>
+          </a:bodyPr>
+          <a:lstStyle/>
+          <a:p>
+            <a:pPr>
+              <a:buNone/>
+              <a:defRPr sz="1200" b="0">
+                <a:solidFill>
+                  <a:srgbClr val="000000"/>
+                </a:solidFill>
+                <a:latin typeface="Helvetica Neue"/>
+                <a:ea typeface="Helvetica Neue"/>
+                <a:cs typeface="Helvetica Neue"/>
+              </a:defRPr>
+            </a:pPr>
+            <a:r>
+              <a:rPr sz="1200" b="0">
+                <a:solidFill>
+                  <a:srgbClr val="000000"/>
+                </a:solidFill>
+                <a:latin typeface="Helvetica Neue"/>
+                <a:ea typeface="Helvetica Neue"/>
+                <a:cs typeface="Helvetica Neue"/>
+              </a:rPr>
+              <a:t>Identity and connection provisioning precede this diagram. Auth verifies the user; service identity is verified independently. Only Policy provisions Broker secrets. API means the gateway; Compiler represents each pinned compiler revision in the composition. API allocates the invocation, collects every stage preflight, and obtains one Policy admission before executing any stage. Stage sessions and execution tokens inherit the admitted plan binding. Steps 6–8 recur for each protected operation. Broker validates token, caller, registry, payload digest, credential binding and single-use status, then requests uncached live Policy authorization before every provider request or signature, including each step of a multi-request write. Branch 9a is a provider write. Branch 9b returns signed provider data through Compiler and API to Browser; its dashed arrow depicts this logical return, not a direct Broker/browser transport. Browser uses that request at step 10. Minting and stage-session responses are omitted. Source: docs/graffiticode_capability_policy_spec.md, revision 2026-10-02, contract v2. Implementation evidence: docs/capability-policy-as-built.md. This deck describes required behavior, not deployed conformance. Requirements AUTH-01, ADMIT-01 through ADMIT-03, EXEC-01, EXEC-02, API-01 and API-02.</a:t>
             </a:r>
           </a:p>
         </p:txBody>
@@ -582,12 +624,33 @@
           </p:nvPr>
         </p:nvSpPr>
         <p:spPr/>
-        <p:txBody>
-          <a:bodyPr xmlns:a="http://schemas.openxmlformats.org/drawingml/2006/main"/>
-          <a:lstStyle xmlns:a="http://schemas.openxmlformats.org/drawingml/2006/main"/>
-          <a:p xmlns:a="http://schemas.openxmlformats.org/drawingml/2006/main">
-            <a:r>
-              <a:t>Sources: /Users/jeffdyer/work/graffiticode/console/docs/graffiticode_capability_policy_spec.md, Protected compile and call; /Users/jeffdyer/work/graffiticode/graffiticode/packages/policy/src/policy.js snapshot/mint/issueExecution; /Users/jeffdyer/work/graffiticode/graffiticode/packages/broker/src/broker.js execute; /Users/jeffdyer/work/graffiticode/graffiticode/packages/common/src/protected-registry.js. Tokens bind recipient, immutable connection owner, connection, backend, language, function, operation, registry version, operation ID and args digest. Broker also verifies the caller is a compiler for that language. The broker boundary protects broker-held connection credentials; legacy paths remain a separate migration concern.</a:t>
+        <p:txBody xmlns:a="http://schemas.openxmlformats.org/drawingml/2006/main">
+          <a:bodyPr wrap="square">
+            <a:noAutofit/>
+          </a:bodyPr>
+          <a:lstStyle/>
+          <a:p>
+            <a:pPr>
+              <a:buNone/>
+              <a:defRPr sz="1200" b="0">
+                <a:solidFill>
+                  <a:srgbClr val="000000"/>
+                </a:solidFill>
+                <a:latin typeface="Helvetica Neue"/>
+                <a:ea typeface="Helvetica Neue"/>
+                <a:cs typeface="Helvetica Neue"/>
+              </a:defRPr>
+            </a:pPr>
+            <a:r>
+              <a:rPr sz="1200" b="0">
+                <a:solidFill>
+                  <a:srgbClr val="000000"/>
+                </a:solidFill>
+                <a:latin typeface="Helvetica Neue"/>
+                <a:ea typeface="Helvetica Neue"/>
+                <a:cs typeface="Helvetica Neue"/>
+              </a:rPr>
+              <a:t>The admitted plan binds the complete ordered stages, normalized programs, immutable compiler revisions, connection, invocation, input digest and registry version. Retry identity is retained. Execution tokens expire in at most 60 seconds and are single-use at Broker; that property does not apply to provider sessions. Durable receipts bind operation identity and arguments, survive retries and have no automatic expiry. Pending or uncertain receipts never trigger automatic re-execution. A deliberate new invocation may repeat writes. Source: docs/graffiticode_capability_policy_spec.md, revision 2026-10-02, contract v2. Implementation evidence: docs/capability-policy-as-built.md. This deck describes required behavior, not deployed conformance. Requirements RUN-01, ADMIT-01 through ADMIT-03, TOKEN-01, WRITE-01, WRITE-02 and RETAIN-01.</a:t>
             </a:r>
           </a:p>
         </p:txBody>
@@ -652,12 +715,33 @@
           </p:nvPr>
         </p:nvSpPr>
         <p:spPr/>
-        <p:txBody>
-          <a:bodyPr xmlns:a="http://schemas.openxmlformats.org/drawingml/2006/main"/>
-          <a:lstStyle xmlns:a="http://schemas.openxmlformats.org/drawingml/2006/main"/>
-          <a:p xmlns:a="http://schemas.openxmlformats.org/drawingml/2006/main">
-            <a:r>
-              <a:t>Sources: /Users/jeffdyer/work/graffiticode/console/docs/graffiticode_capability_policy_spec.md, Why this design and Decided/Revocation; /Users/jeffdyer/work/graffiticode/graffiticode/packages/policy/src/policy.js mint; /Users/jeffdyer/work/graffiticode/graffiticode/packages/broker/src/broker.js execute; /Users/jeffdyer/work/graffiticode/graffiticode/packages/policy/src/tokens.js. Admission is an early-error and partial-side-effect prevention measure against the snapshot, not an atomic transaction or the decisive boundary. Every mint rechecks live policy. An execution token already issued remains usable until expiry (at most 60 seconds), subject to broker checks, single-use enforcement and credential availability. Central policy creates an availability dependency and an additional round trip for each protected call. Classic capabilities can revoke via interposition; see https://www.erights.org/elib/capability/duals/myths.html.</a:t>
+        <p:txBody xmlns:a="http://schemas.openxmlformats.org/drawingml/2006/main">
+          <a:bodyPr wrap="square">
+            <a:noAutofit/>
+          </a:bodyPr>
+          <a:lstStyle/>
+          <a:p>
+            <a:pPr>
+              <a:buNone/>
+              <a:defRPr sz="1200" b="0">
+                <a:solidFill>
+                  <a:srgbClr val="000000"/>
+                </a:solidFill>
+                <a:latin typeface="Helvetica Neue"/>
+                <a:ea typeface="Helvetica Neue"/>
+                <a:cs typeface="Helvetica Neue"/>
+              </a:defRPr>
+            </a:pPr>
+            <a:r>
+              <a:rPr sz="1200" b="0">
+                <a:solidFill>
+                  <a:srgbClr val="000000"/>
+                </a:solidFill>
+                <a:latin typeface="Helvetica Neue"/>
+                <a:ea typeface="Helvetica Neue"/>
+                <a:cs typeface="Helvetica Neue"/>
+              </a:rPr>
+              <a:t>Admission is chain-wide: denial of a later stage prevents earlier effects. Policy also rechecks at mint; the right column adds the required Broker-to-Policy check immediately before each effect or receipt replay. Checks fail closed when Policy is unavailable. Revocation committed before the authorization read is observed. A check that precedes revocation may authorize immediately following dispatch; no distributed provider transaction or rollback is promised. Revoke between provider writes and later steps stop, with known completed steps preserved. Existing browser sessions obey separately verified provider lifetime/revocation limits. Source: docs/graffiticode_capability_policy_spec.md, revision 2026-10-02, contract v2. Implementation evidence: docs/capability-policy-as-built.md. This deck describes required behavior, not deployed conformance. Requirements ADMIT-02, EXEC-02, REVOKE-01, WRITE-01 and PROVIDER-01.</a:t>
             </a:r>
           </a:p>
         </p:txBody>
@@ -722,12 +806,33 @@
           </p:nvPr>
         </p:nvSpPr>
         <p:spPr/>
-        <p:txBody>
-          <a:bodyPr xmlns:a="http://schemas.openxmlformats.org/drawingml/2006/main"/>
-          <a:lstStyle xmlns:a="http://schemas.openxmlformats.org/drawingml/2006/main"/>
-          <a:p xmlns:a="http://schemas.openxmlformats.org/drawingml/2006/main">
-            <a:r>
-              <a:t>Brokered connection model: the owner manages grants through Policy. Policy authorizes specific compiler calls and issues scoped tokens. The compiler forwards tokens and payloads to Broker. Broker verifies the token and uses the stored credential internally to call external providers. Connection credentials are persisted only in the Broker-owned store, encrypted with a Broker-only key. The external secret-management API allows POST (create), PUT (rotate) and DELETE. It exposes no GET/read-back endpoint and never echoes credential values. Only the Policy service may provision or delete credentials. Console and Policy handle the credential transiently during provisioning, without retaining it. No read-back describes the external API, not the Broker’s necessary internal retrieval of a secret to use it. This is the brokered connection model, not a claim that all legacy credential paths have migrated. The diagram’s Policy-to-Broker arrow represents token authority relayed through Compiler. Sources: /Users/jeffdyer/work/graffiticode/graffiticode/packages/broker/src/app.js (provisioning routes and role check); /Users/jeffdyer/work/graffiticode/graffiticode/packages/broker/src/broker.js (credential retrieval and operation.run); /Users/jeffdyer/work/graffiticode/console/docs/graffiticode_capability_policy_spec.md (Credentials); /Users/jeffdyer/work/graffiticode/graffiticode/packages/policy/src/policy.js.</a:t>
+        <p:txBody xmlns:a="http://schemas.openxmlformats.org/drawingml/2006/main">
+          <a:bodyPr wrap="square">
+            <a:noAutofit/>
+          </a:bodyPr>
+          <a:lstStyle/>
+          <a:p>
+            <a:pPr>
+              <a:buNone/>
+              <a:defRPr sz="1200" b="0">
+                <a:solidFill>
+                  <a:srgbClr val="000000"/>
+                </a:solidFill>
+                <a:latin typeface="Helvetica Neue"/>
+                <a:ea typeface="Helvetica Neue"/>
+                <a:cs typeface="Helvetica Neue"/>
+              </a:defRPr>
+            </a:pPr>
+            <a:r>
+              <a:rPr sz="1200" b="0">
+                <a:solidFill>
+                  <a:srgbClr val="000000"/>
+                </a:solidFill>
+                <a:latin typeface="Helvetica Neue"/>
+                <a:ea typeface="Helvetica Neue"/>
+                <a:cs typeface="Helvetica Neue"/>
+              </a:rPr>
+              <a:t>Alice grants Bob exactly L0176 save-to-itembank on her connection. Implicit delegable init preview permission accompanies it. The grant does not cover another language, item-scoped access, onward sharing, publication or Author. Save operations create draft records; they do not publish. Only a connection owner can publish their own eligible artifact. Author is owner-only but disabled at both Policy and Broker until provider request shape, edit/delete/reference/widget restrictions and session limits pass real integration tests. Source: docs/graffiticode_capability_policy_spec.md, revision 2026-10-02, contract v2. Implementation evidence: docs/capability-policy-as-built.md. This deck describes required behavior, not deployed conformance. Requirements GRANT-01, L0176-01, AUTHOR-01 and PUB-01.</a:t>
             </a:r>
           </a:p>
         </p:txBody>
@@ -792,12 +897,33 @@
           </p:nvPr>
         </p:nvSpPr>
         <p:spPr/>
-        <p:txBody>
-          <a:bodyPr xmlns:a="http://schemas.openxmlformats.org/drawingml/2006/main"/>
-          <a:lstStyle xmlns:a="http://schemas.openxmlformats.org/drawingml/2006/main"/>
-          <a:p xmlns:a="http://schemas.openxmlformats.org/drawingml/2006/main">
-            <a:r>
-              <a:t>Summary of the brokered connection path. The connection owner grants a recipient account access to specific language/function pairs. The recipient selects a connection; the gateway supplies verified invocation context. The compiler performs admission, requests a scoped execution token from policy, and forwards that token with the payload to the broker. The policy-to-broker arrow is a logical authorization flow through the compiler, not a direct network request. Policy checks live grants at each mint; the broker checks signature, caller language, registry, named operation, payload digest, credential binding and single-use status. The broker retains the connection credential and calls the external provider. Execution tokens last at most 60 seconds. This summarizes the brokered model, not a claim that every legacy credential path has migrated. Sources: /Users/jeffdyer/work/graffiticode/console/docs/graffiticode_capability_policy_spec.md, Goal and terminology and Protected compile and call; /Users/jeffdyer/work/graffiticode/graffiticode/packages/policy/src/policy.js; /Users/jeffdyer/work/graffiticode/graffiticode/packages/broker/src/broker.js; /Users/jeffdyer/work/graffiticode/graffiticode/packages/common/src/protected-registry.js.</a:t>
+        <p:txBody xmlns:a="http://schemas.openxmlformats.org/drawingml/2006/main">
+          <a:bodyPr wrap="square">
+            <a:noAutofit/>
+          </a:bodyPr>
+          <a:lstStyle/>
+          <a:p>
+            <a:pPr>
+              <a:buNone/>
+              <a:defRPr sz="1200" b="0">
+                <a:solidFill>
+                  <a:srgbClr val="000000"/>
+                </a:solidFill>
+                <a:latin typeface="Helvetica Neue"/>
+                <a:ea typeface="Helvetica Neue"/>
+                <a:cs typeface="Helvetica Neue"/>
+              </a:defRPr>
+            </a:pPr>
+            <a:r>
+              <a:rPr sz="1200" b="0">
+                <a:solidFill>
+                  <a:srgbClr val="000000"/>
+                </a:solidFill>
+                <a:latin typeface="Helvetica Neue"/>
+                <a:ea typeface="Helvetica Neue"/>
+                <a:cs typeface="Helvetica Neue"/>
+              </a:rPr>
+              <a:t>Arrows summarize authority relationships. Gateway coordinates preflight; Policy admits the full chain and rechecks at mint and execution. The two-way Policy/Broker link includes Broker’s live authorization request. Broker alone stores connection secrets, encrypted and bound to immutable owner/backend/provider identity. Console and Policy handle secrets only transiently when provisioning; Broker has create/rotate/delete and no read-back API. Enforced egress and least-privilege identities prevent compiler bypass; old provider credentials must be invalidated. Provider writes occur at Broker; browser signing follows slide 2. System previews have no user grant and cannot write or issue Author authority. Private and published views use unsigned stored artifacts and fresh preview authority, never rerun source saves. Publication is owner-only and pins immutable artifact content. Source: docs/graffiticode_capability_policy_spec.md, revision 2026-10-02, contract v2. Implementation evidence: docs/capability-policy-as-built.md. This deck describes required behavior, not deployed conformance. Requirements SECRET-01, ISOLATE-01, PREVIEW-01, ARTIFACT-01, READ-01, PUB-01 and RELEASE-01.</a:t>
             </a:r>
           </a:p>
         </p:txBody>
@@ -1520,6 +1646,88 @@
             <a:noFill/>
           </a:ln>
         </p:spPr>
+        <p:txBody xmlns:a="http://schemas.openxmlformats.org/drawingml/2006/main">
+          <a:bodyPr wrap="square">
+            <a:noAutofit/>
+          </a:bodyPr>
+          <a:lstStyle/>
+          <a:p>
+            <a:pPr>
+              <a:buNone/>
+              <a:defRPr sz="3600" b="1">
+                <a:solidFill>
+                  <a:srgbClr val="A7E1C7"/>
+                </a:solidFill>
+                <a:latin typeface="Helvetica Neue"/>
+                <a:ea typeface="Helvetica Neue"/>
+                <a:cs typeface="Helvetica Neue"/>
+              </a:defRPr>
+            </a:pPr>
+            <a:r>
+              <a:rPr sz="3600" b="1">
+                <a:solidFill>
+                  <a:srgbClr val="A7E1C7"/>
+                </a:solidFill>
+                <a:latin typeface="Helvetica Neue"/>
+                <a:ea typeface="Helvetica Neue"/>
+                <a:cs typeface="Helvetica Neue"/>
+              </a:rPr>
+              <a:t>Owner-managed grants.</a:t>
+            </a:r>
+          </a:p>
+          <a:p>
+            <a:pPr>
+              <a:buNone/>
+              <a:defRPr sz="3600" b="1">
+                <a:solidFill>
+                  <a:srgbClr val="A7E1C7"/>
+                </a:solidFill>
+                <a:latin typeface="Helvetica Neue"/>
+                <a:ea typeface="Helvetica Neue"/>
+                <a:cs typeface="Helvetica Neue"/>
+              </a:defRPr>
+            </a:pPr>
+            <a:r>
+              <a:rPr sz="3600" b="1">
+                <a:solidFill>
+                  <a:srgbClr val="A7E1C7"/>
+                </a:solidFill>
+                <a:latin typeface="Helvetica Neue"/>
+                <a:ea typeface="Helvetica Neue"/>
+                <a:cs typeface="Helvetica Neue"/>
+              </a:rPr>
+              <a:t>Live checks for every protected call.</a:t>
+            </a:r>
+          </a:p>
+        </p:txBody>
+      </p:sp>
+      <p:sp>
+        <p:nvSpPr>
+          <p:cNvPr id="3" name="">
+            <a:extLst xmlns:a="http://schemas.openxmlformats.org/drawingml/2006/main">
+              <a:ext uri="{FF2B5EF4-FFF2-40B4-BE49-F238E27FC236}">
+                <a16:creationId xmlns:a16="http://schemas.microsoft.com/office/drawing/2014/main" id="{EEB606F3-B174-474B-9540-974939DF3F10}"/>
+              </a:ext>
+            </a:extLst>
+          </p:cNvPr>
+          <p:cNvSpPr>
+            <a:spLocks xmlns:a="http://schemas.openxmlformats.org/drawingml/2006/main" noGrp="1"/>
+          </p:cNvSpPr>
+          <p:nvPr/>
+        </p:nvSpPr>
+        <p:spPr>
+          <a:xfrm xmlns:a="http://schemas.openxmlformats.org/drawingml/2006/main">
+            <a:off x="609600" y="4552950"/>
+            <a:ext cx="9906000" cy="876300"/>
+          </a:xfrm>
+          <a:prstGeom xmlns:a="http://schemas.openxmlformats.org/drawingml/2006/main" prst="rect">
+            <a:avLst/>
+          </a:prstGeom>
+          <a:noFill xmlns:a="http://schemas.openxmlformats.org/drawingml/2006/main"/>
+          <a:ln xmlns:a="http://schemas.openxmlformats.org/drawingml/2006/main" w="0">
+            <a:noFill/>
+          </a:ln>
+        </p:spPr>
         <p:txBody>
           <a:bodyPr xmlns:a="http://schemas.openxmlformats.org/drawingml/2006/main">
             <a:noAutofit/>
@@ -1528,88 +1736,6 @@
           <a:p xmlns:a="http://schemas.openxmlformats.org/drawingml/2006/main">
             <a:pPr>
               <a:buNone/>
-              <a:defRPr sz="3600" b="1">
-                <a:solidFill>
-                  <a:srgbClr val="A7E1C7"/>
-                </a:solidFill>
-                <a:latin typeface="Helvetica Neue"/>
-                <a:ea typeface="Helvetica Neue"/>
-                <a:cs typeface="Helvetica Neue"/>
-              </a:defRPr>
-            </a:pPr>
-            <a:r>
-              <a:rPr sz="3600" b="1">
-                <a:solidFill>
-                  <a:srgbClr val="A7E1C7"/>
-                </a:solidFill>
-                <a:latin typeface="Helvetica Neue"/>
-                <a:ea typeface="Helvetica Neue"/>
-                <a:cs typeface="Helvetica Neue"/>
-              </a:rPr>
-              <a:t>Owner-managed grants.</a:t>
-            </a:r>
-          </a:p>
-          <a:p xmlns:a="http://schemas.openxmlformats.org/drawingml/2006/main">
-            <a:pPr>
-              <a:buNone/>
-              <a:defRPr sz="3600" b="1">
-                <a:solidFill>
-                  <a:srgbClr val="A7E1C7"/>
-                </a:solidFill>
-                <a:latin typeface="Helvetica Neue"/>
-                <a:ea typeface="Helvetica Neue"/>
-                <a:cs typeface="Helvetica Neue"/>
-              </a:defRPr>
-            </a:pPr>
-            <a:r>
-              <a:rPr sz="3600" b="1">
-                <a:solidFill>
-                  <a:srgbClr val="A7E1C7"/>
-                </a:solidFill>
-                <a:latin typeface="Helvetica Neue"/>
-                <a:ea typeface="Helvetica Neue"/>
-                <a:cs typeface="Helvetica Neue"/>
-              </a:rPr>
-              <a:t>Proof for each protected call.</a:t>
-            </a:r>
-          </a:p>
-        </p:txBody>
-      </p:sp>
-      <p:sp>
-        <p:nvSpPr>
-          <p:cNvPr id="3" name="">
-            <a:extLst xmlns:a="http://schemas.openxmlformats.org/drawingml/2006/main">
-              <a:ext uri="{FF2B5EF4-FFF2-40B4-BE49-F238E27FC236}">
-                <a16:creationId xmlns:a16="http://schemas.microsoft.com/office/drawing/2014/main" id="{EEB606F3-B174-474B-9540-974939DF3F10}"/>
-              </a:ext>
-            </a:extLst>
-          </p:cNvPr>
-          <p:cNvSpPr>
-            <a:spLocks xmlns:a="http://schemas.openxmlformats.org/drawingml/2006/main" noGrp="1"/>
-          </p:cNvSpPr>
-          <p:nvPr/>
-        </p:nvSpPr>
-        <p:spPr>
-          <a:xfrm xmlns:a="http://schemas.openxmlformats.org/drawingml/2006/main">
-            <a:off x="609600" y="4552950"/>
-            <a:ext cx="9906000" cy="876300"/>
-          </a:xfrm>
-          <a:prstGeom xmlns:a="http://schemas.openxmlformats.org/drawingml/2006/main" prst="rect">
-            <a:avLst/>
-          </a:prstGeom>
-          <a:noFill xmlns:a="http://schemas.openxmlformats.org/drawingml/2006/main"/>
-          <a:ln xmlns:a="http://schemas.openxmlformats.org/drawingml/2006/main" w="0">
-            <a:noFill/>
-          </a:ln>
-        </p:spPr>
-        <p:txBody>
-          <a:bodyPr xmlns:a="http://schemas.openxmlformats.org/drawingml/2006/main">
-            <a:noAutofit/>
-          </a:bodyPr>
-          <a:lstStyle xmlns:a="http://schemas.openxmlformats.org/drawingml/2006/main"/>
-          <a:p xmlns:a="http://schemas.openxmlformats.org/drawingml/2006/main">
-            <a:pPr>
-              <a:buNone/>
               <a:defRPr sz="2250" b="0">
                 <a:solidFill>
                   <a:srgbClr val="FFFFFF"/>
@@ -1650,22 +1776,22 @@
         <p:spPr>
           <a:xfrm xmlns:a="http://schemas.openxmlformats.org/drawingml/2006/main">
             <a:off x="609600" y="5810250"/>
-            <a:ext cx="10001250" cy="285750"/>
-          </a:xfrm>
-          <a:prstGeom xmlns:a="http://schemas.openxmlformats.org/drawingml/2006/main" prst="rect">
-            <a:avLst/>
-          </a:prstGeom>
-          <a:noFill xmlns:a="http://schemas.openxmlformats.org/drawingml/2006/main"/>
-          <a:ln xmlns:a="http://schemas.openxmlformats.org/drawingml/2006/main" w="0">
-            <a:noFill/>
-          </a:ln>
-        </p:spPr>
-        <p:txBody>
-          <a:bodyPr xmlns:a="http://schemas.openxmlformats.org/drawingml/2006/main">
-            <a:noAutofit/>
-          </a:bodyPr>
-          <a:lstStyle xmlns:a="http://schemas.openxmlformats.org/drawingml/2006/main"/>
-          <a:p xmlns:a="http://schemas.openxmlformats.org/drawingml/2006/main">
+            <a:ext cx="10001250" cy="609600"/>
+          </a:xfrm>
+          <a:prstGeom xmlns:a="http://schemas.openxmlformats.org/drawingml/2006/main" prst="rect">
+            <a:avLst/>
+          </a:prstGeom>
+          <a:noFill xmlns:a="http://schemas.openxmlformats.org/drawingml/2006/main"/>
+          <a:ln xmlns:a="http://schemas.openxmlformats.org/drawingml/2006/main" w="0">
+            <a:noFill/>
+          </a:ln>
+        </p:spPr>
+        <p:txBody xmlns:a="http://schemas.openxmlformats.org/drawingml/2006/main">
+          <a:bodyPr wrap="square">
+            <a:noAutofit/>
+          </a:bodyPr>
+          <a:lstStyle/>
+          <a:p>
             <a:pPr>
               <a:buNone/>
               <a:defRPr sz="1575" b="0">
@@ -1686,7 +1812,31 @@
                 <a:ea typeface="Helvetica Neue"/>
                 <a:cs typeface="Helvetica Neue"/>
               </a:rPr>
-              <a:t>Comparison with the classic object-capability model</a:t>
+              <a:t>Intended design, contract v2</a:t>
+            </a:r>
+          </a:p>
+          <a:p>
+            <a:pPr>
+              <a:buNone/>
+              <a:defRPr sz="1575" b="0">
+                <a:solidFill>
+                  <a:srgbClr val="B8CCC3"/>
+                </a:solidFill>
+                <a:latin typeface="Helvetica Neue"/>
+                <a:ea typeface="Helvetica Neue"/>
+                <a:cs typeface="Helvetica Neue"/>
+              </a:defRPr>
+            </a:pPr>
+            <a:r>
+              <a:rPr sz="1575" b="0">
+                <a:solidFill>
+                  <a:srgbClr val="B8CCC3"/>
+                </a:solidFill>
+                <a:latin typeface="Helvetica Neue"/>
+                <a:ea typeface="Helvetica Neue"/>
+                <a:cs typeface="Helvetica Neue"/>
+              </a:rPr>
+              <a:t>Specification dated 2 October 2026</a:t>
             </a:r>
           </a:p>
         </p:txBody>
@@ -1805,12 +1955,12 @@
             <a:noFill/>
           </a:ln>
         </p:spPr>
-        <p:txBody>
-          <a:bodyPr xmlns:a="http://schemas.openxmlformats.org/drawingml/2006/main">
-            <a:noAutofit/>
-          </a:bodyPr>
-          <a:lstStyle xmlns:a="http://schemas.openxmlformats.org/drawingml/2006/main"/>
-          <a:p xmlns:a="http://schemas.openxmlformats.org/drawingml/2006/main">
+        <p:txBody xmlns:a="http://schemas.openxmlformats.org/drawingml/2006/main">
+          <a:bodyPr wrap="square">
+            <a:noAutofit/>
+          </a:bodyPr>
+          <a:lstStyle/>
+          <a:p>
             <a:pPr>
               <a:buNone/>
               <a:defRPr sz="2025" b="0">
@@ -1831,7 +1981,7 @@
                 <a:ea typeface="Helvetica Neue"/>
                 <a:cs typeface="Helvetica Neue"/>
               </a:rPr>
-              <a:t>Auth establishes identity. API routes the run. Policy and Broker enforce authority.</a:t>
+              <a:t>Auth verifies identity. API preflights every stage before Policy admits the chain.</a:t>
             </a:r>
           </a:p>
         </p:txBody>
@@ -1893,12 +2043,12 @@
             <a:noFill/>
           </a:ln>
         </p:spPr>
-        <p:txBody>
-          <a:bodyPr xmlns:a="http://schemas.openxmlformats.org/drawingml/2006/main">
-            <a:noAutofit/>
-          </a:bodyPr>
-          <a:lstStyle xmlns:a="http://schemas.openxmlformats.org/drawingml/2006/main"/>
-          <a:p xmlns:a="http://schemas.openxmlformats.org/drawingml/2006/main">
+        <p:txBody xmlns:a="http://schemas.openxmlformats.org/drawingml/2006/main">
+          <a:bodyPr wrap="square">
+            <a:noAutofit/>
+          </a:bodyPr>
+          <a:lstStyle/>
+          <a:p>
             <a:pPr>
               <a:buNone/>
               <a:defRPr sz="1875" b="1">
@@ -1919,7 +2069,7 @@
                 <a:ea typeface="Helvetica Neue"/>
                 <a:cs typeface="Helvetica Neue"/>
               </a:rPr>
-              <a:t>Console</a:t>
+              <a:t>Client</a:t>
             </a:r>
           </a:p>
         </p:txBody>
@@ -1941,7 +2091,7 @@
         <p:spPr>
           <a:xfrm xmlns:a="http://schemas.openxmlformats.org/drawingml/2006/main">
             <a:off x="1143000" y="2228850"/>
-            <a:ext cx="0" cy="4029075"/>
+            <a:ext cx="0" cy="3886200"/>
           </a:xfrm>
           <a:prstGeom xmlns:a="http://schemas.openxmlformats.org/drawingml/2006/main" prst="line">
             <a:avLst/>
@@ -2012,12 +2162,12 @@
             <a:noFill/>
           </a:ln>
         </p:spPr>
-        <p:txBody>
-          <a:bodyPr xmlns:a="http://schemas.openxmlformats.org/drawingml/2006/main">
-            <a:noAutofit/>
-          </a:bodyPr>
-          <a:lstStyle xmlns:a="http://schemas.openxmlformats.org/drawingml/2006/main"/>
-          <a:p xmlns:a="http://schemas.openxmlformats.org/drawingml/2006/main">
+        <p:txBody xmlns:a="http://schemas.openxmlformats.org/drawingml/2006/main">
+          <a:bodyPr wrap="square">
+            <a:noAutofit/>
+          </a:bodyPr>
+          <a:lstStyle/>
+          <a:p>
             <a:pPr>
               <a:buNone/>
               <a:defRPr sz="1875" b="1">
@@ -2038,7 +2188,7 @@
                 <a:ea typeface="Helvetica Neue"/>
                 <a:cs typeface="Helvetica Neue"/>
               </a:rPr>
-              <a:t>Auth</a:t>
+              <a:t>API</a:t>
             </a:r>
           </a:p>
         </p:txBody>
@@ -2060,7 +2210,7 @@
         <p:spPr>
           <a:xfrm xmlns:a="http://schemas.openxmlformats.org/drawingml/2006/main">
             <a:off x="2743200" y="2228850"/>
-            <a:ext cx="0" cy="4029075"/>
+            <a:ext cx="0" cy="3886200"/>
           </a:xfrm>
           <a:prstGeom xmlns:a="http://schemas.openxmlformats.org/drawingml/2006/main" prst="line">
             <a:avLst/>
@@ -2131,12 +2281,12 @@
             <a:noFill/>
           </a:ln>
         </p:spPr>
-        <p:txBody>
-          <a:bodyPr xmlns:a="http://schemas.openxmlformats.org/drawingml/2006/main">
-            <a:noAutofit/>
-          </a:bodyPr>
-          <a:lstStyle xmlns:a="http://schemas.openxmlformats.org/drawingml/2006/main"/>
-          <a:p xmlns:a="http://schemas.openxmlformats.org/drawingml/2006/main">
+        <p:txBody xmlns:a="http://schemas.openxmlformats.org/drawingml/2006/main">
+          <a:bodyPr wrap="square">
+            <a:noAutofit/>
+          </a:bodyPr>
+          <a:lstStyle/>
+          <a:p>
             <a:pPr>
               <a:buNone/>
               <a:defRPr sz="1875" b="1">
@@ -2157,7 +2307,7 @@
                 <a:ea typeface="Helvetica Neue"/>
                 <a:cs typeface="Helvetica Neue"/>
               </a:rPr>
-              <a:t>API</a:t>
+              <a:t>Compiler</a:t>
             </a:r>
           </a:p>
         </p:txBody>
@@ -2179,7 +2329,7 @@
         <p:spPr>
           <a:xfrm xmlns:a="http://schemas.openxmlformats.org/drawingml/2006/main">
             <a:off x="4343400" y="2228850"/>
-            <a:ext cx="0" cy="4029075"/>
+            <a:ext cx="0" cy="3886200"/>
           </a:xfrm>
           <a:prstGeom xmlns:a="http://schemas.openxmlformats.org/drawingml/2006/main" prst="line">
             <a:avLst/>
@@ -2250,12 +2400,12 @@
             <a:noFill/>
           </a:ln>
         </p:spPr>
-        <p:txBody>
-          <a:bodyPr xmlns:a="http://schemas.openxmlformats.org/drawingml/2006/main">
-            <a:noAutofit/>
-          </a:bodyPr>
-          <a:lstStyle xmlns:a="http://schemas.openxmlformats.org/drawingml/2006/main"/>
-          <a:p xmlns:a="http://schemas.openxmlformats.org/drawingml/2006/main">
+        <p:txBody xmlns:a="http://schemas.openxmlformats.org/drawingml/2006/main">
+          <a:bodyPr wrap="square">
+            <a:noAutofit/>
+          </a:bodyPr>
+          <a:lstStyle/>
+          <a:p>
             <a:pPr>
               <a:buNone/>
               <a:defRPr sz="1875" b="1">
@@ -2276,7 +2426,7 @@
                 <a:ea typeface="Helvetica Neue"/>
                 <a:cs typeface="Helvetica Neue"/>
               </a:rPr>
-              <a:t>Compiler</a:t>
+              <a:t>Policy</a:t>
             </a:r>
           </a:p>
         </p:txBody>
@@ -2298,7 +2448,7 @@
         <p:spPr>
           <a:xfrm xmlns:a="http://schemas.openxmlformats.org/drawingml/2006/main">
             <a:off x="5943600" y="2228850"/>
-            <a:ext cx="0" cy="4029075"/>
+            <a:ext cx="0" cy="3886200"/>
           </a:xfrm>
           <a:prstGeom xmlns:a="http://schemas.openxmlformats.org/drawingml/2006/main" prst="line">
             <a:avLst/>
@@ -2369,12 +2519,12 @@
             <a:noFill/>
           </a:ln>
         </p:spPr>
-        <p:txBody>
-          <a:bodyPr xmlns:a="http://schemas.openxmlformats.org/drawingml/2006/main">
-            <a:noAutofit/>
-          </a:bodyPr>
-          <a:lstStyle xmlns:a="http://schemas.openxmlformats.org/drawingml/2006/main"/>
-          <a:p xmlns:a="http://schemas.openxmlformats.org/drawingml/2006/main">
+        <p:txBody xmlns:a="http://schemas.openxmlformats.org/drawingml/2006/main">
+          <a:bodyPr wrap="square">
+            <a:noAutofit/>
+          </a:bodyPr>
+          <a:lstStyle/>
+          <a:p>
             <a:pPr>
               <a:buNone/>
               <a:defRPr sz="1875" b="1">
@@ -2395,7 +2545,7 @@
                 <a:ea typeface="Helvetica Neue"/>
                 <a:cs typeface="Helvetica Neue"/>
               </a:rPr>
-              <a:t>Policy</a:t>
+              <a:t>Broker</a:t>
             </a:r>
           </a:p>
         </p:txBody>
@@ -2417,7 +2567,7 @@
         <p:spPr>
           <a:xfrm xmlns:a="http://schemas.openxmlformats.org/drawingml/2006/main">
             <a:off x="7543800" y="2228850"/>
-            <a:ext cx="0" cy="4029075"/>
+            <a:ext cx="0" cy="3886200"/>
           </a:xfrm>
           <a:prstGeom xmlns:a="http://schemas.openxmlformats.org/drawingml/2006/main" prst="line">
             <a:avLst/>
@@ -2488,12 +2638,12 @@
             <a:noFill/>
           </a:ln>
         </p:spPr>
-        <p:txBody>
-          <a:bodyPr xmlns:a="http://schemas.openxmlformats.org/drawingml/2006/main">
-            <a:noAutofit/>
-          </a:bodyPr>
-          <a:lstStyle xmlns:a="http://schemas.openxmlformats.org/drawingml/2006/main"/>
-          <a:p xmlns:a="http://schemas.openxmlformats.org/drawingml/2006/main">
+        <p:txBody xmlns:a="http://schemas.openxmlformats.org/drawingml/2006/main">
+          <a:bodyPr wrap="square">
+            <a:noAutofit/>
+          </a:bodyPr>
+          <a:lstStyle/>
+          <a:p>
             <a:pPr>
               <a:buNone/>
               <a:defRPr sz="1875" b="1">
@@ -2514,7 +2664,7 @@
                 <a:ea typeface="Helvetica Neue"/>
                 <a:cs typeface="Helvetica Neue"/>
               </a:rPr>
-              <a:t>Broker</a:t>
+              <a:t>Browser</a:t>
             </a:r>
           </a:p>
         </p:txBody>
@@ -2536,7 +2686,7 @@
         <p:spPr>
           <a:xfrm xmlns:a="http://schemas.openxmlformats.org/drawingml/2006/main">
             <a:off x="9144000" y="2228850"/>
-            <a:ext cx="0" cy="4029075"/>
+            <a:ext cx="0" cy="3886200"/>
           </a:xfrm>
           <a:prstGeom xmlns:a="http://schemas.openxmlformats.org/drawingml/2006/main" prst="line">
             <a:avLst/>
@@ -2607,12 +2757,12 @@
             <a:noFill/>
           </a:ln>
         </p:spPr>
-        <p:txBody>
-          <a:bodyPr xmlns:a="http://schemas.openxmlformats.org/drawingml/2006/main">
-            <a:noAutofit/>
-          </a:bodyPr>
-          <a:lstStyle xmlns:a="http://schemas.openxmlformats.org/drawingml/2006/main"/>
-          <a:p xmlns:a="http://schemas.openxmlformats.org/drawingml/2006/main">
+        <p:txBody xmlns:a="http://schemas.openxmlformats.org/drawingml/2006/main">
+          <a:bodyPr wrap="square">
+            <a:noAutofit/>
+          </a:bodyPr>
+          <a:lstStyle/>
+          <a:p>
             <a:pPr>
               <a:buNone/>
               <a:defRPr sz="1875" b="1">
@@ -2633,7 +2783,7 @@
                 <a:ea typeface="Helvetica Neue"/>
                 <a:cs typeface="Helvetica Neue"/>
               </a:rPr>
-              <a:t>Service</a:t>
+              <a:t>Provider</a:t>
             </a:r>
           </a:p>
         </p:txBody>
@@ -2655,7 +2805,7 @@
         <p:spPr>
           <a:xfrm xmlns:a="http://schemas.openxmlformats.org/drawingml/2006/main">
             <a:off x="10744200" y="2228850"/>
-            <a:ext cx="0" cy="4029075"/>
+            <a:ext cx="0" cy="3886200"/>
           </a:xfrm>
           <a:prstGeom xmlns:a="http://schemas.openxmlformats.org/drawingml/2006/main" prst="line">
             <a:avLst/>
@@ -2671,73 +2821,96 @@
       </p:sp>
       <p:sp>
         <p:nvSpPr>
-          <p:cNvPr id="24" name="">
-            <a:extLst xmlns:a="http://schemas.openxmlformats.org/drawingml/2006/main">
-              <a:ext uri="{FF2B5EF4-FFF2-40B4-BE49-F238E27FC236}">
-                <a16:creationId xmlns:a16="http://schemas.microsoft.com/office/drawing/2014/main" id="{BA07ECA2-8928-4F90-A3A7-764E050327FE}"/>
-              </a:ext>
-            </a:extLst>
-          </p:cNvPr>
-          <p:cNvSpPr>
-            <a:spLocks xmlns:a="http://schemas.openxmlformats.org/drawingml/2006/main" noGrp="1"/>
-          </p:cNvSpPr>
-          <p:nvPr/>
-        </p:nvSpPr>
-        <p:spPr>
-          <a:xfrm xmlns:a="http://schemas.openxmlformats.org/drawingml/2006/main">
-            <a:off x="1143000" y="2638425"/>
-            <a:ext cx="9525" cy="9525"/>
-          </a:xfrm>
-          <a:prstGeom xmlns:a="http://schemas.openxmlformats.org/drawingml/2006/main" prst="rect">
-            <a:avLst/>
-          </a:prstGeom>
-          <a:noFill xmlns:a="http://schemas.openxmlformats.org/drawingml/2006/main"/>
-          <a:ln xmlns:a="http://schemas.openxmlformats.org/drawingml/2006/main" w="0">
-            <a:noFill/>
-          </a:ln>
-        </p:spPr>
-      </p:sp>
-      <p:sp>
-        <p:nvSpPr>
-          <p:cNvPr id="25" name="">
-            <a:extLst xmlns:a="http://schemas.openxmlformats.org/drawingml/2006/main">
-              <a:ext uri="{FF2B5EF4-FFF2-40B4-BE49-F238E27FC236}">
-                <a16:creationId xmlns:a16="http://schemas.microsoft.com/office/drawing/2014/main" id="{5D5F6CB0-6D26-4234-9883-2B3D9513447C}"/>
-              </a:ext>
-            </a:extLst>
-          </p:cNvPr>
-          <p:cNvSpPr>
-            <a:spLocks xmlns:a="http://schemas.openxmlformats.org/drawingml/2006/main" noGrp="1"/>
-          </p:cNvSpPr>
-          <p:nvPr/>
-        </p:nvSpPr>
-        <p:spPr>
-          <a:xfrm xmlns:a="http://schemas.openxmlformats.org/drawingml/2006/main">
-            <a:off x="2743200" y="2638425"/>
-            <a:ext cx="9525" cy="9525"/>
-          </a:xfrm>
-          <a:prstGeom xmlns:a="http://schemas.openxmlformats.org/drawingml/2006/main" prst="rect">
-            <a:avLst/>
-          </a:prstGeom>
-          <a:noFill xmlns:a="http://schemas.openxmlformats.org/drawingml/2006/main"/>
-          <a:ln xmlns:a="http://schemas.openxmlformats.org/drawingml/2006/main" w="0">
-            <a:noFill/>
-          </a:ln>
-        </p:spPr>
+          <p:cNvPr id="60" name="">
+            <a:extLst xmlns:a="http://schemas.openxmlformats.org/drawingml/2006/main">
+              <a:ext uri="{FF2B5EF4-FFF2-40B4-BE49-F238E27FC236}">
+                <a16:creationId xmlns:a16="http://schemas.microsoft.com/office/drawing/2014/main" id="{6DAA9B5E-0DB9-412B-8A3D-01B8BC37AAF5}"/>
+              </a:ext>
+            </a:extLst>
+          </p:cNvPr>
+          <p:cNvSpPr>
+            <a:spLocks xmlns:a="http://schemas.openxmlformats.org/drawingml/2006/main" noGrp="1"/>
+          </p:cNvSpPr>
+          <p:nvPr/>
+        </p:nvSpPr>
+        <p:spPr>
+          <a:xfrm xmlns:a="http://schemas.openxmlformats.org/drawingml/2006/main">
+            <a:off x="609600" y="6210300"/>
+            <a:ext cx="10972800" cy="571500"/>
+          </a:xfrm>
+          <a:prstGeom xmlns:a="http://schemas.openxmlformats.org/drawingml/2006/main" prst="rect">
+            <a:avLst/>
+          </a:prstGeom>
+          <a:noFill xmlns:a="http://schemas.openxmlformats.org/drawingml/2006/main"/>
+          <a:ln xmlns:a="http://schemas.openxmlformats.org/drawingml/2006/main" w="0">
+            <a:noFill/>
+          </a:ln>
+        </p:spPr>
+        <p:txBody xmlns:a="http://schemas.openxmlformats.org/drawingml/2006/main">
+          <a:bodyPr wrap="square">
+            <a:noAutofit/>
+          </a:bodyPr>
+          <a:lstStyle/>
+          <a:p>
+            <a:pPr>
+              <a:buNone/>
+              <a:defRPr sz="1500" b="0">
+                <a:solidFill>
+                  <a:srgbClr val="53645D"/>
+                </a:solidFill>
+                <a:latin typeface="Helvetica Neue"/>
+                <a:ea typeface="Helvetica Neue"/>
+                <a:cs typeface="Helvetica Neue"/>
+              </a:defRPr>
+            </a:pPr>
+            <a:r>
+              <a:rPr sz="1500" b="0">
+                <a:solidFill>
+                  <a:srgbClr val="53645D"/>
+                </a:solidFill>
+                <a:latin typeface="Helvetica Neue"/>
+                <a:ea typeface="Helvetica Neue"/>
+                <a:cs typeface="Helvetica Neue"/>
+              </a:rPr>
+              <a:t>9a: writes. 9b–10: signing, returned through the compiler and API to the browser.</a:t>
+            </a:r>
+          </a:p>
+          <a:p>
+            <a:pPr>
+              <a:buNone/>
+              <a:defRPr sz="1500" b="0">
+                <a:solidFill>
+                  <a:srgbClr val="53645D"/>
+                </a:solidFill>
+                <a:latin typeface="Helvetica Neue"/>
+                <a:ea typeface="Helvetica Neue"/>
+                <a:cs typeface="Helvetica Neue"/>
+              </a:defRPr>
+            </a:pPr>
+            <a:r>
+              <a:rPr sz="1500" b="0">
+                <a:solidFill>
+                  <a:srgbClr val="53645D"/>
+                </a:solidFill>
+                <a:latin typeface="Helvetica Neue"/>
+                <a:ea typeface="Helvetica Neue"/>
+                <a:cs typeface="Helvetica Neue"/>
+              </a:rPr>
+              <a:t>Live checks repeat before every provider request or signature. Other responses are omitted.</a:t>
+            </a:r>
+          </a:p>
+        </p:txBody>
       </p:sp>
       <p:cxnSp>
         <p:nvCxnSpPr>
-          <p:cNvPr id="376" name=""/>
-          <p:cNvCxnSpPr>
-            <a:stCxn xmlns:a="http://schemas.openxmlformats.org/drawingml/2006/main" id="24" idx="3"/>
-            <a:endCxn xmlns:a="http://schemas.openxmlformats.org/drawingml/2006/main" id="25" idx="1"/>
-          </p:cNvCxnSpPr>
+          <p:cNvPr id="500" name="500"/>
+          <p:cNvCxnSpPr/>
           <p:nvPr/>
         </p:nvCxnSpPr>
         <p:spPr>
           <a:xfrm xmlns:a="http://schemas.openxmlformats.org/drawingml/2006/main">
-            <a:off x="1152525" y="2643188"/>
-            <a:ext cx="1590675" cy="0"/>
+            <a:off x="1143000" y="2571750"/>
+            <a:ext cx="1600200" cy="0"/>
           </a:xfrm>
           <a:prstGeom xmlns:a="http://schemas.openxmlformats.org/drawingml/2006/main" prst="straightConnector1">
             <a:avLst/>
@@ -2752,40 +2925,34 @@
       </p:cxnSp>
       <p:sp>
         <p:nvSpPr>
-          <p:cNvPr id="27" name="">
-            <a:extLst xmlns:a="http://schemas.openxmlformats.org/drawingml/2006/main">
-              <a:ext uri="{FF2B5EF4-FFF2-40B4-BE49-F238E27FC236}">
-                <a16:creationId xmlns:a16="http://schemas.microsoft.com/office/drawing/2014/main" id="{A7D47957-D793-4A29-B26E-BA1956641FE3}"/>
-              </a:ext>
-            </a:extLst>
-          </p:cNvPr>
-          <p:cNvSpPr>
-            <a:spLocks xmlns:a="http://schemas.openxmlformats.org/drawingml/2006/main" noGrp="1"/>
-          </p:cNvSpPr>
-          <p:nvPr/>
-        </p:nvSpPr>
-        <p:spPr>
-          <a:xfrm xmlns:a="http://schemas.openxmlformats.org/drawingml/2006/main">
-            <a:off x="1219200" y="2324100"/>
-            <a:ext cx="1447800" cy="295275"/>
-          </a:xfrm>
-          <a:prstGeom xmlns:a="http://schemas.openxmlformats.org/drawingml/2006/main" prst="rect">
-            <a:avLst/>
-          </a:prstGeom>
-          <a:noFill xmlns:a="http://schemas.openxmlformats.org/drawingml/2006/main"/>
-          <a:ln xmlns:a="http://schemas.openxmlformats.org/drawingml/2006/main" w="0">
-            <a:noFill/>
-          </a:ln>
-        </p:spPr>
-        <p:txBody>
-          <a:bodyPr xmlns:a="http://schemas.openxmlformats.org/drawingml/2006/main">
-            <a:noAutofit/>
-          </a:bodyPr>
-          <a:lstStyle xmlns:a="http://schemas.openxmlformats.org/drawingml/2006/main"/>
-          <a:p xmlns:a="http://schemas.openxmlformats.org/drawingml/2006/main">
-            <a:pPr>
-              <a:buNone/>
-              <a:defRPr sz="1575" b="0">
+          <p:cNvPr id="600" name=""/>
+          <p:cNvSpPr>
+            <a:spLocks xmlns:a="http://schemas.openxmlformats.org/drawingml/2006/main" noGrp="1"/>
+          </p:cNvSpPr>
+          <p:nvPr/>
+        </p:nvSpPr>
+        <p:spPr>
+          <a:xfrm xmlns:a="http://schemas.openxmlformats.org/drawingml/2006/main">
+            <a:off x="1238250" y="2314575"/>
+            <a:ext cx="1466850" cy="247650"/>
+          </a:xfrm>
+          <a:prstGeom xmlns:a="http://schemas.openxmlformats.org/drawingml/2006/main" prst="rect">
+            <a:avLst/>
+          </a:prstGeom>
+          <a:noFill xmlns:a="http://schemas.openxmlformats.org/drawingml/2006/main"/>
+          <a:ln xmlns:a="http://schemas.openxmlformats.org/drawingml/2006/main" w="0">
+            <a:noFill/>
+          </a:ln>
+        </p:spPr>
+        <p:txBody xmlns:a="http://schemas.openxmlformats.org/drawingml/2006/main">
+          <a:bodyPr wrap="square" lIns="0" rIns="0" tIns="0" bIns="0">
+            <a:noAutofit/>
+          </a:bodyPr>
+          <a:lstStyle/>
+          <a:p>
+            <a:pPr>
+              <a:buNone/>
+              <a:defRPr sz="1500" b="0">
                 <a:solidFill>
                   <a:srgbClr val="17302B"/>
                 </a:solidFill>
@@ -2795,7 +2962,7 @@
               </a:defRPr>
             </a:pPr>
             <a:r>
-              <a:rPr sz="1575" b="0">
+              <a:rPr sz="1500" b="0">
                 <a:solidFill>
                   <a:srgbClr val="17302B"/>
                 </a:solidFill>
@@ -2803,80 +2970,21 @@
                 <a:ea typeface="Helvetica Neue"/>
                 <a:cs typeface="Helvetica Neue"/>
               </a:rPr>
-              <a:t>1  Sign in</a:t>
-            </a:r>
-          </a:p>
-        </p:txBody>
-      </p:sp>
-      <p:sp>
-        <p:nvSpPr>
-          <p:cNvPr id="28" name="">
-            <a:extLst xmlns:a="http://schemas.openxmlformats.org/drawingml/2006/main">
-              <a:ext uri="{FF2B5EF4-FFF2-40B4-BE49-F238E27FC236}">
-                <a16:creationId xmlns:a16="http://schemas.microsoft.com/office/drawing/2014/main" id="{A983C511-73B1-4E59-BEC3-41D73506A587}"/>
-              </a:ext>
-            </a:extLst>
-          </p:cNvPr>
-          <p:cNvSpPr>
-            <a:spLocks xmlns:a="http://schemas.openxmlformats.org/drawingml/2006/main" noGrp="1"/>
-          </p:cNvSpPr>
-          <p:nvPr/>
-        </p:nvSpPr>
-        <p:spPr>
-          <a:xfrm xmlns:a="http://schemas.openxmlformats.org/drawingml/2006/main">
-            <a:off x="1143000" y="3057525"/>
-            <a:ext cx="9525" cy="9525"/>
-          </a:xfrm>
-          <a:prstGeom xmlns:a="http://schemas.openxmlformats.org/drawingml/2006/main" prst="rect">
-            <a:avLst/>
-          </a:prstGeom>
-          <a:noFill xmlns:a="http://schemas.openxmlformats.org/drawingml/2006/main"/>
-          <a:ln xmlns:a="http://schemas.openxmlformats.org/drawingml/2006/main" w="0">
-            <a:noFill/>
-          </a:ln>
-        </p:spPr>
-      </p:sp>
-      <p:sp>
-        <p:nvSpPr>
-          <p:cNvPr id="29" name="">
-            <a:extLst xmlns:a="http://schemas.openxmlformats.org/drawingml/2006/main">
-              <a:ext uri="{FF2B5EF4-FFF2-40B4-BE49-F238E27FC236}">
-                <a16:creationId xmlns:a16="http://schemas.microsoft.com/office/drawing/2014/main" id="{47250D8F-0321-48B9-9C87-7CCAF8172A42}"/>
-              </a:ext>
-            </a:extLst>
-          </p:cNvPr>
-          <p:cNvSpPr>
-            <a:spLocks xmlns:a="http://schemas.openxmlformats.org/drawingml/2006/main" noGrp="1"/>
-          </p:cNvSpPr>
-          <p:nvPr/>
-        </p:nvSpPr>
-        <p:spPr>
-          <a:xfrm xmlns:a="http://schemas.openxmlformats.org/drawingml/2006/main">
-            <a:off x="7543800" y="3057525"/>
-            <a:ext cx="9525" cy="9525"/>
-          </a:xfrm>
-          <a:prstGeom xmlns:a="http://schemas.openxmlformats.org/drawingml/2006/main" prst="rect">
-            <a:avLst/>
-          </a:prstGeom>
-          <a:noFill xmlns:a="http://schemas.openxmlformats.org/drawingml/2006/main"/>
-          <a:ln xmlns:a="http://schemas.openxmlformats.org/drawingml/2006/main" w="0">
-            <a:noFill/>
-          </a:ln>
-        </p:spPr>
+              <a:t>1  Run</a:t>
+            </a:r>
+          </a:p>
+        </p:txBody>
       </p:sp>
       <p:cxnSp>
         <p:nvCxnSpPr>
-          <p:cNvPr id="380" name=""/>
-          <p:cNvCxnSpPr>
-            <a:stCxn xmlns:a="http://schemas.openxmlformats.org/drawingml/2006/main" id="28" idx="3"/>
-            <a:endCxn xmlns:a="http://schemas.openxmlformats.org/drawingml/2006/main" id="29" idx="1"/>
-          </p:cNvCxnSpPr>
+          <p:cNvPr id="501" name="501"/>
+          <p:cNvCxnSpPr/>
           <p:nvPr/>
         </p:nvCxnSpPr>
         <p:spPr>
           <a:xfrm xmlns:a="http://schemas.openxmlformats.org/drawingml/2006/main">
-            <a:off x="1152525" y="3062288"/>
-            <a:ext cx="6391275" cy="0"/>
+            <a:off x="2743200" y="2914650"/>
+            <a:ext cx="3200400" cy="0"/>
           </a:xfrm>
           <a:prstGeom xmlns:a="http://schemas.openxmlformats.org/drawingml/2006/main" prst="straightConnector1">
             <a:avLst/>
@@ -2891,40 +2999,34 @@
       </p:cxnSp>
       <p:sp>
         <p:nvSpPr>
-          <p:cNvPr id="31" name="">
-            <a:extLst xmlns:a="http://schemas.openxmlformats.org/drawingml/2006/main">
-              <a:ext uri="{FF2B5EF4-FFF2-40B4-BE49-F238E27FC236}">
-                <a16:creationId xmlns:a16="http://schemas.microsoft.com/office/drawing/2014/main" id="{E2213043-0BF1-4B3B-BA5C-6499C3F189C2}"/>
-              </a:ext>
-            </a:extLst>
-          </p:cNvPr>
-          <p:cNvSpPr>
-            <a:spLocks xmlns:a="http://schemas.openxmlformats.org/drawingml/2006/main" noGrp="1"/>
-          </p:cNvSpPr>
-          <p:nvPr/>
-        </p:nvSpPr>
-        <p:spPr>
-          <a:xfrm xmlns:a="http://schemas.openxmlformats.org/drawingml/2006/main">
-            <a:off x="1219200" y="2743200"/>
-            <a:ext cx="6248400" cy="295275"/>
-          </a:xfrm>
-          <a:prstGeom xmlns:a="http://schemas.openxmlformats.org/drawingml/2006/main" prst="rect">
-            <a:avLst/>
-          </a:prstGeom>
-          <a:noFill xmlns:a="http://schemas.openxmlformats.org/drawingml/2006/main"/>
-          <a:ln xmlns:a="http://schemas.openxmlformats.org/drawingml/2006/main" w="0">
-            <a:noFill/>
-          </a:ln>
-        </p:spPr>
-        <p:txBody>
-          <a:bodyPr xmlns:a="http://schemas.openxmlformats.org/drawingml/2006/main">
-            <a:noAutofit/>
-          </a:bodyPr>
-          <a:lstStyle xmlns:a="http://schemas.openxmlformats.org/drawingml/2006/main"/>
-          <a:p xmlns:a="http://schemas.openxmlformats.org/drawingml/2006/main">
-            <a:pPr>
-              <a:buNone/>
-              <a:defRPr sz="1575" b="0">
+          <p:cNvPr id="601" name=""/>
+          <p:cNvSpPr>
+            <a:spLocks xmlns:a="http://schemas.openxmlformats.org/drawingml/2006/main" noGrp="1"/>
+          </p:cNvSpPr>
+          <p:nvPr/>
+        </p:nvSpPr>
+        <p:spPr>
+          <a:xfrm xmlns:a="http://schemas.openxmlformats.org/drawingml/2006/main">
+            <a:off x="2838450" y="2657475"/>
+            <a:ext cx="3067050" cy="247650"/>
+          </a:xfrm>
+          <a:prstGeom xmlns:a="http://schemas.openxmlformats.org/drawingml/2006/main" prst="rect">
+            <a:avLst/>
+          </a:prstGeom>
+          <a:noFill xmlns:a="http://schemas.openxmlformats.org/drawingml/2006/main"/>
+          <a:ln xmlns:a="http://schemas.openxmlformats.org/drawingml/2006/main" w="0">
+            <a:noFill/>
+          </a:ln>
+        </p:spPr>
+        <p:txBody xmlns:a="http://schemas.openxmlformats.org/drawingml/2006/main">
+          <a:bodyPr wrap="square" lIns="0" rIns="0" tIns="0" bIns="0">
+            <a:noAutofit/>
+          </a:bodyPr>
+          <a:lstStyle/>
+          <a:p>
+            <a:pPr>
+              <a:buNone/>
+              <a:defRPr sz="1500" b="0">
                 <a:solidFill>
                   <a:srgbClr val="17302B"/>
                 </a:solidFill>
@@ -2934,7 +3036,7 @@
               </a:defRPr>
             </a:pPr>
             <a:r>
-              <a:rPr sz="1575" b="0">
+              <a:rPr sz="1500" b="0">
                 <a:solidFill>
                   <a:srgbClr val="17302B"/>
                 </a:solidFill>
@@ -2942,80 +3044,21 @@
                 <a:ea typeface="Helvetica Neue"/>
                 <a:cs typeface="Helvetica Neue"/>
               </a:rPr>
-              <a:t>2  Manage connection and grants</a:t>
-            </a:r>
-          </a:p>
-        </p:txBody>
-      </p:sp>
-      <p:sp>
-        <p:nvSpPr>
-          <p:cNvPr id="32" name="">
-            <a:extLst xmlns:a="http://schemas.openxmlformats.org/drawingml/2006/main">
-              <a:ext uri="{FF2B5EF4-FFF2-40B4-BE49-F238E27FC236}">
-                <a16:creationId xmlns:a16="http://schemas.microsoft.com/office/drawing/2014/main" id="{075584E4-94E1-4426-AAE7-AB41BE509D40}"/>
-              </a:ext>
-            </a:extLst>
-          </p:cNvPr>
-          <p:cNvSpPr>
-            <a:spLocks xmlns:a="http://schemas.openxmlformats.org/drawingml/2006/main" noGrp="1"/>
-          </p:cNvSpPr>
-          <p:nvPr/>
-        </p:nvSpPr>
-        <p:spPr>
-          <a:xfrm xmlns:a="http://schemas.openxmlformats.org/drawingml/2006/main">
-            <a:off x="7543800" y="3476625"/>
-            <a:ext cx="9525" cy="9525"/>
-          </a:xfrm>
-          <a:prstGeom xmlns:a="http://schemas.openxmlformats.org/drawingml/2006/main" prst="rect">
-            <a:avLst/>
-          </a:prstGeom>
-          <a:noFill xmlns:a="http://schemas.openxmlformats.org/drawingml/2006/main"/>
-          <a:ln xmlns:a="http://schemas.openxmlformats.org/drawingml/2006/main" w="0">
-            <a:noFill/>
-          </a:ln>
-        </p:spPr>
-      </p:sp>
-      <p:sp>
-        <p:nvSpPr>
-          <p:cNvPr id="33" name="">
-            <a:extLst xmlns:a="http://schemas.openxmlformats.org/drawingml/2006/main">
-              <a:ext uri="{FF2B5EF4-FFF2-40B4-BE49-F238E27FC236}">
-                <a16:creationId xmlns:a16="http://schemas.microsoft.com/office/drawing/2014/main" id="{665D1A79-0B0F-41F4-8084-A4B6435D166A}"/>
-              </a:ext>
-            </a:extLst>
-          </p:cNvPr>
-          <p:cNvSpPr>
-            <a:spLocks xmlns:a="http://schemas.openxmlformats.org/drawingml/2006/main" noGrp="1"/>
-          </p:cNvSpPr>
-          <p:nvPr/>
-        </p:nvSpPr>
-        <p:spPr>
-          <a:xfrm xmlns:a="http://schemas.openxmlformats.org/drawingml/2006/main">
-            <a:off x="9144000" y="3476625"/>
-            <a:ext cx="9525" cy="9525"/>
-          </a:xfrm>
-          <a:prstGeom xmlns:a="http://schemas.openxmlformats.org/drawingml/2006/main" prst="rect">
-            <a:avLst/>
-          </a:prstGeom>
-          <a:noFill xmlns:a="http://schemas.openxmlformats.org/drawingml/2006/main"/>
-          <a:ln xmlns:a="http://schemas.openxmlformats.org/drawingml/2006/main" w="0">
-            <a:noFill/>
-          </a:ln>
-        </p:spPr>
+              <a:t>2  Allocate invocation</a:t>
+            </a:r>
+          </a:p>
+        </p:txBody>
       </p:sp>
       <p:cxnSp>
         <p:nvCxnSpPr>
-          <p:cNvPr id="384" name=""/>
-          <p:cNvCxnSpPr>
-            <a:stCxn xmlns:a="http://schemas.openxmlformats.org/drawingml/2006/main" id="32" idx="3"/>
-            <a:endCxn xmlns:a="http://schemas.openxmlformats.org/drawingml/2006/main" id="33" idx="1"/>
-          </p:cNvCxnSpPr>
+          <p:cNvPr id="502" name="502"/>
+          <p:cNvCxnSpPr/>
           <p:nvPr/>
         </p:nvCxnSpPr>
         <p:spPr>
           <a:xfrm xmlns:a="http://schemas.openxmlformats.org/drawingml/2006/main">
-            <a:off x="7553325" y="3481388"/>
-            <a:ext cx="1590675" cy="0"/>
+            <a:off x="2743200" y="3257550"/>
+            <a:ext cx="1600200" cy="0"/>
           </a:xfrm>
           <a:prstGeom xmlns:a="http://schemas.openxmlformats.org/drawingml/2006/main" prst="straightConnector1">
             <a:avLst/>
@@ -3030,37 +3073,31 @@
       </p:cxnSp>
       <p:sp>
         <p:nvSpPr>
-          <p:cNvPr id="35" name="">
-            <a:extLst xmlns:a="http://schemas.openxmlformats.org/drawingml/2006/main">
-              <a:ext uri="{FF2B5EF4-FFF2-40B4-BE49-F238E27FC236}">
-                <a16:creationId xmlns:a16="http://schemas.microsoft.com/office/drawing/2014/main" id="{6444128F-B50C-4FA0-ADC2-1078E1E6E08A}"/>
-              </a:ext>
-            </a:extLst>
-          </p:cNvPr>
-          <p:cNvSpPr>
-            <a:spLocks xmlns:a="http://schemas.openxmlformats.org/drawingml/2006/main" noGrp="1"/>
-          </p:cNvSpPr>
-          <p:nvPr/>
-        </p:nvSpPr>
-        <p:spPr>
-          <a:xfrm xmlns:a="http://schemas.openxmlformats.org/drawingml/2006/main">
-            <a:off x="7620000" y="3162300"/>
-            <a:ext cx="1447800" cy="295275"/>
-          </a:xfrm>
-          <a:prstGeom xmlns:a="http://schemas.openxmlformats.org/drawingml/2006/main" prst="rect">
-            <a:avLst/>
-          </a:prstGeom>
-          <a:noFill xmlns:a="http://schemas.openxmlformats.org/drawingml/2006/main"/>
-          <a:ln xmlns:a="http://schemas.openxmlformats.org/drawingml/2006/main" w="0">
-            <a:noFill/>
-          </a:ln>
-        </p:spPr>
-        <p:txBody>
-          <a:bodyPr xmlns:a="http://schemas.openxmlformats.org/drawingml/2006/main">
-            <a:noAutofit/>
-          </a:bodyPr>
-          <a:lstStyle xmlns:a="http://schemas.openxmlformats.org/drawingml/2006/main"/>
-          <a:p xmlns:a="http://schemas.openxmlformats.org/drawingml/2006/main">
+          <p:cNvPr id="602" name=""/>
+          <p:cNvSpPr>
+            <a:spLocks xmlns:a="http://schemas.openxmlformats.org/drawingml/2006/main" noGrp="1"/>
+          </p:cNvSpPr>
+          <p:nvPr/>
+        </p:nvSpPr>
+        <p:spPr>
+          <a:xfrm xmlns:a="http://schemas.openxmlformats.org/drawingml/2006/main">
+            <a:off x="2838450" y="3000375"/>
+            <a:ext cx="1466850" cy="247650"/>
+          </a:xfrm>
+          <a:prstGeom xmlns:a="http://schemas.openxmlformats.org/drawingml/2006/main" prst="rect">
+            <a:avLst/>
+          </a:prstGeom>
+          <a:noFill xmlns:a="http://schemas.openxmlformats.org/drawingml/2006/main"/>
+          <a:ln xmlns:a="http://schemas.openxmlformats.org/drawingml/2006/main" w="0">
+            <a:noFill/>
+          </a:ln>
+        </p:spPr>
+        <p:txBody xmlns:a="http://schemas.openxmlformats.org/drawingml/2006/main">
+          <a:bodyPr wrap="square" lIns="0" rIns="0" tIns="0" bIns="0">
+            <a:noAutofit/>
+          </a:bodyPr>
+          <a:lstStyle/>
+          <a:p>
             <a:pPr>
               <a:buNone/>
               <a:defRPr sz="1500" b="0">
@@ -3081,80 +3118,21 @@
                 <a:ea typeface="Helvetica Neue"/>
                 <a:cs typeface="Helvetica Neue"/>
               </a:rPr>
-              <a:t>3  Store secret</a:t>
-            </a:r>
-          </a:p>
-        </p:txBody>
-      </p:sp>
-      <p:sp>
-        <p:nvSpPr>
-          <p:cNvPr id="36" name="">
-            <a:extLst xmlns:a="http://schemas.openxmlformats.org/drawingml/2006/main">
-              <a:ext uri="{FF2B5EF4-FFF2-40B4-BE49-F238E27FC236}">
-                <a16:creationId xmlns:a16="http://schemas.microsoft.com/office/drawing/2014/main" id="{BF32BD2E-B4AB-4D72-A7C1-236FBF257CF1}"/>
-              </a:ext>
-            </a:extLst>
-          </p:cNvPr>
-          <p:cNvSpPr>
-            <a:spLocks xmlns:a="http://schemas.openxmlformats.org/drawingml/2006/main" noGrp="1"/>
-          </p:cNvSpPr>
-          <p:nvPr/>
-        </p:nvSpPr>
-        <p:spPr>
-          <a:xfrm xmlns:a="http://schemas.openxmlformats.org/drawingml/2006/main">
-            <a:off x="1143000" y="3895725"/>
-            <a:ext cx="9525" cy="9525"/>
-          </a:xfrm>
-          <a:prstGeom xmlns:a="http://schemas.openxmlformats.org/drawingml/2006/main" prst="rect">
-            <a:avLst/>
-          </a:prstGeom>
-          <a:noFill xmlns:a="http://schemas.openxmlformats.org/drawingml/2006/main"/>
-          <a:ln xmlns:a="http://schemas.openxmlformats.org/drawingml/2006/main" w="0">
-            <a:noFill/>
-          </a:ln>
-        </p:spPr>
-      </p:sp>
-      <p:sp>
-        <p:nvSpPr>
-          <p:cNvPr id="37" name="">
-            <a:extLst xmlns:a="http://schemas.openxmlformats.org/drawingml/2006/main">
-              <a:ext uri="{FF2B5EF4-FFF2-40B4-BE49-F238E27FC236}">
-                <a16:creationId xmlns:a16="http://schemas.microsoft.com/office/drawing/2014/main" id="{DC0D3AC4-ABCA-46FB-8D5F-9867E1CF3583}"/>
-              </a:ext>
-            </a:extLst>
-          </p:cNvPr>
-          <p:cNvSpPr>
-            <a:spLocks xmlns:a="http://schemas.openxmlformats.org/drawingml/2006/main" noGrp="1"/>
-          </p:cNvSpPr>
-          <p:nvPr/>
-        </p:nvSpPr>
-        <p:spPr>
-          <a:xfrm xmlns:a="http://schemas.openxmlformats.org/drawingml/2006/main">
-            <a:off x="4343400" y="3895725"/>
-            <a:ext cx="9525" cy="9525"/>
-          </a:xfrm>
-          <a:prstGeom xmlns:a="http://schemas.openxmlformats.org/drawingml/2006/main" prst="rect">
-            <a:avLst/>
-          </a:prstGeom>
-          <a:noFill xmlns:a="http://schemas.openxmlformats.org/drawingml/2006/main"/>
-          <a:ln xmlns:a="http://schemas.openxmlformats.org/drawingml/2006/main" w="0">
-            <a:noFill/>
-          </a:ln>
-        </p:spPr>
+              <a:t>3  Preflight</a:t>
+            </a:r>
+          </a:p>
+        </p:txBody>
       </p:sp>
       <p:cxnSp>
         <p:nvCxnSpPr>
-          <p:cNvPr id="388" name=""/>
-          <p:cNvCxnSpPr>
-            <a:stCxn xmlns:a="http://schemas.openxmlformats.org/drawingml/2006/main" id="36" idx="3"/>
-            <a:endCxn xmlns:a="http://schemas.openxmlformats.org/drawingml/2006/main" id="37" idx="1"/>
-          </p:cNvCxnSpPr>
+          <p:cNvPr id="503" name="503"/>
+          <p:cNvCxnSpPr/>
           <p:nvPr/>
         </p:nvCxnSpPr>
         <p:spPr>
           <a:xfrm xmlns:a="http://schemas.openxmlformats.org/drawingml/2006/main">
-            <a:off x="1152525" y="3900488"/>
-            <a:ext cx="3190875" cy="0"/>
+            <a:off x="2743200" y="3600450"/>
+            <a:ext cx="3200400" cy="0"/>
           </a:xfrm>
           <a:prstGeom xmlns:a="http://schemas.openxmlformats.org/drawingml/2006/main" prst="straightConnector1">
             <a:avLst/>
@@ -3169,40 +3147,34 @@
       </p:cxnSp>
       <p:sp>
         <p:nvSpPr>
-          <p:cNvPr id="39" name="">
-            <a:extLst xmlns:a="http://schemas.openxmlformats.org/drawingml/2006/main">
-              <a:ext uri="{FF2B5EF4-FFF2-40B4-BE49-F238E27FC236}">
-                <a16:creationId xmlns:a16="http://schemas.microsoft.com/office/drawing/2014/main" id="{F9788A57-018E-411A-885B-B3928700E799}"/>
-              </a:ext>
-            </a:extLst>
-          </p:cNvPr>
-          <p:cNvSpPr>
-            <a:spLocks xmlns:a="http://schemas.openxmlformats.org/drawingml/2006/main" noGrp="1"/>
-          </p:cNvSpPr>
-          <p:nvPr/>
-        </p:nvSpPr>
-        <p:spPr>
-          <a:xfrm xmlns:a="http://schemas.openxmlformats.org/drawingml/2006/main">
-            <a:off x="1219200" y="3581400"/>
-            <a:ext cx="3048000" cy="295275"/>
-          </a:xfrm>
-          <a:prstGeom xmlns:a="http://schemas.openxmlformats.org/drawingml/2006/main" prst="rect">
-            <a:avLst/>
-          </a:prstGeom>
-          <a:noFill xmlns:a="http://schemas.openxmlformats.org/drawingml/2006/main"/>
-          <a:ln xmlns:a="http://schemas.openxmlformats.org/drawingml/2006/main" w="0">
-            <a:noFill/>
-          </a:ln>
-        </p:spPr>
-        <p:txBody>
-          <a:bodyPr xmlns:a="http://schemas.openxmlformats.org/drawingml/2006/main">
-            <a:noAutofit/>
-          </a:bodyPr>
-          <a:lstStyle xmlns:a="http://schemas.openxmlformats.org/drawingml/2006/main"/>
-          <a:p xmlns:a="http://schemas.openxmlformats.org/drawingml/2006/main">
-            <a:pPr>
-              <a:buNone/>
-              <a:defRPr sz="1575" b="0">
+          <p:cNvPr id="603" name=""/>
+          <p:cNvSpPr>
+            <a:spLocks xmlns:a="http://schemas.openxmlformats.org/drawingml/2006/main" noGrp="1"/>
+          </p:cNvSpPr>
+          <p:nvPr/>
+        </p:nvSpPr>
+        <p:spPr>
+          <a:xfrm xmlns:a="http://schemas.openxmlformats.org/drawingml/2006/main">
+            <a:off x="2838450" y="3343275"/>
+            <a:ext cx="3067050" cy="247650"/>
+          </a:xfrm>
+          <a:prstGeom xmlns:a="http://schemas.openxmlformats.org/drawingml/2006/main" prst="rect">
+            <a:avLst/>
+          </a:prstGeom>
+          <a:noFill xmlns:a="http://schemas.openxmlformats.org/drawingml/2006/main"/>
+          <a:ln xmlns:a="http://schemas.openxmlformats.org/drawingml/2006/main" w="0">
+            <a:noFill/>
+          </a:ln>
+        </p:spPr>
+        <p:txBody xmlns:a="http://schemas.openxmlformats.org/drawingml/2006/main">
+          <a:bodyPr wrap="square" lIns="0" rIns="0" tIns="0" bIns="0">
+            <a:noAutofit/>
+          </a:bodyPr>
+          <a:lstStyle/>
+          <a:p>
+            <a:pPr>
+              <a:buNone/>
+              <a:defRPr sz="1500" b="0">
                 <a:solidFill>
                   <a:srgbClr val="17302B"/>
                 </a:solidFill>
@@ -3212,7 +3184,7 @@
               </a:defRPr>
             </a:pPr>
             <a:r>
-              <a:rPr sz="1575" b="0">
+              <a:rPr sz="1500" b="0">
                 <a:solidFill>
                   <a:srgbClr val="17302B"/>
                 </a:solidFill>
@@ -3220,80 +3192,21 @@
                 <a:ea typeface="Helvetica Neue"/>
                 <a:cs typeface="Helvetica Neue"/>
               </a:rPr>
-              <a:t>4  Run with connection</a:t>
-            </a:r>
-          </a:p>
-        </p:txBody>
-      </p:sp>
-      <p:sp>
-        <p:nvSpPr>
-          <p:cNvPr id="40" name="">
-            <a:extLst xmlns:a="http://schemas.openxmlformats.org/drawingml/2006/main">
-              <a:ext uri="{FF2B5EF4-FFF2-40B4-BE49-F238E27FC236}">
-                <a16:creationId xmlns:a16="http://schemas.microsoft.com/office/drawing/2014/main" id="{EA253ED9-5329-47AE-9CBA-DD7B4900ED62}"/>
-              </a:ext>
-            </a:extLst>
-          </p:cNvPr>
-          <p:cNvSpPr>
-            <a:spLocks xmlns:a="http://schemas.openxmlformats.org/drawingml/2006/main" noGrp="1"/>
-          </p:cNvSpPr>
-          <p:nvPr/>
-        </p:nvSpPr>
-        <p:spPr>
-          <a:xfrm xmlns:a="http://schemas.openxmlformats.org/drawingml/2006/main">
-            <a:off x="4343400" y="4314825"/>
-            <a:ext cx="9525" cy="9525"/>
-          </a:xfrm>
-          <a:prstGeom xmlns:a="http://schemas.openxmlformats.org/drawingml/2006/main" prst="rect">
-            <a:avLst/>
-          </a:prstGeom>
-          <a:noFill xmlns:a="http://schemas.openxmlformats.org/drawingml/2006/main"/>
-          <a:ln xmlns:a="http://schemas.openxmlformats.org/drawingml/2006/main" w="0">
-            <a:noFill/>
-          </a:ln>
-        </p:spPr>
-      </p:sp>
-      <p:sp>
-        <p:nvSpPr>
-          <p:cNvPr id="41" name="">
-            <a:extLst xmlns:a="http://schemas.openxmlformats.org/drawingml/2006/main">
-              <a:ext uri="{FF2B5EF4-FFF2-40B4-BE49-F238E27FC236}">
-                <a16:creationId xmlns:a16="http://schemas.microsoft.com/office/drawing/2014/main" id="{CCC65F60-6EFF-4261-9440-8C52FE58FD56}"/>
-              </a:ext>
-            </a:extLst>
-          </p:cNvPr>
-          <p:cNvSpPr>
-            <a:spLocks xmlns:a="http://schemas.openxmlformats.org/drawingml/2006/main" noGrp="1"/>
-          </p:cNvSpPr>
-          <p:nvPr/>
-        </p:nvSpPr>
-        <p:spPr>
-          <a:xfrm xmlns:a="http://schemas.openxmlformats.org/drawingml/2006/main">
-            <a:off x="7543800" y="4314825"/>
-            <a:ext cx="9525" cy="9525"/>
-          </a:xfrm>
-          <a:prstGeom xmlns:a="http://schemas.openxmlformats.org/drawingml/2006/main" prst="rect">
-            <a:avLst/>
-          </a:prstGeom>
-          <a:noFill xmlns:a="http://schemas.openxmlformats.org/drawingml/2006/main"/>
-          <a:ln xmlns:a="http://schemas.openxmlformats.org/drawingml/2006/main" w="0">
-            <a:noFill/>
-          </a:ln>
-        </p:spPr>
+              <a:t>4  Admit full chain</a:t>
+            </a:r>
+          </a:p>
+        </p:txBody>
       </p:sp>
       <p:cxnSp>
         <p:nvCxnSpPr>
-          <p:cNvPr id="392" name=""/>
-          <p:cNvCxnSpPr>
-            <a:stCxn xmlns:a="http://schemas.openxmlformats.org/drawingml/2006/main" id="40" idx="3"/>
-            <a:endCxn xmlns:a="http://schemas.openxmlformats.org/drawingml/2006/main" id="41" idx="1"/>
-          </p:cNvCxnSpPr>
+          <p:cNvPr id="504" name="504"/>
+          <p:cNvCxnSpPr/>
           <p:nvPr/>
         </p:nvCxnSpPr>
         <p:spPr>
           <a:xfrm xmlns:a="http://schemas.openxmlformats.org/drawingml/2006/main">
-            <a:off x="4352925" y="4319588"/>
-            <a:ext cx="3190875" cy="0"/>
+            <a:off x="2743200" y="3943350"/>
+            <a:ext cx="1600200" cy="0"/>
           </a:xfrm>
           <a:prstGeom xmlns:a="http://schemas.openxmlformats.org/drawingml/2006/main" prst="straightConnector1">
             <a:avLst/>
@@ -3308,40 +3221,34 @@
       </p:cxnSp>
       <p:sp>
         <p:nvSpPr>
-          <p:cNvPr id="43" name="">
-            <a:extLst xmlns:a="http://schemas.openxmlformats.org/drawingml/2006/main">
-              <a:ext uri="{FF2B5EF4-FFF2-40B4-BE49-F238E27FC236}">
-                <a16:creationId xmlns:a16="http://schemas.microsoft.com/office/drawing/2014/main" id="{B87A2F3D-FD7D-4C72-B5B4-AC68B51A9B93}"/>
-              </a:ext>
-            </a:extLst>
-          </p:cNvPr>
-          <p:cNvSpPr>
-            <a:spLocks xmlns:a="http://schemas.openxmlformats.org/drawingml/2006/main" noGrp="1"/>
-          </p:cNvSpPr>
-          <p:nvPr/>
-        </p:nvSpPr>
-        <p:spPr>
-          <a:xfrm xmlns:a="http://schemas.openxmlformats.org/drawingml/2006/main">
-            <a:off x="4419600" y="4000500"/>
-            <a:ext cx="3048000" cy="295275"/>
-          </a:xfrm>
-          <a:prstGeom xmlns:a="http://schemas.openxmlformats.org/drawingml/2006/main" prst="rect">
-            <a:avLst/>
-          </a:prstGeom>
-          <a:noFill xmlns:a="http://schemas.openxmlformats.org/drawingml/2006/main"/>
-          <a:ln xmlns:a="http://schemas.openxmlformats.org/drawingml/2006/main" w="0">
-            <a:noFill/>
-          </a:ln>
-        </p:spPr>
-        <p:txBody>
-          <a:bodyPr xmlns:a="http://schemas.openxmlformats.org/drawingml/2006/main">
-            <a:noAutofit/>
-          </a:bodyPr>
-          <a:lstStyle xmlns:a="http://schemas.openxmlformats.org/drawingml/2006/main"/>
-          <a:p xmlns:a="http://schemas.openxmlformats.org/drawingml/2006/main">
-            <a:pPr>
-              <a:buNone/>
-              <a:defRPr sz="1575" b="0">
+          <p:cNvPr id="604" name=""/>
+          <p:cNvSpPr>
+            <a:spLocks xmlns:a="http://schemas.openxmlformats.org/drawingml/2006/main" noGrp="1"/>
+          </p:cNvSpPr>
+          <p:nvPr/>
+        </p:nvSpPr>
+        <p:spPr>
+          <a:xfrm xmlns:a="http://schemas.openxmlformats.org/drawingml/2006/main">
+            <a:off x="2838450" y="3686175"/>
+            <a:ext cx="1466850" cy="247650"/>
+          </a:xfrm>
+          <a:prstGeom xmlns:a="http://schemas.openxmlformats.org/drawingml/2006/main" prst="rect">
+            <a:avLst/>
+          </a:prstGeom>
+          <a:noFill xmlns:a="http://schemas.openxmlformats.org/drawingml/2006/main"/>
+          <a:ln xmlns:a="http://schemas.openxmlformats.org/drawingml/2006/main" w="0">
+            <a:noFill/>
+          </a:ln>
+        </p:spPr>
+        <p:txBody xmlns:a="http://schemas.openxmlformats.org/drawingml/2006/main">
+          <a:bodyPr wrap="square" lIns="0" rIns="0" tIns="0" bIns="0">
+            <a:noAutofit/>
+          </a:bodyPr>
+          <a:lstStyle/>
+          <a:p>
+            <a:pPr>
+              <a:buNone/>
+              <a:defRPr sz="1500" b="0">
                 <a:solidFill>
                   <a:srgbClr val="17302B"/>
                 </a:solidFill>
@@ -3351,7 +3258,7 @@
               </a:defRPr>
             </a:pPr>
             <a:r>
-              <a:rPr sz="1575" b="0">
+              <a:rPr sz="1500" b="0">
                 <a:solidFill>
                   <a:srgbClr val="17302B"/>
                 </a:solidFill>
@@ -3359,80 +3266,21 @@
                 <a:ea typeface="Helvetica Neue"/>
                 <a:cs typeface="Helvetica Neue"/>
               </a:rPr>
-              <a:t>5  Create authorized run</a:t>
-            </a:r>
-          </a:p>
-        </p:txBody>
-      </p:sp>
-      <p:sp>
-        <p:nvSpPr>
-          <p:cNvPr id="44" name="">
-            <a:extLst xmlns:a="http://schemas.openxmlformats.org/drawingml/2006/main">
-              <a:ext uri="{FF2B5EF4-FFF2-40B4-BE49-F238E27FC236}">
-                <a16:creationId xmlns:a16="http://schemas.microsoft.com/office/drawing/2014/main" id="{37A5F90F-DC31-477D-947A-EBCA39637121}"/>
-              </a:ext>
-            </a:extLst>
-          </p:cNvPr>
-          <p:cNvSpPr>
-            <a:spLocks xmlns:a="http://schemas.openxmlformats.org/drawingml/2006/main" noGrp="1"/>
-          </p:cNvSpPr>
-          <p:nvPr/>
-        </p:nvSpPr>
-        <p:spPr>
-          <a:xfrm xmlns:a="http://schemas.openxmlformats.org/drawingml/2006/main">
-            <a:off x="4343400" y="4733925"/>
-            <a:ext cx="9525" cy="9525"/>
-          </a:xfrm>
-          <a:prstGeom xmlns:a="http://schemas.openxmlformats.org/drawingml/2006/main" prst="rect">
-            <a:avLst/>
-          </a:prstGeom>
-          <a:noFill xmlns:a="http://schemas.openxmlformats.org/drawingml/2006/main"/>
-          <a:ln xmlns:a="http://schemas.openxmlformats.org/drawingml/2006/main" w="0">
-            <a:noFill/>
-          </a:ln>
-        </p:spPr>
-      </p:sp>
-      <p:sp>
-        <p:nvSpPr>
-          <p:cNvPr id="45" name="">
-            <a:extLst xmlns:a="http://schemas.openxmlformats.org/drawingml/2006/main">
-              <a:ext uri="{FF2B5EF4-FFF2-40B4-BE49-F238E27FC236}">
-                <a16:creationId xmlns:a16="http://schemas.microsoft.com/office/drawing/2014/main" id="{394F15E2-98DA-4280-A3EB-1FC2B40AC59A}"/>
-              </a:ext>
-            </a:extLst>
-          </p:cNvPr>
-          <p:cNvSpPr>
-            <a:spLocks xmlns:a="http://schemas.openxmlformats.org/drawingml/2006/main" noGrp="1"/>
-          </p:cNvSpPr>
-          <p:nvPr/>
-        </p:nvSpPr>
-        <p:spPr>
-          <a:xfrm xmlns:a="http://schemas.openxmlformats.org/drawingml/2006/main">
-            <a:off x="5943600" y="4733925"/>
-            <a:ext cx="9525" cy="9525"/>
-          </a:xfrm>
-          <a:prstGeom xmlns:a="http://schemas.openxmlformats.org/drawingml/2006/main" prst="rect">
-            <a:avLst/>
-          </a:prstGeom>
-          <a:noFill xmlns:a="http://schemas.openxmlformats.org/drawingml/2006/main"/>
-          <a:ln xmlns:a="http://schemas.openxmlformats.org/drawingml/2006/main" w="0">
-            <a:noFill/>
-          </a:ln>
-        </p:spPr>
+              <a:t>5  Run stages</a:t>
+            </a:r>
+          </a:p>
+        </p:txBody>
       </p:sp>
       <p:cxnSp>
         <p:nvCxnSpPr>
-          <p:cNvPr id="396" name=""/>
-          <p:cNvCxnSpPr>
-            <a:stCxn xmlns:a="http://schemas.openxmlformats.org/drawingml/2006/main" id="44" idx="3"/>
-            <a:endCxn xmlns:a="http://schemas.openxmlformats.org/drawingml/2006/main" id="45" idx="1"/>
-          </p:cNvCxnSpPr>
+          <p:cNvPr id="505" name="505"/>
+          <p:cNvCxnSpPr/>
           <p:nvPr/>
         </p:nvCxnSpPr>
         <p:spPr>
           <a:xfrm xmlns:a="http://schemas.openxmlformats.org/drawingml/2006/main">
-            <a:off x="4352925" y="4738688"/>
-            <a:ext cx="1590675" cy="0"/>
+            <a:off x="4343400" y="4286250"/>
+            <a:ext cx="1600200" cy="0"/>
           </a:xfrm>
           <a:prstGeom xmlns:a="http://schemas.openxmlformats.org/drawingml/2006/main" prst="straightConnector1">
             <a:avLst/>
@@ -3447,40 +3295,34 @@
       </p:cxnSp>
       <p:sp>
         <p:nvSpPr>
-          <p:cNvPr id="47" name="">
-            <a:extLst xmlns:a="http://schemas.openxmlformats.org/drawingml/2006/main">
-              <a:ext uri="{FF2B5EF4-FFF2-40B4-BE49-F238E27FC236}">
-                <a16:creationId xmlns:a16="http://schemas.microsoft.com/office/drawing/2014/main" id="{25606DE2-9848-4620-A5E0-88F21CC51D3F}"/>
-              </a:ext>
-            </a:extLst>
-          </p:cNvPr>
-          <p:cNvSpPr>
-            <a:spLocks xmlns:a="http://schemas.openxmlformats.org/drawingml/2006/main" noGrp="1"/>
-          </p:cNvSpPr>
-          <p:nvPr/>
-        </p:nvSpPr>
-        <p:spPr>
-          <a:xfrm xmlns:a="http://schemas.openxmlformats.org/drawingml/2006/main">
-            <a:off x="4419600" y="4419600"/>
-            <a:ext cx="1447800" cy="295275"/>
-          </a:xfrm>
-          <a:prstGeom xmlns:a="http://schemas.openxmlformats.org/drawingml/2006/main" prst="rect">
-            <a:avLst/>
-          </a:prstGeom>
-          <a:noFill xmlns:a="http://schemas.openxmlformats.org/drawingml/2006/main"/>
-          <a:ln xmlns:a="http://schemas.openxmlformats.org/drawingml/2006/main" w="0">
-            <a:noFill/>
-          </a:ln>
-        </p:spPr>
-        <p:txBody>
-          <a:bodyPr xmlns:a="http://schemas.openxmlformats.org/drawingml/2006/main">
-            <a:noAutofit/>
-          </a:bodyPr>
-          <a:lstStyle xmlns:a="http://schemas.openxmlformats.org/drawingml/2006/main"/>
-          <a:p xmlns:a="http://schemas.openxmlformats.org/drawingml/2006/main">
-            <a:pPr>
-              <a:buNone/>
-              <a:defRPr sz="1575" b="0">
+          <p:cNvPr id="605" name=""/>
+          <p:cNvSpPr>
+            <a:spLocks xmlns:a="http://schemas.openxmlformats.org/drawingml/2006/main" noGrp="1"/>
+          </p:cNvSpPr>
+          <p:nvPr/>
+        </p:nvSpPr>
+        <p:spPr>
+          <a:xfrm xmlns:a="http://schemas.openxmlformats.org/drawingml/2006/main">
+            <a:off x="4438650" y="4029075"/>
+            <a:ext cx="1466850" cy="247650"/>
+          </a:xfrm>
+          <a:prstGeom xmlns:a="http://schemas.openxmlformats.org/drawingml/2006/main" prst="rect">
+            <a:avLst/>
+          </a:prstGeom>
+          <a:noFill xmlns:a="http://schemas.openxmlformats.org/drawingml/2006/main"/>
+          <a:ln xmlns:a="http://schemas.openxmlformats.org/drawingml/2006/main" w="0">
+            <a:noFill/>
+          </a:ln>
+        </p:spPr>
+        <p:txBody xmlns:a="http://schemas.openxmlformats.org/drawingml/2006/main">
+          <a:bodyPr wrap="square" lIns="0" rIns="0" tIns="0" bIns="0">
+            <a:noAutofit/>
+          </a:bodyPr>
+          <a:lstStyle/>
+          <a:p>
+            <a:pPr>
+              <a:buNone/>
+              <a:defRPr sz="1500" b="0">
                 <a:solidFill>
                   <a:srgbClr val="17302B"/>
                 </a:solidFill>
@@ -3490,7 +3332,7 @@
               </a:defRPr>
             </a:pPr>
             <a:r>
-              <a:rPr sz="1575" b="0">
+              <a:rPr sz="1500" b="0">
                 <a:solidFill>
                   <a:srgbClr val="17302B"/>
                 </a:solidFill>
@@ -3498,80 +3340,21 @@
                 <a:ea typeface="Helvetica Neue"/>
                 <a:cs typeface="Helvetica Neue"/>
               </a:rPr>
-              <a:t>6  Compile</a:t>
-            </a:r>
-          </a:p>
-        </p:txBody>
-      </p:sp>
-      <p:sp>
-        <p:nvSpPr>
-          <p:cNvPr id="48" name="">
-            <a:extLst xmlns:a="http://schemas.openxmlformats.org/drawingml/2006/main">
-              <a:ext uri="{FF2B5EF4-FFF2-40B4-BE49-F238E27FC236}">
-                <a16:creationId xmlns:a16="http://schemas.microsoft.com/office/drawing/2014/main" id="{C21D3939-A232-4E35-BF7F-C349EAE7AB03}"/>
-              </a:ext>
-            </a:extLst>
-          </p:cNvPr>
-          <p:cNvSpPr>
-            <a:spLocks xmlns:a="http://schemas.openxmlformats.org/drawingml/2006/main" noGrp="1"/>
-          </p:cNvSpPr>
-          <p:nvPr/>
-        </p:nvSpPr>
-        <p:spPr>
-          <a:xfrm xmlns:a="http://schemas.openxmlformats.org/drawingml/2006/main">
-            <a:off x="5943600" y="5153025"/>
-            <a:ext cx="9525" cy="9525"/>
-          </a:xfrm>
-          <a:prstGeom xmlns:a="http://schemas.openxmlformats.org/drawingml/2006/main" prst="rect">
-            <a:avLst/>
-          </a:prstGeom>
-          <a:noFill xmlns:a="http://schemas.openxmlformats.org/drawingml/2006/main"/>
-          <a:ln xmlns:a="http://schemas.openxmlformats.org/drawingml/2006/main" w="0">
-            <a:noFill/>
-          </a:ln>
-        </p:spPr>
-      </p:sp>
-      <p:sp>
-        <p:nvSpPr>
-          <p:cNvPr id="49" name="">
-            <a:extLst xmlns:a="http://schemas.openxmlformats.org/drawingml/2006/main">
-              <a:ext uri="{FF2B5EF4-FFF2-40B4-BE49-F238E27FC236}">
-                <a16:creationId xmlns:a16="http://schemas.microsoft.com/office/drawing/2014/main" id="{56C0752D-4FC0-452C-9386-43C72DAE80FC}"/>
-              </a:ext>
-            </a:extLst>
-          </p:cNvPr>
-          <p:cNvSpPr>
-            <a:spLocks xmlns:a="http://schemas.openxmlformats.org/drawingml/2006/main" noGrp="1"/>
-          </p:cNvSpPr>
-          <p:nvPr/>
-        </p:nvSpPr>
-        <p:spPr>
-          <a:xfrm xmlns:a="http://schemas.openxmlformats.org/drawingml/2006/main">
-            <a:off x="7543800" y="5153025"/>
-            <a:ext cx="9525" cy="9525"/>
-          </a:xfrm>
-          <a:prstGeom xmlns:a="http://schemas.openxmlformats.org/drawingml/2006/main" prst="rect">
-            <a:avLst/>
-          </a:prstGeom>
-          <a:noFill xmlns:a="http://schemas.openxmlformats.org/drawingml/2006/main"/>
-          <a:ln xmlns:a="http://schemas.openxmlformats.org/drawingml/2006/main" w="0">
-            <a:noFill/>
-          </a:ln>
-        </p:spPr>
+              <a:t>6  Mint token</a:t>
+            </a:r>
+          </a:p>
+        </p:txBody>
       </p:sp>
       <p:cxnSp>
         <p:nvCxnSpPr>
-          <p:cNvPr id="400" name=""/>
-          <p:cNvCxnSpPr>
-            <a:stCxn xmlns:a="http://schemas.openxmlformats.org/drawingml/2006/main" id="48" idx="3"/>
-            <a:endCxn xmlns:a="http://schemas.openxmlformats.org/drawingml/2006/main" id="49" idx="1"/>
-          </p:cNvCxnSpPr>
+          <p:cNvPr id="506" name="506"/>
+          <p:cNvCxnSpPr/>
           <p:nvPr/>
         </p:nvCxnSpPr>
         <p:spPr>
           <a:xfrm xmlns:a="http://schemas.openxmlformats.org/drawingml/2006/main">
-            <a:off x="5953125" y="5157788"/>
-            <a:ext cx="1590675" cy="0"/>
+            <a:off x="4343400" y="4629150"/>
+            <a:ext cx="3200400" cy="0"/>
           </a:xfrm>
           <a:prstGeom xmlns:a="http://schemas.openxmlformats.org/drawingml/2006/main" prst="straightConnector1">
             <a:avLst/>
@@ -3586,37 +3369,31 @@
       </p:cxnSp>
       <p:sp>
         <p:nvSpPr>
-          <p:cNvPr id="51" name="">
-            <a:extLst xmlns:a="http://schemas.openxmlformats.org/drawingml/2006/main">
-              <a:ext uri="{FF2B5EF4-FFF2-40B4-BE49-F238E27FC236}">
-                <a16:creationId xmlns:a16="http://schemas.microsoft.com/office/drawing/2014/main" id="{6E2AF650-9881-4E7D-A5A9-E8CD1E0ABA29}"/>
-              </a:ext>
-            </a:extLst>
-          </p:cNvPr>
-          <p:cNvSpPr>
-            <a:spLocks xmlns:a="http://schemas.openxmlformats.org/drawingml/2006/main" noGrp="1"/>
-          </p:cNvSpPr>
-          <p:nvPr/>
-        </p:nvSpPr>
-        <p:spPr>
-          <a:xfrm xmlns:a="http://schemas.openxmlformats.org/drawingml/2006/main">
-            <a:off x="6019800" y="4838700"/>
-            <a:ext cx="1447800" cy="295275"/>
-          </a:xfrm>
-          <a:prstGeom xmlns:a="http://schemas.openxmlformats.org/drawingml/2006/main" prst="rect">
-            <a:avLst/>
-          </a:prstGeom>
-          <a:noFill xmlns:a="http://schemas.openxmlformats.org/drawingml/2006/main"/>
-          <a:ln xmlns:a="http://schemas.openxmlformats.org/drawingml/2006/main" w="0">
-            <a:noFill/>
-          </a:ln>
-        </p:spPr>
-        <p:txBody>
-          <a:bodyPr xmlns:a="http://schemas.openxmlformats.org/drawingml/2006/main">
-            <a:noAutofit/>
-          </a:bodyPr>
-          <a:lstStyle xmlns:a="http://schemas.openxmlformats.org/drawingml/2006/main"/>
-          <a:p xmlns:a="http://schemas.openxmlformats.org/drawingml/2006/main">
+          <p:cNvPr id="606" name=""/>
+          <p:cNvSpPr>
+            <a:spLocks xmlns:a="http://schemas.openxmlformats.org/drawingml/2006/main" noGrp="1"/>
+          </p:cNvSpPr>
+          <p:nvPr/>
+        </p:nvSpPr>
+        <p:spPr>
+          <a:xfrm xmlns:a="http://schemas.openxmlformats.org/drawingml/2006/main">
+            <a:off x="4438650" y="4371975"/>
+            <a:ext cx="3067050" cy="247650"/>
+          </a:xfrm>
+          <a:prstGeom xmlns:a="http://schemas.openxmlformats.org/drawingml/2006/main" prst="rect">
+            <a:avLst/>
+          </a:prstGeom>
+          <a:noFill xmlns:a="http://schemas.openxmlformats.org/drawingml/2006/main"/>
+          <a:ln xmlns:a="http://schemas.openxmlformats.org/drawingml/2006/main" w="0">
+            <a:noFill/>
+          </a:ln>
+        </p:spPr>
+        <p:txBody xmlns:a="http://schemas.openxmlformats.org/drawingml/2006/main">
+          <a:bodyPr wrap="square" lIns="0" rIns="0" tIns="0" bIns="0">
+            <a:noAutofit/>
+          </a:bodyPr>
+          <a:lstStyle/>
+          <a:p>
             <a:pPr>
               <a:buNone/>
               <a:defRPr sz="1500" b="0">
@@ -3637,80 +3414,95 @@
                 <a:ea typeface="Helvetica Neue"/>
                 <a:cs typeface="Helvetica Neue"/>
               </a:rPr>
-              <a:t>7  Mint token</a:t>
-            </a:r>
-          </a:p>
-        </p:txBody>
-      </p:sp>
-      <p:sp>
-        <p:nvSpPr>
-          <p:cNvPr id="52" name="">
-            <a:extLst xmlns:a="http://schemas.openxmlformats.org/drawingml/2006/main">
-              <a:ext uri="{FF2B5EF4-FFF2-40B4-BE49-F238E27FC236}">
-                <a16:creationId xmlns:a16="http://schemas.microsoft.com/office/drawing/2014/main" id="{CD16FC22-12A1-4975-BD5A-2EE8D75E5119}"/>
-              </a:ext>
-            </a:extLst>
-          </p:cNvPr>
-          <p:cNvSpPr>
-            <a:spLocks xmlns:a="http://schemas.openxmlformats.org/drawingml/2006/main" noGrp="1"/>
-          </p:cNvSpPr>
-          <p:nvPr/>
-        </p:nvSpPr>
-        <p:spPr>
-          <a:xfrm xmlns:a="http://schemas.openxmlformats.org/drawingml/2006/main">
-            <a:off x="5943600" y="5572125"/>
-            <a:ext cx="9525" cy="9525"/>
-          </a:xfrm>
-          <a:prstGeom xmlns:a="http://schemas.openxmlformats.org/drawingml/2006/main" prst="rect">
-            <a:avLst/>
-          </a:prstGeom>
-          <a:noFill xmlns:a="http://schemas.openxmlformats.org/drawingml/2006/main"/>
-          <a:ln xmlns:a="http://schemas.openxmlformats.org/drawingml/2006/main" w="0">
-            <a:noFill/>
-          </a:ln>
-        </p:spPr>
-      </p:sp>
-      <p:sp>
-        <p:nvSpPr>
-          <p:cNvPr id="53" name="">
-            <a:extLst xmlns:a="http://schemas.openxmlformats.org/drawingml/2006/main">
-              <a:ext uri="{FF2B5EF4-FFF2-40B4-BE49-F238E27FC236}">
-                <a16:creationId xmlns:a16="http://schemas.microsoft.com/office/drawing/2014/main" id="{5B368C75-977A-49C6-8030-D8DAF992E2BE}"/>
-              </a:ext>
-            </a:extLst>
-          </p:cNvPr>
-          <p:cNvSpPr>
-            <a:spLocks xmlns:a="http://schemas.openxmlformats.org/drawingml/2006/main" noGrp="1"/>
-          </p:cNvSpPr>
-          <p:nvPr/>
-        </p:nvSpPr>
-        <p:spPr>
-          <a:xfrm xmlns:a="http://schemas.openxmlformats.org/drawingml/2006/main">
-            <a:off x="9144000" y="5572125"/>
-            <a:ext cx="9525" cy="9525"/>
-          </a:xfrm>
-          <a:prstGeom xmlns:a="http://schemas.openxmlformats.org/drawingml/2006/main" prst="rect">
-            <a:avLst/>
-          </a:prstGeom>
-          <a:noFill xmlns:a="http://schemas.openxmlformats.org/drawingml/2006/main"/>
-          <a:ln xmlns:a="http://schemas.openxmlformats.org/drawingml/2006/main" w="0">
-            <a:noFill/>
-          </a:ln>
-        </p:spPr>
+              <a:t>7  Token + payload</a:t>
+            </a:r>
+          </a:p>
+        </p:txBody>
       </p:sp>
       <p:cxnSp>
         <p:nvCxnSpPr>
-          <p:cNvPr id="404" name=""/>
-          <p:cNvCxnSpPr>
-            <a:stCxn xmlns:a="http://schemas.openxmlformats.org/drawingml/2006/main" id="52" idx="3"/>
-            <a:endCxn xmlns:a="http://schemas.openxmlformats.org/drawingml/2006/main" id="53" idx="1"/>
-          </p:cNvCxnSpPr>
+          <p:cNvPr id="507" name="507"/>
+          <p:cNvCxnSpPr/>
           <p:nvPr/>
         </p:nvCxnSpPr>
         <p:spPr>
           <a:xfrm xmlns:a="http://schemas.openxmlformats.org/drawingml/2006/main">
-            <a:off x="5953125" y="5576888"/>
-            <a:ext cx="3190875" cy="0"/>
+            <a:off x="5943600" y="4972050"/>
+            <a:ext cx="1600200" cy="0"/>
+          </a:xfrm>
+          <a:prstGeom xmlns:a="http://schemas.openxmlformats.org/drawingml/2006/main" prst="straightConnector1">
+            <a:avLst/>
+          </a:prstGeom>
+          <a:ln xmlns:a="http://schemas.openxmlformats.org/drawingml/2006/main" w="19050">
+            <a:solidFill>
+              <a:srgbClr val="117C63"/>
+            </a:solidFill>
+            <a:headEnd type="triangle" w="med" len="med"/>
+          </a:ln>
+        </p:spPr>
+      </p:cxnSp>
+      <p:sp>
+        <p:nvSpPr>
+          <p:cNvPr id="607" name=""/>
+          <p:cNvSpPr>
+            <a:spLocks xmlns:a="http://schemas.openxmlformats.org/drawingml/2006/main" noGrp="1"/>
+          </p:cNvSpPr>
+          <p:nvPr/>
+        </p:nvSpPr>
+        <p:spPr>
+          <a:xfrm xmlns:a="http://schemas.openxmlformats.org/drawingml/2006/main">
+            <a:off x="6038850" y="4714875"/>
+            <a:ext cx="1466850" cy="247650"/>
+          </a:xfrm>
+          <a:prstGeom xmlns:a="http://schemas.openxmlformats.org/drawingml/2006/main" prst="rect">
+            <a:avLst/>
+          </a:prstGeom>
+          <a:noFill xmlns:a="http://schemas.openxmlformats.org/drawingml/2006/main"/>
+          <a:ln xmlns:a="http://schemas.openxmlformats.org/drawingml/2006/main" w="0">
+            <a:noFill/>
+          </a:ln>
+        </p:spPr>
+        <p:txBody xmlns:a="http://schemas.openxmlformats.org/drawingml/2006/main">
+          <a:bodyPr wrap="square" lIns="0" rIns="0" tIns="0" bIns="0">
+            <a:noAutofit/>
+          </a:bodyPr>
+          <a:lstStyle/>
+          <a:p>
+            <a:pPr>
+              <a:buNone/>
+              <a:defRPr sz="1500" b="0">
+                <a:solidFill>
+                  <a:srgbClr val="17302B"/>
+                </a:solidFill>
+                <a:latin typeface="Helvetica Neue"/>
+                <a:ea typeface="Helvetica Neue"/>
+                <a:cs typeface="Helvetica Neue"/>
+              </a:defRPr>
+            </a:pPr>
+            <a:r>
+              <a:rPr sz="1500" b="0">
+                <a:solidFill>
+                  <a:srgbClr val="17302B"/>
+                </a:solidFill>
+                <a:latin typeface="Helvetica Neue"/>
+                <a:ea typeface="Helvetica Neue"/>
+                <a:cs typeface="Helvetica Neue"/>
+              </a:rPr>
+              <a:t>8  Live check</a:t>
+            </a:r>
+          </a:p>
+        </p:txBody>
+      </p:sp>
+      <p:cxnSp>
+        <p:nvCxnSpPr>
+          <p:cNvPr id="508" name="508"/>
+          <p:cNvCxnSpPr/>
+          <p:nvPr/>
+        </p:nvCxnSpPr>
+        <p:spPr>
+          <a:xfrm xmlns:a="http://schemas.openxmlformats.org/drawingml/2006/main">
+            <a:off x="7543800" y="5314950"/>
+            <a:ext cx="3200400" cy="0"/>
           </a:xfrm>
           <a:prstGeom xmlns:a="http://schemas.openxmlformats.org/drawingml/2006/main" prst="straightConnector1">
             <a:avLst/>
@@ -3725,37 +3517,31 @@
       </p:cxnSp>
       <p:sp>
         <p:nvSpPr>
-          <p:cNvPr id="55" name="">
-            <a:extLst xmlns:a="http://schemas.openxmlformats.org/drawingml/2006/main">
-              <a:ext uri="{FF2B5EF4-FFF2-40B4-BE49-F238E27FC236}">
-                <a16:creationId xmlns:a16="http://schemas.microsoft.com/office/drawing/2014/main" id="{F6DEF29D-0899-47FA-A17A-713FA66680A1}"/>
-              </a:ext>
-            </a:extLst>
-          </p:cNvPr>
-          <p:cNvSpPr>
-            <a:spLocks xmlns:a="http://schemas.openxmlformats.org/drawingml/2006/main" noGrp="1"/>
-          </p:cNvSpPr>
-          <p:nvPr/>
-        </p:nvSpPr>
-        <p:spPr>
-          <a:xfrm xmlns:a="http://schemas.openxmlformats.org/drawingml/2006/main">
-            <a:off x="6019800" y="5257800"/>
-            <a:ext cx="3048000" cy="295275"/>
-          </a:xfrm>
-          <a:prstGeom xmlns:a="http://schemas.openxmlformats.org/drawingml/2006/main" prst="rect">
-            <a:avLst/>
-          </a:prstGeom>
-          <a:noFill xmlns:a="http://schemas.openxmlformats.org/drawingml/2006/main"/>
-          <a:ln xmlns:a="http://schemas.openxmlformats.org/drawingml/2006/main" w="0">
-            <a:noFill/>
-          </a:ln>
-        </p:spPr>
-        <p:txBody>
-          <a:bodyPr xmlns:a="http://schemas.openxmlformats.org/drawingml/2006/main">
-            <a:noAutofit/>
-          </a:bodyPr>
-          <a:lstStyle xmlns:a="http://schemas.openxmlformats.org/drawingml/2006/main"/>
-          <a:p xmlns:a="http://schemas.openxmlformats.org/drawingml/2006/main">
+          <p:cNvPr id="608" name=""/>
+          <p:cNvSpPr>
+            <a:spLocks xmlns:a="http://schemas.openxmlformats.org/drawingml/2006/main" noGrp="1"/>
+          </p:cNvSpPr>
+          <p:nvPr/>
+        </p:nvSpPr>
+        <p:spPr>
+          <a:xfrm xmlns:a="http://schemas.openxmlformats.org/drawingml/2006/main">
+            <a:off x="7639050" y="5057775"/>
+            <a:ext cx="3067050" cy="247650"/>
+          </a:xfrm>
+          <a:prstGeom xmlns:a="http://schemas.openxmlformats.org/drawingml/2006/main" prst="rect">
+            <a:avLst/>
+          </a:prstGeom>
+          <a:noFill xmlns:a="http://schemas.openxmlformats.org/drawingml/2006/main"/>
+          <a:ln xmlns:a="http://schemas.openxmlformats.org/drawingml/2006/main" w="0">
+            <a:noFill/>
+          </a:ln>
+        </p:spPr>
+        <p:txBody xmlns:a="http://schemas.openxmlformats.org/drawingml/2006/main">
+          <a:bodyPr wrap="square" lIns="0" rIns="0" tIns="0" bIns="0">
+            <a:noAutofit/>
+          </a:bodyPr>
+          <a:lstStyle/>
+          <a:p>
             <a:pPr>
               <a:buNone/>
               <a:defRPr sz="1500" b="0">
@@ -3776,80 +3562,96 @@
                 <a:ea typeface="Helvetica Neue"/>
                 <a:cs typeface="Helvetica Neue"/>
               </a:rPr>
-              <a:t>8  Execute: token + payload</a:t>
-            </a:r>
-          </a:p>
-        </p:txBody>
-      </p:sp>
-      <p:sp>
-        <p:nvSpPr>
-          <p:cNvPr id="56" name="">
-            <a:extLst xmlns:a="http://schemas.openxmlformats.org/drawingml/2006/main">
-              <a:ext uri="{FF2B5EF4-FFF2-40B4-BE49-F238E27FC236}">
-                <a16:creationId xmlns:a16="http://schemas.microsoft.com/office/drawing/2014/main" id="{A287FE50-F7A4-4FC0-938D-37384B6D3538}"/>
-              </a:ext>
-            </a:extLst>
-          </p:cNvPr>
-          <p:cNvSpPr>
-            <a:spLocks xmlns:a="http://schemas.openxmlformats.org/drawingml/2006/main" noGrp="1"/>
-          </p:cNvSpPr>
-          <p:nvPr/>
-        </p:nvSpPr>
-        <p:spPr>
-          <a:xfrm xmlns:a="http://schemas.openxmlformats.org/drawingml/2006/main">
-            <a:off x="9144000" y="6143625"/>
-            <a:ext cx="9525" cy="9525"/>
-          </a:xfrm>
-          <a:prstGeom xmlns:a="http://schemas.openxmlformats.org/drawingml/2006/main" prst="rect">
-            <a:avLst/>
-          </a:prstGeom>
-          <a:noFill xmlns:a="http://schemas.openxmlformats.org/drawingml/2006/main"/>
-          <a:ln xmlns:a="http://schemas.openxmlformats.org/drawingml/2006/main" w="0">
-            <a:noFill/>
-          </a:ln>
-        </p:spPr>
-      </p:sp>
-      <p:sp>
-        <p:nvSpPr>
-          <p:cNvPr id="57" name="">
-            <a:extLst xmlns:a="http://schemas.openxmlformats.org/drawingml/2006/main">
-              <a:ext uri="{FF2B5EF4-FFF2-40B4-BE49-F238E27FC236}">
-                <a16:creationId xmlns:a16="http://schemas.microsoft.com/office/drawing/2014/main" id="{25A72750-2BD1-4396-90F9-AD98A8CA0B0E}"/>
-              </a:ext>
-            </a:extLst>
-          </p:cNvPr>
-          <p:cNvSpPr>
-            <a:spLocks xmlns:a="http://schemas.openxmlformats.org/drawingml/2006/main" noGrp="1"/>
-          </p:cNvSpPr>
-          <p:nvPr/>
-        </p:nvSpPr>
-        <p:spPr>
-          <a:xfrm xmlns:a="http://schemas.openxmlformats.org/drawingml/2006/main">
-            <a:off x="10744200" y="6143625"/>
-            <a:ext cx="9525" cy="9525"/>
-          </a:xfrm>
-          <a:prstGeom xmlns:a="http://schemas.openxmlformats.org/drawingml/2006/main" prst="rect">
-            <a:avLst/>
-          </a:prstGeom>
-          <a:noFill xmlns:a="http://schemas.openxmlformats.org/drawingml/2006/main"/>
-          <a:ln xmlns:a="http://schemas.openxmlformats.org/drawingml/2006/main" w="0">
-            <a:noFill/>
-          </a:ln>
-        </p:spPr>
+              <a:t>9a  Provider write</a:t>
+            </a:r>
+          </a:p>
+        </p:txBody>
       </p:sp>
       <p:cxnSp>
         <p:nvCxnSpPr>
-          <p:cNvPr id="408" name=""/>
-          <p:cNvCxnSpPr>
-            <a:stCxn xmlns:a="http://schemas.openxmlformats.org/drawingml/2006/main" id="56" idx="3"/>
-            <a:endCxn xmlns:a="http://schemas.openxmlformats.org/drawingml/2006/main" id="57" idx="1"/>
-          </p:cNvCxnSpPr>
+          <p:cNvPr id="509" name="509"/>
+          <p:cNvCxnSpPr/>
           <p:nvPr/>
         </p:nvCxnSpPr>
         <p:spPr>
           <a:xfrm xmlns:a="http://schemas.openxmlformats.org/drawingml/2006/main">
-            <a:off x="9153525" y="6148388"/>
-            <a:ext cx="1590675" cy="0"/>
+            <a:off x="7543800" y="5657850"/>
+            <a:ext cx="1600200" cy="0"/>
+          </a:xfrm>
+          <a:prstGeom xmlns:a="http://schemas.openxmlformats.org/drawingml/2006/main" prst="straightConnector1">
+            <a:avLst/>
+          </a:prstGeom>
+          <a:ln xmlns:a="http://schemas.openxmlformats.org/drawingml/2006/main" w="19050">
+            <a:solidFill>
+              <a:srgbClr val="117C63"/>
+            </a:solidFill>
+            <a:prstDash val="dash"/>
+            <a:tailEnd type="triangle" w="med" len="med"/>
+          </a:ln>
+        </p:spPr>
+      </p:cxnSp>
+      <p:sp>
+        <p:nvSpPr>
+          <p:cNvPr id="609" name=""/>
+          <p:cNvSpPr>
+            <a:spLocks xmlns:a="http://schemas.openxmlformats.org/drawingml/2006/main" noGrp="1"/>
+          </p:cNvSpPr>
+          <p:nvPr/>
+        </p:nvSpPr>
+        <p:spPr>
+          <a:xfrm xmlns:a="http://schemas.openxmlformats.org/drawingml/2006/main">
+            <a:off x="7639050" y="5400675"/>
+            <a:ext cx="1466850" cy="247650"/>
+          </a:xfrm>
+          <a:prstGeom xmlns:a="http://schemas.openxmlformats.org/drawingml/2006/main" prst="rect">
+            <a:avLst/>
+          </a:prstGeom>
+          <a:noFill xmlns:a="http://schemas.openxmlformats.org/drawingml/2006/main"/>
+          <a:ln xmlns:a="http://schemas.openxmlformats.org/drawingml/2006/main" w="0">
+            <a:noFill/>
+          </a:ln>
+        </p:spPr>
+        <p:txBody xmlns:a="http://schemas.openxmlformats.org/drawingml/2006/main">
+          <a:bodyPr wrap="square" lIns="0" rIns="0" tIns="0" bIns="0">
+            <a:noAutofit/>
+          </a:bodyPr>
+          <a:lstStyle/>
+          <a:p>
+            <a:pPr>
+              <a:buNone/>
+              <a:defRPr sz="1500" b="0">
+                <a:solidFill>
+                  <a:srgbClr val="17302B"/>
+                </a:solidFill>
+                <a:latin typeface="Helvetica Neue"/>
+                <a:ea typeface="Helvetica Neue"/>
+                <a:cs typeface="Helvetica Neue"/>
+              </a:defRPr>
+            </a:pPr>
+            <a:r>
+              <a:rPr sz="1500" b="0">
+                <a:solidFill>
+                  <a:srgbClr val="17302B"/>
+                </a:solidFill>
+                <a:latin typeface="Helvetica Neue"/>
+                <a:ea typeface="Helvetica Neue"/>
+                <a:cs typeface="Helvetica Neue"/>
+              </a:rPr>
+              <a:t>9b  Signed data</a:t>
+            </a:r>
+          </a:p>
+        </p:txBody>
+      </p:sp>
+      <p:cxnSp>
+        <p:nvCxnSpPr>
+          <p:cNvPr id="510" name="510"/>
+          <p:cNvCxnSpPr/>
+          <p:nvPr/>
+        </p:nvCxnSpPr>
+        <p:spPr>
+          <a:xfrm xmlns:a="http://schemas.openxmlformats.org/drawingml/2006/main">
+            <a:off x="9144000" y="6000750"/>
+            <a:ext cx="1600200" cy="0"/>
           </a:xfrm>
           <a:prstGeom xmlns:a="http://schemas.openxmlformats.org/drawingml/2006/main" prst="straightConnector1">
             <a:avLst/>
@@ -3864,37 +3666,31 @@
       </p:cxnSp>
       <p:sp>
         <p:nvSpPr>
-          <p:cNvPr id="59" name="">
-            <a:extLst xmlns:a="http://schemas.openxmlformats.org/drawingml/2006/main">
-              <a:ext uri="{FF2B5EF4-FFF2-40B4-BE49-F238E27FC236}">
-                <a16:creationId xmlns:a16="http://schemas.microsoft.com/office/drawing/2014/main" id="{46E9BA47-AA0F-49AB-A713-BF1B25FCD237}"/>
-              </a:ext>
-            </a:extLst>
-          </p:cNvPr>
-          <p:cNvSpPr>
-            <a:spLocks xmlns:a="http://schemas.openxmlformats.org/drawingml/2006/main" noGrp="1"/>
-          </p:cNvSpPr>
-          <p:nvPr/>
-        </p:nvSpPr>
-        <p:spPr>
-          <a:xfrm xmlns:a="http://schemas.openxmlformats.org/drawingml/2006/main">
-            <a:off x="9220200" y="5829300"/>
-            <a:ext cx="2190750" cy="295275"/>
-          </a:xfrm>
-          <a:prstGeom xmlns:a="http://schemas.openxmlformats.org/drawingml/2006/main" prst="rect">
-            <a:avLst/>
-          </a:prstGeom>
-          <a:noFill xmlns:a="http://schemas.openxmlformats.org/drawingml/2006/main"/>
-          <a:ln xmlns:a="http://schemas.openxmlformats.org/drawingml/2006/main" w="0">
-            <a:noFill/>
-          </a:ln>
-        </p:spPr>
-        <p:txBody>
-          <a:bodyPr xmlns:a="http://schemas.openxmlformats.org/drawingml/2006/main">
-            <a:noAutofit/>
-          </a:bodyPr>
-          <a:lstStyle xmlns:a="http://schemas.openxmlformats.org/drawingml/2006/main"/>
-          <a:p xmlns:a="http://schemas.openxmlformats.org/drawingml/2006/main">
+          <p:cNvPr id="610" name=""/>
+          <p:cNvSpPr>
+            <a:spLocks xmlns:a="http://schemas.openxmlformats.org/drawingml/2006/main" noGrp="1"/>
+          </p:cNvSpPr>
+          <p:nvPr/>
+        </p:nvSpPr>
+        <p:spPr>
+          <a:xfrm xmlns:a="http://schemas.openxmlformats.org/drawingml/2006/main">
+            <a:off x="9239250" y="5743575"/>
+            <a:ext cx="1466850" cy="247650"/>
+          </a:xfrm>
+          <a:prstGeom xmlns:a="http://schemas.openxmlformats.org/drawingml/2006/main" prst="rect">
+            <a:avLst/>
+          </a:prstGeom>
+          <a:noFill xmlns:a="http://schemas.openxmlformats.org/drawingml/2006/main"/>
+          <a:ln xmlns:a="http://schemas.openxmlformats.org/drawingml/2006/main" w="0">
+            <a:noFill/>
+          </a:ln>
+        </p:spPr>
+        <p:txBody xmlns:a="http://schemas.openxmlformats.org/drawingml/2006/main">
+          <a:bodyPr wrap="square" lIns="0" rIns="0" tIns="0" bIns="0">
+            <a:noAutofit/>
+          </a:bodyPr>
+          <a:lstStyle/>
+          <a:p>
             <a:pPr>
               <a:buNone/>
               <a:defRPr sz="1500" b="0">
@@ -3915,65 +3711,7 @@
                 <a:ea typeface="Helvetica Neue"/>
                 <a:cs typeface="Helvetica Neue"/>
               </a:rPr>
-              <a:t>9  Call with secret</a:t>
-            </a:r>
-          </a:p>
-        </p:txBody>
-      </p:sp>
-      <p:sp>
-        <p:nvSpPr>
-          <p:cNvPr id="60" name="">
-            <a:extLst xmlns:a="http://schemas.openxmlformats.org/drawingml/2006/main">
-              <a:ext uri="{FF2B5EF4-FFF2-40B4-BE49-F238E27FC236}">
-                <a16:creationId xmlns:a16="http://schemas.microsoft.com/office/drawing/2014/main" id="{6DAA9B5E-0DB9-412B-8A3D-01B8BC37AAF5}"/>
-              </a:ext>
-            </a:extLst>
-          </p:cNvPr>
-          <p:cNvSpPr>
-            <a:spLocks xmlns:a="http://schemas.openxmlformats.org/drawingml/2006/main" noGrp="1"/>
-          </p:cNvSpPr>
-          <p:nvPr/>
-        </p:nvSpPr>
-        <p:spPr>
-          <a:xfrm xmlns:a="http://schemas.openxmlformats.org/drawingml/2006/main">
-            <a:off x="609600" y="6229350"/>
-            <a:ext cx="10972800" cy="409575"/>
-          </a:xfrm>
-          <a:prstGeom xmlns:a="http://schemas.openxmlformats.org/drawingml/2006/main" prst="rect">
-            <a:avLst/>
-          </a:prstGeom>
-          <a:noFill xmlns:a="http://schemas.openxmlformats.org/drawingml/2006/main"/>
-          <a:ln xmlns:a="http://schemas.openxmlformats.org/drawingml/2006/main" w="0">
-            <a:noFill/>
-          </a:ln>
-        </p:spPr>
-        <p:txBody>
-          <a:bodyPr xmlns:a="http://schemas.openxmlformats.org/drawingml/2006/main">
-            <a:noAutofit/>
-          </a:bodyPr>
-          <a:lstStyle xmlns:a="http://schemas.openxmlformats.org/drawingml/2006/main"/>
-          <a:p xmlns:a="http://schemas.openxmlformats.org/drawingml/2006/main">
-            <a:pPr>
-              <a:buNone/>
-              <a:defRPr sz="1575" b="0">
-                <a:solidFill>
-                  <a:srgbClr val="53645D"/>
-                </a:solidFill>
-                <a:latin typeface="Helvetica Neue"/>
-                <a:ea typeface="Helvetica Neue"/>
-                <a:cs typeface="Helvetica Neue"/>
-              </a:defRPr>
-            </a:pPr>
-            <a:r>
-              <a:rPr sz="1575" b="0">
-                <a:solidFill>
-                  <a:srgbClr val="53645D"/>
-                </a:solidFill>
-                <a:latin typeface="Helvetica Neue"/>
-                <a:ea typeface="Helvetica Neue"/>
-                <a:cs typeface="Helvetica Neue"/>
-              </a:rPr>
-              <a:t>Requests shown; responses return on the same path. Broker calls the service provider and keeps the API key secure.</a:t>
+              <a:t>10  Use request</a:t>
             </a:r>
           </a:p>
         </p:txBody>
@@ -4034,6 +3772,64 @@
             <a:noFill/>
           </a:ln>
         </p:spPr>
+        <p:txBody xmlns:a="http://schemas.openxmlformats.org/drawingml/2006/main">
+          <a:bodyPr wrap="square">
+            <a:noAutofit/>
+          </a:bodyPr>
+          <a:lstStyle/>
+          <a:p>
+            <a:pPr>
+              <a:buNone/>
+              <a:defRPr sz="3300" b="1">
+                <a:solidFill>
+                  <a:srgbClr val="17302B"/>
+                </a:solidFill>
+                <a:latin typeface="Helvetica Neue"/>
+                <a:ea typeface="Helvetica Neue"/>
+                <a:cs typeface="Helvetica Neue"/>
+              </a:defRPr>
+            </a:pPr>
+            <a:r>
+              <a:rPr sz="3300" b="1">
+                <a:solidFill>
+                  <a:srgbClr val="17302B"/>
+                </a:solidFill>
+                <a:latin typeface="Helvetica Neue"/>
+                <a:ea typeface="Helvetica Neue"/>
+                <a:cs typeface="Helvetica Neue"/>
+              </a:rPr>
+              <a:t>How a protected run is authorized</a:t>
+            </a:r>
+          </a:p>
+        </p:txBody>
+      </p:sp>
+      <p:sp>
+        <p:nvSpPr>
+          <p:cNvPr id="2" name="">
+            <a:extLst xmlns:a="http://schemas.openxmlformats.org/drawingml/2006/main">
+              <a:ext uri="{FF2B5EF4-FFF2-40B4-BE49-F238E27FC236}">
+                <a16:creationId xmlns:a16="http://schemas.microsoft.com/office/drawing/2014/main" id="{4C041610-A025-47C5-8756-DB3144CD1C11}"/>
+              </a:ext>
+            </a:extLst>
+          </p:cNvPr>
+          <p:cNvSpPr>
+            <a:spLocks xmlns:a="http://schemas.openxmlformats.org/drawingml/2006/main" noGrp="1"/>
+          </p:cNvSpPr>
+          <p:nvPr/>
+        </p:nvSpPr>
+        <p:spPr>
+          <a:xfrm xmlns:a="http://schemas.openxmlformats.org/drawingml/2006/main">
+            <a:off x="609600" y="1695450"/>
+            <a:ext cx="609600" cy="457200"/>
+          </a:xfrm>
+          <a:prstGeom xmlns:a="http://schemas.openxmlformats.org/drawingml/2006/main" prst="rect">
+            <a:avLst/>
+          </a:prstGeom>
+          <a:noFill xmlns:a="http://schemas.openxmlformats.org/drawingml/2006/main"/>
+          <a:ln xmlns:a="http://schemas.openxmlformats.org/drawingml/2006/main" w="0">
+            <a:noFill/>
+          </a:ln>
+        </p:spPr>
         <p:txBody>
           <a:bodyPr xmlns:a="http://schemas.openxmlformats.org/drawingml/2006/main">
             <a:noAutofit/>
@@ -4042,7 +3838,65 @@
           <a:p xmlns:a="http://schemas.openxmlformats.org/drawingml/2006/main">
             <a:pPr>
               <a:buNone/>
-              <a:defRPr sz="3300" b="1">
+              <a:defRPr sz="2550" b="1">
+                <a:solidFill>
+                  <a:srgbClr val="117C63"/>
+                </a:solidFill>
+                <a:latin typeface="Helvetica Neue"/>
+                <a:ea typeface="Helvetica Neue"/>
+                <a:cs typeface="Helvetica Neue"/>
+              </a:defRPr>
+            </a:pPr>
+            <a:r>
+              <a:rPr sz="2550" b="1">
+                <a:solidFill>
+                  <a:srgbClr val="117C63"/>
+                </a:solidFill>
+                <a:latin typeface="Helvetica Neue"/>
+                <a:ea typeface="Helvetica Neue"/>
+                <a:cs typeface="Helvetica Neue"/>
+              </a:rPr>
+              <a:t>01</a:t>
+            </a:r>
+          </a:p>
+        </p:txBody>
+      </p:sp>
+      <p:sp>
+        <p:nvSpPr>
+          <p:cNvPr id="3" name="">
+            <a:extLst xmlns:a="http://schemas.openxmlformats.org/drawingml/2006/main">
+              <a:ext uri="{FF2B5EF4-FFF2-40B4-BE49-F238E27FC236}">
+                <a16:creationId xmlns:a16="http://schemas.microsoft.com/office/drawing/2014/main" id="{8396EA76-E4BB-4EE2-BCA7-0B3E1685B2CB}"/>
+              </a:ext>
+            </a:extLst>
+          </p:cNvPr>
+          <p:cNvSpPr>
+            <a:spLocks xmlns:a="http://schemas.openxmlformats.org/drawingml/2006/main" noGrp="1"/>
+          </p:cNvSpPr>
+          <p:nvPr/>
+        </p:nvSpPr>
+        <p:spPr>
+          <a:xfrm xmlns:a="http://schemas.openxmlformats.org/drawingml/2006/main">
+            <a:off x="1504950" y="1695450"/>
+            <a:ext cx="4191000" cy="438150"/>
+          </a:xfrm>
+          <a:prstGeom xmlns:a="http://schemas.openxmlformats.org/drawingml/2006/main" prst="rect">
+            <a:avLst/>
+          </a:prstGeom>
+          <a:noFill xmlns:a="http://schemas.openxmlformats.org/drawingml/2006/main"/>
+          <a:ln xmlns:a="http://schemas.openxmlformats.org/drawingml/2006/main" w="0">
+            <a:noFill/>
+          </a:ln>
+        </p:spPr>
+        <p:txBody xmlns:a="http://schemas.openxmlformats.org/drawingml/2006/main">
+          <a:bodyPr wrap="square">
+            <a:noAutofit/>
+          </a:bodyPr>
+          <a:lstStyle/>
+          <a:p>
+            <a:pPr>
+              <a:buNone/>
+              <a:defRPr sz="2250" b="1">
                 <a:solidFill>
                   <a:srgbClr val="17302B"/>
                 </a:solidFill>
@@ -4052,7 +3906,7 @@
               </a:defRPr>
             </a:pPr>
             <a:r>
-              <a:rPr sz="3300" b="1">
+              <a:rPr sz="2250" b="1">
                 <a:solidFill>
                   <a:srgbClr val="17302B"/>
                 </a:solidFill>
@@ -4060,28 +3914,86 @@
                 <a:ea typeface="Helvetica Neue"/>
                 <a:cs typeface="Helvetica Neue"/>
               </a:rPr>
-              <a:t>How a protected call runs</a:t>
-            </a:r>
-          </a:p>
-        </p:txBody>
-      </p:sp>
-      <p:sp>
-        <p:nvSpPr>
-          <p:cNvPr id="2" name="">
-            <a:extLst xmlns:a="http://schemas.openxmlformats.org/drawingml/2006/main">
-              <a:ext uri="{FF2B5EF4-FFF2-40B4-BE49-F238E27FC236}">
-                <a16:creationId xmlns:a16="http://schemas.microsoft.com/office/drawing/2014/main" id="{4C041610-A025-47C5-8756-DB3144CD1C11}"/>
-              </a:ext>
-            </a:extLst>
-          </p:cNvPr>
-          <p:cNvSpPr>
-            <a:spLocks xmlns:a="http://schemas.openxmlformats.org/drawingml/2006/main" noGrp="1"/>
-          </p:cNvSpPr>
-          <p:nvPr/>
-        </p:nvSpPr>
-        <p:spPr>
-          <a:xfrm xmlns:a="http://schemas.openxmlformats.org/drawingml/2006/main">
-            <a:off x="609600" y="1695450"/>
+              <a:t>Bind the invocation</a:t>
+            </a:r>
+          </a:p>
+        </p:txBody>
+      </p:sp>
+      <p:sp>
+        <p:nvSpPr>
+          <p:cNvPr id="4" name="">
+            <a:extLst xmlns:a="http://schemas.openxmlformats.org/drawingml/2006/main">
+              <a:ext uri="{FF2B5EF4-FFF2-40B4-BE49-F238E27FC236}">
+                <a16:creationId xmlns:a16="http://schemas.microsoft.com/office/drawing/2014/main" id="{3EA4B59F-D4FC-499D-A684-2CEAD4FE77D8}"/>
+              </a:ext>
+            </a:extLst>
+          </p:cNvPr>
+          <p:cNvSpPr>
+            <a:spLocks xmlns:a="http://schemas.openxmlformats.org/drawingml/2006/main" noGrp="1"/>
+          </p:cNvSpPr>
+          <p:nvPr/>
+        </p:nvSpPr>
+        <p:spPr>
+          <a:xfrm xmlns:a="http://schemas.openxmlformats.org/drawingml/2006/main">
+            <a:off x="5962650" y="1695450"/>
+            <a:ext cx="5505450" cy="857250"/>
+          </a:xfrm>
+          <a:prstGeom xmlns:a="http://schemas.openxmlformats.org/drawingml/2006/main" prst="rect">
+            <a:avLst/>
+          </a:prstGeom>
+          <a:noFill xmlns:a="http://schemas.openxmlformats.org/drawingml/2006/main"/>
+          <a:ln xmlns:a="http://schemas.openxmlformats.org/drawingml/2006/main" w="0">
+            <a:noFill/>
+          </a:ln>
+        </p:spPr>
+        <p:txBody xmlns:a="http://schemas.openxmlformats.org/drawingml/2006/main">
+          <a:bodyPr wrap="square">
+            <a:noAutofit/>
+          </a:bodyPr>
+          <a:lstStyle/>
+          <a:p>
+            <a:pPr>
+              <a:buNone/>
+              <a:defRPr sz="2025" b="0">
+                <a:solidFill>
+                  <a:srgbClr val="17302B"/>
+                </a:solidFill>
+                <a:latin typeface="Helvetica Neue"/>
+                <a:ea typeface="Helvetica Neue"/>
+                <a:cs typeface="Helvetica Neue"/>
+              </a:defRPr>
+            </a:pPr>
+            <a:r>
+              <a:rPr sz="2025" b="0">
+                <a:solidFill>
+                  <a:srgbClr val="17302B"/>
+                </a:solidFill>
+                <a:latin typeface="Helvetica Neue"/>
+                <a:ea typeface="Helvetica Neue"/>
+                <a:cs typeface="Helvetica Neue"/>
+              </a:rPr>
+              <a:t>The gateway binds the user, connection and retry identity.</a:t>
+            </a:r>
+          </a:p>
+        </p:txBody>
+      </p:sp>
+      <p:sp>
+        <p:nvSpPr>
+          <p:cNvPr id="5" name="">
+            <a:extLst xmlns:a="http://schemas.openxmlformats.org/drawingml/2006/main">
+              <a:ext uri="{FF2B5EF4-FFF2-40B4-BE49-F238E27FC236}">
+                <a16:creationId xmlns:a16="http://schemas.microsoft.com/office/drawing/2014/main" id="{19D15BC9-B984-42AF-9B6A-175DC98A1B19}"/>
+              </a:ext>
+            </a:extLst>
+          </p:cNvPr>
+          <p:cNvSpPr>
+            <a:spLocks xmlns:a="http://schemas.openxmlformats.org/drawingml/2006/main" noGrp="1"/>
+          </p:cNvSpPr>
+          <p:nvPr/>
+        </p:nvSpPr>
+        <p:spPr>
+          <a:xfrm xmlns:a="http://schemas.openxmlformats.org/drawingml/2006/main">
+            <a:off x="609600" y="2695575"/>
             <a:ext cx="609600" cy="457200"/>
           </a:xfrm>
           <a:prstGeom xmlns:a="http://schemas.openxmlformats.org/drawingml/2006/main" prst="rect">
@@ -4118,29 +4030,145 @@
                 <a:ea typeface="Helvetica Neue"/>
                 <a:cs typeface="Helvetica Neue"/>
               </a:rPr>
-              <a:t>01</a:t>
-            </a:r>
-          </a:p>
-        </p:txBody>
-      </p:sp>
-      <p:sp>
-        <p:nvSpPr>
-          <p:cNvPr id="3" name="">
-            <a:extLst xmlns:a="http://schemas.openxmlformats.org/drawingml/2006/main">
-              <a:ext uri="{FF2B5EF4-FFF2-40B4-BE49-F238E27FC236}">
-                <a16:creationId xmlns:a16="http://schemas.microsoft.com/office/drawing/2014/main" id="{8396EA76-E4BB-4EE2-BCA7-0B3E1685B2CB}"/>
-              </a:ext>
-            </a:extLst>
-          </p:cNvPr>
-          <p:cNvSpPr>
-            <a:spLocks xmlns:a="http://schemas.openxmlformats.org/drawingml/2006/main" noGrp="1"/>
-          </p:cNvSpPr>
-          <p:nvPr/>
-        </p:nvSpPr>
-        <p:spPr>
-          <a:xfrm xmlns:a="http://schemas.openxmlformats.org/drawingml/2006/main">
-            <a:off x="1504950" y="1695450"/>
+              <a:t>02</a:t>
+            </a:r>
+          </a:p>
+        </p:txBody>
+      </p:sp>
+      <p:sp>
+        <p:nvSpPr>
+          <p:cNvPr id="6" name="">
+            <a:extLst xmlns:a="http://schemas.openxmlformats.org/drawingml/2006/main">
+              <a:ext uri="{FF2B5EF4-FFF2-40B4-BE49-F238E27FC236}">
+                <a16:creationId xmlns:a16="http://schemas.microsoft.com/office/drawing/2014/main" id="{3D55ECBF-7860-4E87-8E32-93EDAF26E436}"/>
+              </a:ext>
+            </a:extLst>
+          </p:cNvPr>
+          <p:cNvSpPr>
+            <a:spLocks xmlns:a="http://schemas.openxmlformats.org/drawingml/2006/main" noGrp="1"/>
+          </p:cNvSpPr>
+          <p:nvPr/>
+        </p:nvSpPr>
+        <p:spPr>
+          <a:xfrm xmlns:a="http://schemas.openxmlformats.org/drawingml/2006/main">
+            <a:off x="1504950" y="2695575"/>
             <a:ext cx="4191000" cy="438150"/>
+          </a:xfrm>
+          <a:prstGeom xmlns:a="http://schemas.openxmlformats.org/drawingml/2006/main" prst="rect">
+            <a:avLst/>
+          </a:prstGeom>
+          <a:noFill xmlns:a="http://schemas.openxmlformats.org/drawingml/2006/main"/>
+          <a:ln xmlns:a="http://schemas.openxmlformats.org/drawingml/2006/main" w="0">
+            <a:noFill/>
+          </a:ln>
+        </p:spPr>
+        <p:txBody xmlns:a="http://schemas.openxmlformats.org/drawingml/2006/main">
+          <a:bodyPr wrap="square">
+            <a:noAutofit/>
+          </a:bodyPr>
+          <a:lstStyle/>
+          <a:p>
+            <a:pPr>
+              <a:buNone/>
+              <a:defRPr sz="2250" b="1">
+                <a:solidFill>
+                  <a:srgbClr val="17302B"/>
+                </a:solidFill>
+                <a:latin typeface="Helvetica Neue"/>
+                <a:ea typeface="Helvetica Neue"/>
+                <a:cs typeface="Helvetica Neue"/>
+              </a:defRPr>
+            </a:pPr>
+            <a:r>
+              <a:rPr sz="2250" b="1">
+                <a:solidFill>
+                  <a:srgbClr val="17302B"/>
+                </a:solidFill>
+                <a:latin typeface="Helvetica Neue"/>
+                <a:ea typeface="Helvetica Neue"/>
+                <a:cs typeface="Helvetica Neue"/>
+              </a:rPr>
+              <a:t>Admit the full chain</a:t>
+            </a:r>
+          </a:p>
+        </p:txBody>
+      </p:sp>
+      <p:sp>
+        <p:nvSpPr>
+          <p:cNvPr id="7" name="">
+            <a:extLst xmlns:a="http://schemas.openxmlformats.org/drawingml/2006/main">
+              <a:ext uri="{FF2B5EF4-FFF2-40B4-BE49-F238E27FC236}">
+                <a16:creationId xmlns:a16="http://schemas.microsoft.com/office/drawing/2014/main" id="{444E9874-EA03-4655-B475-A048546CD91A}"/>
+              </a:ext>
+            </a:extLst>
+          </p:cNvPr>
+          <p:cNvSpPr>
+            <a:spLocks xmlns:a="http://schemas.openxmlformats.org/drawingml/2006/main" noGrp="1"/>
+          </p:cNvSpPr>
+          <p:nvPr/>
+        </p:nvSpPr>
+        <p:spPr>
+          <a:xfrm xmlns:a="http://schemas.openxmlformats.org/drawingml/2006/main">
+            <a:off x="5962650" y="2695575"/>
+            <a:ext cx="5505450" cy="857250"/>
+          </a:xfrm>
+          <a:prstGeom xmlns:a="http://schemas.openxmlformats.org/drawingml/2006/main" prst="rect">
+            <a:avLst/>
+          </a:prstGeom>
+          <a:noFill xmlns:a="http://schemas.openxmlformats.org/drawingml/2006/main"/>
+          <a:ln xmlns:a="http://schemas.openxmlformats.org/drawingml/2006/main" w="0">
+            <a:noFill/>
+          </a:ln>
+        </p:spPr>
+        <p:txBody xmlns:a="http://schemas.openxmlformats.org/drawingml/2006/main">
+          <a:bodyPr wrap="square">
+            <a:noAutofit/>
+          </a:bodyPr>
+          <a:lstStyle/>
+          <a:p>
+            <a:pPr>
+              <a:buNone/>
+              <a:defRPr sz="2025" b="0">
+                <a:solidFill>
+                  <a:srgbClr val="17302B"/>
+                </a:solidFill>
+                <a:latin typeface="Helvetica Neue"/>
+                <a:ea typeface="Helvetica Neue"/>
+                <a:cs typeface="Helvetica Neue"/>
+              </a:defRPr>
+            </a:pPr>
+            <a:r>
+              <a:rPr sz="2025" b="0">
+                <a:solidFill>
+                  <a:srgbClr val="17302B"/>
+                </a:solidFill>
+                <a:latin typeface="Helvetica Neue"/>
+                <a:ea typeface="Helvetica Neue"/>
+                <a:cs typeface="Helvetica Neue"/>
+              </a:rPr>
+              <a:t>Compilers preflight all stages. Policy admits one pinned plan before execution.</a:t>
+            </a:r>
+          </a:p>
+        </p:txBody>
+      </p:sp>
+      <p:sp>
+        <p:nvSpPr>
+          <p:cNvPr id="8" name="">
+            <a:extLst xmlns:a="http://schemas.openxmlformats.org/drawingml/2006/main">
+              <a:ext uri="{FF2B5EF4-FFF2-40B4-BE49-F238E27FC236}">
+                <a16:creationId xmlns:a16="http://schemas.microsoft.com/office/drawing/2014/main" id="{7D02FD7A-151A-4CB5-A810-54BF7025F135}"/>
+              </a:ext>
+            </a:extLst>
+          </p:cNvPr>
+          <p:cNvSpPr>
+            <a:spLocks xmlns:a="http://schemas.openxmlformats.org/drawingml/2006/main" noGrp="1"/>
+          </p:cNvSpPr>
+          <p:nvPr/>
+        </p:nvSpPr>
+        <p:spPr>
+          <a:xfrm xmlns:a="http://schemas.openxmlformats.org/drawingml/2006/main">
+            <a:off x="609600" y="3695700"/>
+            <a:ext cx="609600" cy="457200"/>
           </a:xfrm>
           <a:prstGeom xmlns:a="http://schemas.openxmlformats.org/drawingml/2006/main" prst="rect">
             <a:avLst/>
@@ -4158,47 +4186,47 @@
           <a:p xmlns:a="http://schemas.openxmlformats.org/drawingml/2006/main">
             <a:pPr>
               <a:buNone/>
-              <a:defRPr sz="2250" b="1">
-                <a:solidFill>
-                  <a:srgbClr val="17302B"/>
-                </a:solidFill>
-                <a:latin typeface="Helvetica Neue"/>
-                <a:ea typeface="Helvetica Neue"/>
-                <a:cs typeface="Helvetica Neue"/>
-              </a:defRPr>
-            </a:pPr>
-            <a:r>
-              <a:rPr sz="2250" b="1">
-                <a:solidFill>
-                  <a:srgbClr val="17302B"/>
-                </a:solidFill>
-                <a:latin typeface="Helvetica Neue"/>
-                <a:ea typeface="Helvetica Neue"/>
-                <a:cs typeface="Helvetica Neue"/>
-              </a:rPr>
-              <a:t>Select a connection</a:t>
-            </a:r>
-          </a:p>
-        </p:txBody>
-      </p:sp>
-      <p:sp>
-        <p:nvSpPr>
-          <p:cNvPr id="4" name="">
-            <a:extLst xmlns:a="http://schemas.openxmlformats.org/drawingml/2006/main">
-              <a:ext uri="{FF2B5EF4-FFF2-40B4-BE49-F238E27FC236}">
-                <a16:creationId xmlns:a16="http://schemas.microsoft.com/office/drawing/2014/main" id="{3EA4B59F-D4FC-499D-A684-2CEAD4FE77D8}"/>
-              </a:ext>
-            </a:extLst>
-          </p:cNvPr>
-          <p:cNvSpPr>
-            <a:spLocks xmlns:a="http://schemas.openxmlformats.org/drawingml/2006/main" noGrp="1"/>
-          </p:cNvSpPr>
-          <p:nvPr/>
-        </p:nvSpPr>
-        <p:spPr>
-          <a:xfrm xmlns:a="http://schemas.openxmlformats.org/drawingml/2006/main">
-            <a:off x="5962650" y="1695450"/>
-            <a:ext cx="5505450" cy="742950"/>
+              <a:defRPr sz="2550" b="1">
+                <a:solidFill>
+                  <a:srgbClr val="117C63"/>
+                </a:solidFill>
+                <a:latin typeface="Helvetica Neue"/>
+                <a:ea typeface="Helvetica Neue"/>
+                <a:cs typeface="Helvetica Neue"/>
+              </a:defRPr>
+            </a:pPr>
+            <a:r>
+              <a:rPr sz="2550" b="1">
+                <a:solidFill>
+                  <a:srgbClr val="117C63"/>
+                </a:solidFill>
+                <a:latin typeface="Helvetica Neue"/>
+                <a:ea typeface="Helvetica Neue"/>
+                <a:cs typeface="Helvetica Neue"/>
+              </a:rPr>
+              <a:t>03</a:t>
+            </a:r>
+          </a:p>
+        </p:txBody>
+      </p:sp>
+      <p:sp>
+        <p:nvSpPr>
+          <p:cNvPr id="9" name="">
+            <a:extLst xmlns:a="http://schemas.openxmlformats.org/drawingml/2006/main">
+              <a:ext uri="{FF2B5EF4-FFF2-40B4-BE49-F238E27FC236}">
+                <a16:creationId xmlns:a16="http://schemas.microsoft.com/office/drawing/2014/main" id="{E78D7242-CD9B-40E0-BAB6-2FA3C64E26F2}"/>
+              </a:ext>
+            </a:extLst>
+          </p:cNvPr>
+          <p:cNvSpPr>
+            <a:spLocks xmlns:a="http://schemas.openxmlformats.org/drawingml/2006/main" noGrp="1"/>
+          </p:cNvSpPr>
+          <p:nvPr/>
+        </p:nvSpPr>
+        <p:spPr>
+          <a:xfrm xmlns:a="http://schemas.openxmlformats.org/drawingml/2006/main">
+            <a:off x="1504950" y="3695700"/>
+            <a:ext cx="4191000" cy="438150"/>
           </a:xfrm>
           <a:prstGeom xmlns:a="http://schemas.openxmlformats.org/drawingml/2006/main" prst="rect">
             <a:avLst/>
@@ -4216,6 +4244,64 @@
           <a:p xmlns:a="http://schemas.openxmlformats.org/drawingml/2006/main">
             <a:pPr>
               <a:buNone/>
+              <a:defRPr sz="2250" b="1">
+                <a:solidFill>
+                  <a:srgbClr val="17302B"/>
+                </a:solidFill>
+                <a:latin typeface="Helvetica Neue"/>
+                <a:ea typeface="Helvetica Neue"/>
+                <a:cs typeface="Helvetica Neue"/>
+              </a:defRPr>
+            </a:pPr>
+            <a:r>
+              <a:rPr sz="2250" b="1">
+                <a:solidFill>
+                  <a:srgbClr val="17302B"/>
+                </a:solidFill>
+                <a:latin typeface="Helvetica Neue"/>
+                <a:ea typeface="Helvetica Neue"/>
+                <a:cs typeface="Helvetica Neue"/>
+              </a:rPr>
+              <a:t>Mint proof for one call</a:t>
+            </a:r>
+          </a:p>
+        </p:txBody>
+      </p:sp>
+      <p:sp>
+        <p:nvSpPr>
+          <p:cNvPr id="10" name="">
+            <a:extLst xmlns:a="http://schemas.openxmlformats.org/drawingml/2006/main">
+              <a:ext uri="{FF2B5EF4-FFF2-40B4-BE49-F238E27FC236}">
+                <a16:creationId xmlns:a16="http://schemas.microsoft.com/office/drawing/2014/main" id="{4139131E-4C54-496A-A498-8307D60AB572}"/>
+              </a:ext>
+            </a:extLst>
+          </p:cNvPr>
+          <p:cNvSpPr>
+            <a:spLocks xmlns:a="http://schemas.openxmlformats.org/drawingml/2006/main" noGrp="1"/>
+          </p:cNvSpPr>
+          <p:nvPr/>
+        </p:nvSpPr>
+        <p:spPr>
+          <a:xfrm xmlns:a="http://schemas.openxmlformats.org/drawingml/2006/main">
+            <a:off x="5962650" y="3695700"/>
+            <a:ext cx="5505450" cy="857250"/>
+          </a:xfrm>
+          <a:prstGeom xmlns:a="http://schemas.openxmlformats.org/drawingml/2006/main" prst="rect">
+            <a:avLst/>
+          </a:prstGeom>
+          <a:noFill xmlns:a="http://schemas.openxmlformats.org/drawingml/2006/main"/>
+          <a:ln xmlns:a="http://schemas.openxmlformats.org/drawingml/2006/main" w="0">
+            <a:noFill/>
+          </a:ln>
+        </p:spPr>
+        <p:txBody xmlns:a="http://schemas.openxmlformats.org/drawingml/2006/main">
+          <a:bodyPr wrap="square">
+            <a:noAutofit/>
+          </a:bodyPr>
+          <a:lstStyle/>
+          <a:p>
+            <a:pPr>
+              <a:buNone/>
               <a:defRPr sz="2025" b="0">
                 <a:solidFill>
                   <a:srgbClr val="17302B"/>
@@ -4234,28 +4320,28 @@
                 <a:ea typeface="Helvetica Neue"/>
                 <a:cs typeface="Helvetica Neue"/>
               </a:rPr>
-              <a:t>The gateway establishes the user and logical invocation.</a:t>
-            </a:r>
-          </a:p>
-        </p:txBody>
-      </p:sp>
-      <p:sp>
-        <p:nvSpPr>
-          <p:cNvPr id="5" name="">
-            <a:extLst xmlns:a="http://schemas.openxmlformats.org/drawingml/2006/main">
-              <a:ext uri="{FF2B5EF4-FFF2-40B4-BE49-F238E27FC236}">
-                <a16:creationId xmlns:a16="http://schemas.microsoft.com/office/drawing/2014/main" id="{19D15BC9-B984-42AF-9B6A-175DC98A1B19}"/>
-              </a:ext>
-            </a:extLst>
-          </p:cNvPr>
-          <p:cNvSpPr>
-            <a:spLocks xmlns:a="http://schemas.openxmlformats.org/drawingml/2006/main" noGrp="1"/>
-          </p:cNvSpPr>
-          <p:nvPr/>
-        </p:nvSpPr>
-        <p:spPr>
-          <a:xfrm xmlns:a="http://schemas.openxmlformats.org/drawingml/2006/main">
-            <a:off x="609600" y="2695575"/>
+              <a:t>Policy rechecks access and binds a token to the operation and argument digest.</a:t>
+            </a:r>
+          </a:p>
+        </p:txBody>
+      </p:sp>
+      <p:sp>
+        <p:nvSpPr>
+          <p:cNvPr id="11" name="">
+            <a:extLst xmlns:a="http://schemas.openxmlformats.org/drawingml/2006/main">
+              <a:ext uri="{FF2B5EF4-FFF2-40B4-BE49-F238E27FC236}">
+                <a16:creationId xmlns:a16="http://schemas.microsoft.com/office/drawing/2014/main" id="{CE55CD08-B572-4016-BAAC-EBF090D60763}"/>
+              </a:ext>
+            </a:extLst>
+          </p:cNvPr>
+          <p:cNvSpPr>
+            <a:spLocks xmlns:a="http://schemas.openxmlformats.org/drawingml/2006/main" noGrp="1"/>
+          </p:cNvSpPr>
+          <p:nvPr/>
+        </p:nvSpPr>
+        <p:spPr>
+          <a:xfrm xmlns:a="http://schemas.openxmlformats.org/drawingml/2006/main">
+            <a:off x="609600" y="4695825"/>
             <a:ext cx="609600" cy="457200"/>
           </a:xfrm>
           <a:prstGeom xmlns:a="http://schemas.openxmlformats.org/drawingml/2006/main" prst="rect">
@@ -4292,44 +4378,44 @@
                 <a:ea typeface="Helvetica Neue"/>
                 <a:cs typeface="Helvetica Neue"/>
               </a:rPr>
-              <a:t>02</a:t>
-            </a:r>
-          </a:p>
-        </p:txBody>
-      </p:sp>
-      <p:sp>
-        <p:nvSpPr>
-          <p:cNvPr id="6" name="">
-            <a:extLst xmlns:a="http://schemas.openxmlformats.org/drawingml/2006/main">
-              <a:ext uri="{FF2B5EF4-FFF2-40B4-BE49-F238E27FC236}">
-                <a16:creationId xmlns:a16="http://schemas.microsoft.com/office/drawing/2014/main" id="{3D55ECBF-7860-4E87-8E32-93EDAF26E436}"/>
-              </a:ext>
-            </a:extLst>
-          </p:cNvPr>
-          <p:cNvSpPr>
-            <a:spLocks xmlns:a="http://schemas.openxmlformats.org/drawingml/2006/main" noGrp="1"/>
-          </p:cNvSpPr>
-          <p:nvPr/>
-        </p:nvSpPr>
-        <p:spPr>
-          <a:xfrm xmlns:a="http://schemas.openxmlformats.org/drawingml/2006/main">
-            <a:off x="1504950" y="2695575"/>
-            <a:ext cx="4191000" cy="438150"/>
-          </a:xfrm>
-          <a:prstGeom xmlns:a="http://schemas.openxmlformats.org/drawingml/2006/main" prst="rect">
-            <a:avLst/>
-          </a:prstGeom>
-          <a:noFill xmlns:a="http://schemas.openxmlformats.org/drawingml/2006/main"/>
-          <a:ln xmlns:a="http://schemas.openxmlformats.org/drawingml/2006/main" w="0">
-            <a:noFill/>
-          </a:ln>
-        </p:spPr>
-        <p:txBody>
-          <a:bodyPr xmlns:a="http://schemas.openxmlformats.org/drawingml/2006/main">
-            <a:noAutofit/>
-          </a:bodyPr>
-          <a:lstStyle xmlns:a="http://schemas.openxmlformats.org/drawingml/2006/main"/>
-          <a:p xmlns:a="http://schemas.openxmlformats.org/drawingml/2006/main">
+              <a:t>04</a:t>
+            </a:r>
+          </a:p>
+        </p:txBody>
+      </p:sp>
+      <p:sp>
+        <p:nvSpPr>
+          <p:cNvPr id="12" name="">
+            <a:extLst xmlns:a="http://schemas.openxmlformats.org/drawingml/2006/main">
+              <a:ext uri="{FF2B5EF4-FFF2-40B4-BE49-F238E27FC236}">
+                <a16:creationId xmlns:a16="http://schemas.microsoft.com/office/drawing/2014/main" id="{DBCE0E39-8DEF-463F-ABBF-D3871AE8BE80}"/>
+              </a:ext>
+            </a:extLst>
+          </p:cNvPr>
+          <p:cNvSpPr>
+            <a:spLocks xmlns:a="http://schemas.openxmlformats.org/drawingml/2006/main" noGrp="1"/>
+          </p:cNvSpPr>
+          <p:nvPr/>
+        </p:nvSpPr>
+        <p:spPr>
+          <a:xfrm xmlns:a="http://schemas.openxmlformats.org/drawingml/2006/main">
+            <a:off x="1504950" y="4695825"/>
+            <a:ext cx="4476750" cy="495300"/>
+          </a:xfrm>
+          <a:prstGeom xmlns:a="http://schemas.openxmlformats.org/drawingml/2006/main" prst="rect">
+            <a:avLst/>
+          </a:prstGeom>
+          <a:noFill xmlns:a="http://schemas.openxmlformats.org/drawingml/2006/main"/>
+          <a:ln xmlns:a="http://schemas.openxmlformats.org/drawingml/2006/main" w="0">
+            <a:noFill/>
+          </a:ln>
+        </p:spPr>
+        <p:txBody xmlns:a="http://schemas.openxmlformats.org/drawingml/2006/main">
+          <a:bodyPr wrap="square">
+            <a:noAutofit/>
+          </a:bodyPr>
+          <a:lstStyle/>
+          <a:p>
             <a:pPr>
               <a:buNone/>
               <a:defRPr sz="2250" b="1">
@@ -4350,44 +4436,44 @@
                 <a:ea typeface="Helvetica Neue"/>
                 <a:cs typeface="Helvetica Neue"/>
               </a:rPr>
-              <a:t>Check the whole program</a:t>
-            </a:r>
-          </a:p>
-        </p:txBody>
-      </p:sp>
-      <p:sp>
-        <p:nvSpPr>
-          <p:cNvPr id="7" name="">
-            <a:extLst xmlns:a="http://schemas.openxmlformats.org/drawingml/2006/main">
-              <a:ext uri="{FF2B5EF4-FFF2-40B4-BE49-F238E27FC236}">
-                <a16:creationId xmlns:a16="http://schemas.microsoft.com/office/drawing/2014/main" id="{444E9874-EA03-4655-B475-A048546CD91A}"/>
-              </a:ext>
-            </a:extLst>
-          </p:cNvPr>
-          <p:cNvSpPr>
-            <a:spLocks xmlns:a="http://schemas.openxmlformats.org/drawingml/2006/main" noGrp="1"/>
-          </p:cNvSpPr>
-          <p:nvPr/>
-        </p:nvSpPr>
-        <p:spPr>
-          <a:xfrm xmlns:a="http://schemas.openxmlformats.org/drawingml/2006/main">
-            <a:off x="5962650" y="2695575"/>
-            <a:ext cx="5505450" cy="742950"/>
-          </a:xfrm>
-          <a:prstGeom xmlns:a="http://schemas.openxmlformats.org/drawingml/2006/main" prst="rect">
-            <a:avLst/>
-          </a:prstGeom>
-          <a:noFill xmlns:a="http://schemas.openxmlformats.org/drawingml/2006/main"/>
-          <a:ln xmlns:a="http://schemas.openxmlformats.org/drawingml/2006/main" w="0">
-            <a:noFill/>
-          </a:ln>
-        </p:spPr>
-        <p:txBody>
-          <a:bodyPr xmlns:a="http://schemas.openxmlformats.org/drawingml/2006/main">
-            <a:noAutofit/>
-          </a:bodyPr>
-          <a:lstStyle xmlns:a="http://schemas.openxmlformats.org/drawingml/2006/main"/>
-          <a:p xmlns:a="http://schemas.openxmlformats.org/drawingml/2006/main">
+              <a:t>Recheck before each effect</a:t>
+            </a:r>
+          </a:p>
+        </p:txBody>
+      </p:sp>
+      <p:sp>
+        <p:nvSpPr>
+          <p:cNvPr id="13" name="">
+            <a:extLst xmlns:a="http://schemas.openxmlformats.org/drawingml/2006/main">
+              <a:ext uri="{FF2B5EF4-FFF2-40B4-BE49-F238E27FC236}">
+                <a16:creationId xmlns:a16="http://schemas.microsoft.com/office/drawing/2014/main" id="{DD270EE4-20E1-4407-92BE-AF8377BFDC37}"/>
+              </a:ext>
+            </a:extLst>
+          </p:cNvPr>
+          <p:cNvSpPr>
+            <a:spLocks xmlns:a="http://schemas.openxmlformats.org/drawingml/2006/main" noGrp="1"/>
+          </p:cNvSpPr>
+          <p:nvPr/>
+        </p:nvSpPr>
+        <p:spPr>
+          <a:xfrm xmlns:a="http://schemas.openxmlformats.org/drawingml/2006/main">
+            <a:off x="5962650" y="4695825"/>
+            <a:ext cx="5505450" cy="914400"/>
+          </a:xfrm>
+          <a:prstGeom xmlns:a="http://schemas.openxmlformats.org/drawingml/2006/main" prst="rect">
+            <a:avLst/>
+          </a:prstGeom>
+          <a:noFill xmlns:a="http://schemas.openxmlformats.org/drawingml/2006/main"/>
+          <a:ln xmlns:a="http://schemas.openxmlformats.org/drawingml/2006/main" w="0">
+            <a:noFill/>
+          </a:ln>
+        </p:spPr>
+        <p:txBody xmlns:a="http://schemas.openxmlformats.org/drawingml/2006/main">
+          <a:bodyPr wrap="square">
+            <a:noAutofit/>
+          </a:bodyPr>
+          <a:lstStyle/>
+          <a:p>
             <a:pPr>
               <a:buNone/>
               <a:defRPr sz="2025" b="0">
@@ -4408,47 +4494,47 @@
                 <a:ea typeface="Helvetica Neue"/>
                 <a:cs typeface="Helvetica Neue"/>
               </a:rPr>
-              <a:t>The compiler rejects ungranted protected functions before execution.</a:t>
-            </a:r>
-          </a:p>
-        </p:txBody>
-      </p:sp>
-      <p:sp>
-        <p:nvSpPr>
-          <p:cNvPr id="8" name="">
-            <a:extLst xmlns:a="http://schemas.openxmlformats.org/drawingml/2006/main">
-              <a:ext uri="{FF2B5EF4-FFF2-40B4-BE49-F238E27FC236}">
-                <a16:creationId xmlns:a16="http://schemas.microsoft.com/office/drawing/2014/main" id="{7D02FD7A-151A-4CB5-A810-54BF7025F135}"/>
-              </a:ext>
-            </a:extLst>
-          </p:cNvPr>
-          <p:cNvSpPr>
-            <a:spLocks xmlns:a="http://schemas.openxmlformats.org/drawingml/2006/main" noGrp="1"/>
-          </p:cNvSpPr>
-          <p:nvPr/>
-        </p:nvSpPr>
-        <p:spPr>
-          <a:xfrm xmlns:a="http://schemas.openxmlformats.org/drawingml/2006/main">
-            <a:off x="609600" y="3695700"/>
-            <a:ext cx="609600" cy="457200"/>
-          </a:xfrm>
-          <a:prstGeom xmlns:a="http://schemas.openxmlformats.org/drawingml/2006/main" prst="rect">
-            <a:avLst/>
-          </a:prstGeom>
-          <a:noFill xmlns:a="http://schemas.openxmlformats.org/drawingml/2006/main"/>
-          <a:ln xmlns:a="http://schemas.openxmlformats.org/drawingml/2006/main" w="0">
-            <a:noFill/>
-          </a:ln>
-        </p:spPr>
-        <p:txBody>
-          <a:bodyPr xmlns:a="http://schemas.openxmlformats.org/drawingml/2006/main">
-            <a:noAutofit/>
-          </a:bodyPr>
-          <a:lstStyle xmlns:a="http://schemas.openxmlformats.org/drawingml/2006/main"/>
-          <a:p xmlns:a="http://schemas.openxmlformats.org/drawingml/2006/main">
-            <a:pPr>
-              <a:buNone/>
-              <a:defRPr sz="2550" b="1">
+              <a:t>Broker verifies proof and asks Policy live before each provider request or signature.</a:t>
+            </a:r>
+          </a:p>
+        </p:txBody>
+      </p:sp>
+      <p:sp>
+        <p:nvSpPr>
+          <p:cNvPr id="14" name="">
+            <a:extLst xmlns:a="http://schemas.openxmlformats.org/drawingml/2006/main">
+              <a:ext uri="{FF2B5EF4-FFF2-40B4-BE49-F238E27FC236}">
+                <a16:creationId xmlns:a16="http://schemas.microsoft.com/office/drawing/2014/main" id="{2C561353-C2AA-4DF1-9605-1422C26A5363}"/>
+              </a:ext>
+            </a:extLst>
+          </p:cNvPr>
+          <p:cNvSpPr>
+            <a:spLocks xmlns:a="http://schemas.openxmlformats.org/drawingml/2006/main" noGrp="1"/>
+          </p:cNvSpPr>
+          <p:nvPr/>
+        </p:nvSpPr>
+        <p:spPr>
+          <a:xfrm xmlns:a="http://schemas.openxmlformats.org/drawingml/2006/main">
+            <a:off x="1504950" y="5743575"/>
+            <a:ext cx="9858375" cy="933450"/>
+          </a:xfrm>
+          <a:prstGeom xmlns:a="http://schemas.openxmlformats.org/drawingml/2006/main" prst="rect">
+            <a:avLst/>
+          </a:prstGeom>
+          <a:noFill xmlns:a="http://schemas.openxmlformats.org/drawingml/2006/main"/>
+          <a:ln xmlns:a="http://schemas.openxmlformats.org/drawingml/2006/main" w="0">
+            <a:noFill/>
+          </a:ln>
+        </p:spPr>
+        <p:txBody xmlns:a="http://schemas.openxmlformats.org/drawingml/2006/main">
+          <a:bodyPr wrap="square">
+            <a:noAutofit/>
+          </a:bodyPr>
+          <a:lstStyle/>
+          <a:p>
+            <a:pPr>
+              <a:buNone/>
+              <a:defRPr sz="1800" b="1">
                 <a:solidFill>
                   <a:srgbClr val="117C63"/>
                 </a:solidFill>
@@ -4458,7 +4544,7 @@
               </a:defRPr>
             </a:pPr>
             <a:r>
-              <a:rPr sz="2550" b="1">
+              <a:rPr sz="1800" b="1">
                 <a:solidFill>
                   <a:srgbClr val="117C63"/>
                 </a:solidFill>
@@ -4466,163 +4552,13 @@
                 <a:ea typeface="Helvetica Neue"/>
                 <a:cs typeface="Helvetica Neue"/>
               </a:rPr>
-              <a:t>03</a:t>
-            </a:r>
-          </a:p>
-        </p:txBody>
-      </p:sp>
-      <p:sp>
-        <p:nvSpPr>
-          <p:cNvPr id="9" name="">
-            <a:extLst xmlns:a="http://schemas.openxmlformats.org/drawingml/2006/main">
-              <a:ext uri="{FF2B5EF4-FFF2-40B4-BE49-F238E27FC236}">
-                <a16:creationId xmlns:a16="http://schemas.microsoft.com/office/drawing/2014/main" id="{E78D7242-CD9B-40E0-BAB6-2FA3C64E26F2}"/>
-              </a:ext>
-            </a:extLst>
-          </p:cNvPr>
-          <p:cNvSpPr>
-            <a:spLocks xmlns:a="http://schemas.openxmlformats.org/drawingml/2006/main" noGrp="1"/>
-          </p:cNvSpPr>
-          <p:nvPr/>
-        </p:nvSpPr>
-        <p:spPr>
-          <a:xfrm xmlns:a="http://schemas.openxmlformats.org/drawingml/2006/main">
-            <a:off x="1504950" y="3695700"/>
-            <a:ext cx="4191000" cy="438150"/>
-          </a:xfrm>
-          <a:prstGeom xmlns:a="http://schemas.openxmlformats.org/drawingml/2006/main" prst="rect">
-            <a:avLst/>
-          </a:prstGeom>
-          <a:noFill xmlns:a="http://schemas.openxmlformats.org/drawingml/2006/main"/>
-          <a:ln xmlns:a="http://schemas.openxmlformats.org/drawingml/2006/main" w="0">
-            <a:noFill/>
-          </a:ln>
-        </p:spPr>
-        <p:txBody>
-          <a:bodyPr xmlns:a="http://schemas.openxmlformats.org/drawingml/2006/main">
-            <a:noAutofit/>
-          </a:bodyPr>
-          <a:lstStyle xmlns:a="http://schemas.openxmlformats.org/drawingml/2006/main"/>
-          <a:p xmlns:a="http://schemas.openxmlformats.org/drawingml/2006/main">
-            <a:pPr>
-              <a:buNone/>
-              <a:defRPr sz="2250" b="1">
-                <a:solidFill>
-                  <a:srgbClr val="17302B"/>
-                </a:solidFill>
-                <a:latin typeface="Helvetica Neue"/>
-                <a:ea typeface="Helvetica Neue"/>
-                <a:cs typeface="Helvetica Neue"/>
-              </a:defRPr>
-            </a:pPr>
-            <a:r>
-              <a:rPr sz="2250" b="1">
-                <a:solidFill>
-                  <a:srgbClr val="17302B"/>
-                </a:solidFill>
-                <a:latin typeface="Helvetica Neue"/>
-                <a:ea typeface="Helvetica Neue"/>
-                <a:cs typeface="Helvetica Neue"/>
-              </a:rPr>
-              <a:t>Mint proof for one call</a:t>
-            </a:r>
-          </a:p>
-        </p:txBody>
-      </p:sp>
-      <p:sp>
-        <p:nvSpPr>
-          <p:cNvPr id="10" name="">
-            <a:extLst xmlns:a="http://schemas.openxmlformats.org/drawingml/2006/main">
-              <a:ext uri="{FF2B5EF4-FFF2-40B4-BE49-F238E27FC236}">
-                <a16:creationId xmlns:a16="http://schemas.microsoft.com/office/drawing/2014/main" id="{4139131E-4C54-496A-A498-8307D60AB572}"/>
-              </a:ext>
-            </a:extLst>
-          </p:cNvPr>
-          <p:cNvSpPr>
-            <a:spLocks xmlns:a="http://schemas.openxmlformats.org/drawingml/2006/main" noGrp="1"/>
-          </p:cNvSpPr>
-          <p:nvPr/>
-        </p:nvSpPr>
-        <p:spPr>
-          <a:xfrm xmlns:a="http://schemas.openxmlformats.org/drawingml/2006/main">
-            <a:off x="5962650" y="3695700"/>
-            <a:ext cx="5505450" cy="742950"/>
-          </a:xfrm>
-          <a:prstGeom xmlns:a="http://schemas.openxmlformats.org/drawingml/2006/main" prst="rect">
-            <a:avLst/>
-          </a:prstGeom>
-          <a:noFill xmlns:a="http://schemas.openxmlformats.org/drawingml/2006/main"/>
-          <a:ln xmlns:a="http://schemas.openxmlformats.org/drawingml/2006/main" w="0">
-            <a:noFill/>
-          </a:ln>
-        </p:spPr>
-        <p:txBody>
-          <a:bodyPr xmlns:a="http://schemas.openxmlformats.org/drawingml/2006/main">
-            <a:noAutofit/>
-          </a:bodyPr>
-          <a:lstStyle xmlns:a="http://schemas.openxmlformats.org/drawingml/2006/main"/>
-          <a:p xmlns:a="http://schemas.openxmlformats.org/drawingml/2006/main">
-            <a:pPr>
-              <a:buNone/>
-              <a:defRPr sz="2025" b="0">
-                <a:solidFill>
-                  <a:srgbClr val="17302B"/>
-                </a:solidFill>
-                <a:latin typeface="Helvetica Neue"/>
-                <a:ea typeface="Helvetica Neue"/>
-                <a:cs typeface="Helvetica Neue"/>
-              </a:defRPr>
-            </a:pPr>
-            <a:r>
-              <a:rPr sz="2025" b="0">
-                <a:solidFill>
-                  <a:srgbClr val="17302B"/>
-                </a:solidFill>
-                <a:latin typeface="Helvetica Neue"/>
-                <a:ea typeface="Helvetica Neue"/>
-                <a:cs typeface="Helvetica Neue"/>
-              </a:rPr>
-              <a:t>Policy rechecks live access and signs the operation and argument digest.</a:t>
-            </a:r>
-          </a:p>
-        </p:txBody>
-      </p:sp>
-      <p:sp>
-        <p:nvSpPr>
-          <p:cNvPr id="11" name="">
-            <a:extLst xmlns:a="http://schemas.openxmlformats.org/drawingml/2006/main">
-              <a:ext uri="{FF2B5EF4-FFF2-40B4-BE49-F238E27FC236}">
-                <a16:creationId xmlns:a16="http://schemas.microsoft.com/office/drawing/2014/main" id="{CE55CD08-B572-4016-BAAC-EBF090D60763}"/>
-              </a:ext>
-            </a:extLst>
-          </p:cNvPr>
-          <p:cNvSpPr>
-            <a:spLocks xmlns:a="http://schemas.openxmlformats.org/drawingml/2006/main" noGrp="1"/>
-          </p:cNvSpPr>
-          <p:nvPr/>
-        </p:nvSpPr>
-        <p:spPr>
-          <a:xfrm xmlns:a="http://schemas.openxmlformats.org/drawingml/2006/main">
-            <a:off x="609600" y="4695825"/>
-            <a:ext cx="609600" cy="457200"/>
-          </a:xfrm>
-          <a:prstGeom xmlns:a="http://schemas.openxmlformats.org/drawingml/2006/main" prst="rect">
-            <a:avLst/>
-          </a:prstGeom>
-          <a:noFill xmlns:a="http://schemas.openxmlformats.org/drawingml/2006/main"/>
-          <a:ln xmlns:a="http://schemas.openxmlformats.org/drawingml/2006/main" w="0">
-            <a:noFill/>
-          </a:ln>
-        </p:spPr>
-        <p:txBody>
-          <a:bodyPr xmlns:a="http://schemas.openxmlformats.org/drawingml/2006/main">
-            <a:noAutofit/>
-          </a:bodyPr>
-          <a:lstStyle xmlns:a="http://schemas.openxmlformats.org/drawingml/2006/main"/>
-          <a:p xmlns:a="http://schemas.openxmlformats.org/drawingml/2006/main">
-            <a:pPr>
-              <a:buNone/>
-              <a:defRPr sz="2550" b="1">
+              <a:t>Execution tokens expire within 60 seconds and are single-use.</a:t>
+            </a:r>
+          </a:p>
+          <a:p>
+            <a:pPr>
+              <a:buNone/>
+              <a:defRPr sz="1800" b="1">
                 <a:solidFill>
                   <a:srgbClr val="117C63"/>
                 </a:solidFill>
@@ -4632,7 +4568,7 @@
               </a:defRPr>
             </a:pPr>
             <a:r>
-              <a:rPr sz="2550" b="1">
+              <a:rPr sz="1800" b="1">
                 <a:solidFill>
                   <a:srgbClr val="117C63"/>
                 </a:solidFill>
@@ -4640,205 +4576,7 @@
                 <a:ea typeface="Helvetica Neue"/>
                 <a:cs typeface="Helvetica Neue"/>
               </a:rPr>
-              <a:t>04</a:t>
-            </a:r>
-          </a:p>
-        </p:txBody>
-      </p:sp>
-      <p:sp>
-        <p:nvSpPr>
-          <p:cNvPr id="12" name="">
-            <a:extLst xmlns:a="http://schemas.openxmlformats.org/drawingml/2006/main">
-              <a:ext uri="{FF2B5EF4-FFF2-40B4-BE49-F238E27FC236}">
-                <a16:creationId xmlns:a16="http://schemas.microsoft.com/office/drawing/2014/main" id="{DBCE0E39-8DEF-463F-ABBF-D3871AE8BE80}"/>
-              </a:ext>
-            </a:extLst>
-          </p:cNvPr>
-          <p:cNvSpPr>
-            <a:spLocks xmlns:a="http://schemas.openxmlformats.org/drawingml/2006/main" noGrp="1"/>
-          </p:cNvSpPr>
-          <p:nvPr/>
-        </p:nvSpPr>
-        <p:spPr>
-          <a:xfrm xmlns:a="http://schemas.openxmlformats.org/drawingml/2006/main">
-            <a:off x="1504950" y="4695825"/>
-            <a:ext cx="4191000" cy="438150"/>
-          </a:xfrm>
-          <a:prstGeom xmlns:a="http://schemas.openxmlformats.org/drawingml/2006/main" prst="rect">
-            <a:avLst/>
-          </a:prstGeom>
-          <a:noFill xmlns:a="http://schemas.openxmlformats.org/drawingml/2006/main"/>
-          <a:ln xmlns:a="http://schemas.openxmlformats.org/drawingml/2006/main" w="0">
-            <a:noFill/>
-          </a:ln>
-        </p:spPr>
-        <p:txBody>
-          <a:bodyPr xmlns:a="http://schemas.openxmlformats.org/drawingml/2006/main">
-            <a:noAutofit/>
-          </a:bodyPr>
-          <a:lstStyle xmlns:a="http://schemas.openxmlformats.org/drawingml/2006/main"/>
-          <a:p xmlns:a="http://schemas.openxmlformats.org/drawingml/2006/main">
-            <a:pPr>
-              <a:buNone/>
-              <a:defRPr sz="2250" b="1">
-                <a:solidFill>
-                  <a:srgbClr val="17302B"/>
-                </a:solidFill>
-                <a:latin typeface="Helvetica Neue"/>
-                <a:ea typeface="Helvetica Neue"/>
-                <a:cs typeface="Helvetica Neue"/>
-              </a:defRPr>
-            </a:pPr>
-            <a:r>
-              <a:rPr sz="2250" b="1">
-                <a:solidFill>
-                  <a:srgbClr val="17302B"/>
-                </a:solidFill>
-                <a:latin typeface="Helvetica Neue"/>
-                <a:ea typeface="Helvetica Neue"/>
-                <a:cs typeface="Helvetica Neue"/>
-              </a:rPr>
-              <a:t>Execute at the broker</a:t>
-            </a:r>
-          </a:p>
-        </p:txBody>
-      </p:sp>
-      <p:sp>
-        <p:nvSpPr>
-          <p:cNvPr id="13" name="">
-            <a:extLst xmlns:a="http://schemas.openxmlformats.org/drawingml/2006/main">
-              <a:ext uri="{FF2B5EF4-FFF2-40B4-BE49-F238E27FC236}">
-                <a16:creationId xmlns:a16="http://schemas.microsoft.com/office/drawing/2014/main" id="{DD270EE4-20E1-4407-92BE-AF8377BFDC37}"/>
-              </a:ext>
-            </a:extLst>
-          </p:cNvPr>
-          <p:cNvSpPr>
-            <a:spLocks xmlns:a="http://schemas.openxmlformats.org/drawingml/2006/main" noGrp="1"/>
-          </p:cNvSpPr>
-          <p:nvPr/>
-        </p:nvSpPr>
-        <p:spPr>
-          <a:xfrm xmlns:a="http://schemas.openxmlformats.org/drawingml/2006/main">
-            <a:off x="5962650" y="4695825"/>
-            <a:ext cx="5505450" cy="742950"/>
-          </a:xfrm>
-          <a:prstGeom xmlns:a="http://schemas.openxmlformats.org/drawingml/2006/main" prst="rect">
-            <a:avLst/>
-          </a:prstGeom>
-          <a:noFill xmlns:a="http://schemas.openxmlformats.org/drawingml/2006/main"/>
-          <a:ln xmlns:a="http://schemas.openxmlformats.org/drawingml/2006/main" w="0">
-            <a:noFill/>
-          </a:ln>
-        </p:spPr>
-        <p:txBody>
-          <a:bodyPr xmlns:a="http://schemas.openxmlformats.org/drawingml/2006/main">
-            <a:noAutofit/>
-          </a:bodyPr>
-          <a:lstStyle xmlns:a="http://schemas.openxmlformats.org/drawingml/2006/main"/>
-          <a:p xmlns:a="http://schemas.openxmlformats.org/drawingml/2006/main">
-            <a:pPr>
-              <a:buNone/>
-              <a:defRPr sz="2025" b="0">
-                <a:solidFill>
-                  <a:srgbClr val="17302B"/>
-                </a:solidFill>
-                <a:latin typeface="Helvetica Neue"/>
-                <a:ea typeface="Helvetica Neue"/>
-                <a:cs typeface="Helvetica Neue"/>
-              </a:defRPr>
-            </a:pPr>
-            <a:r>
-              <a:rPr sz="2025" b="0">
-                <a:solidFill>
-                  <a:srgbClr val="17302B"/>
-                </a:solidFill>
-                <a:latin typeface="Helvetica Neue"/>
-                <a:ea typeface="Helvetica Neue"/>
-                <a:cs typeface="Helvetica Neue"/>
-              </a:rPr>
-              <a:t>The broker verifies the proof, loads the secret and calls the provider.</a:t>
-            </a:r>
-          </a:p>
-        </p:txBody>
-      </p:sp>
-      <p:sp>
-        <p:nvSpPr>
-          <p:cNvPr id="14" name="">
-            <a:extLst xmlns:a="http://schemas.openxmlformats.org/drawingml/2006/main">
-              <a:ext uri="{FF2B5EF4-FFF2-40B4-BE49-F238E27FC236}">
-                <a16:creationId xmlns:a16="http://schemas.microsoft.com/office/drawing/2014/main" id="{2C561353-C2AA-4DF1-9605-1422C26A5363}"/>
-              </a:ext>
-            </a:extLst>
-          </p:cNvPr>
-          <p:cNvSpPr>
-            <a:spLocks xmlns:a="http://schemas.openxmlformats.org/drawingml/2006/main" noGrp="1"/>
-          </p:cNvSpPr>
-          <p:nvPr/>
-        </p:nvSpPr>
-        <p:spPr>
-          <a:xfrm xmlns:a="http://schemas.openxmlformats.org/drawingml/2006/main">
-            <a:off x="1504950" y="5715000"/>
-            <a:ext cx="9620250" cy="762000"/>
-          </a:xfrm>
-          <a:prstGeom xmlns:a="http://schemas.openxmlformats.org/drawingml/2006/main" prst="rect">
-            <a:avLst/>
-          </a:prstGeom>
-          <a:noFill xmlns:a="http://schemas.openxmlformats.org/drawingml/2006/main"/>
-          <a:ln xmlns:a="http://schemas.openxmlformats.org/drawingml/2006/main" w="0">
-            <a:noFill/>
-          </a:ln>
-        </p:spPr>
-        <p:txBody>
-          <a:bodyPr xmlns:a="http://schemas.openxmlformats.org/drawingml/2006/main">
-            <a:noAutofit/>
-          </a:bodyPr>
-          <a:lstStyle xmlns:a="http://schemas.openxmlformats.org/drawingml/2006/main"/>
-          <a:p xmlns:a="http://schemas.openxmlformats.org/drawingml/2006/main">
-            <a:pPr>
-              <a:buNone/>
-              <a:defRPr sz="1875" b="1">
-                <a:solidFill>
-                  <a:srgbClr val="117C63"/>
-                </a:solidFill>
-                <a:latin typeface="Helvetica Neue"/>
-                <a:ea typeface="Helvetica Neue"/>
-                <a:cs typeface="Helvetica Neue"/>
-              </a:defRPr>
-            </a:pPr>
-            <a:r>
-              <a:rPr sz="1875" b="1">
-                <a:solidFill>
-                  <a:srgbClr val="117C63"/>
-                </a:solidFill>
-                <a:latin typeface="Helvetica Neue"/>
-                <a:ea typeface="Helvetica Neue"/>
-                <a:cs typeface="Helvetica Neue"/>
-              </a:rPr>
-              <a:t>Short-lived tokens limit exposure.</a:t>
-            </a:r>
-          </a:p>
-          <a:p xmlns:a="http://schemas.openxmlformats.org/drawingml/2006/main">
-            <a:pPr>
-              <a:buNone/>
-              <a:defRPr sz="1875" b="1">
-                <a:solidFill>
-                  <a:srgbClr val="117C63"/>
-                </a:solidFill>
-                <a:latin typeface="Helvetica Neue"/>
-                <a:ea typeface="Helvetica Neue"/>
-                <a:cs typeface="Helvetica Neue"/>
-              </a:defRPr>
-            </a:pPr>
-            <a:r>
-              <a:rPr sz="1875" b="1">
-                <a:solidFill>
-                  <a:srgbClr val="117C63"/>
-                </a:solidFill>
-                <a:latin typeface="Helvetica Neue"/>
-                <a:ea typeface="Helvetica Neue"/>
-                <a:cs typeface="Helvetica Neue"/>
-              </a:rPr>
-              <a:t>Each execution token expires within 60 seconds and works once.</a:t>
+              <a:t>Receipts prevent repeat writes on retries. Outcomes may be partial or uncertain.</a:t>
             </a:r>
           </a:p>
         </p:txBody>
@@ -4899,12 +4637,12 @@
             <a:noFill/>
           </a:ln>
         </p:spPr>
-        <p:txBody>
-          <a:bodyPr xmlns:a="http://schemas.openxmlformats.org/drawingml/2006/main">
-            <a:noAutofit/>
-          </a:bodyPr>
-          <a:lstStyle xmlns:a="http://schemas.openxmlformats.org/drawingml/2006/main"/>
-          <a:p xmlns:a="http://schemas.openxmlformats.org/drawingml/2006/main">
+        <p:txBody xmlns:a="http://schemas.openxmlformats.org/drawingml/2006/main">
+          <a:bodyPr wrap="square">
+            <a:noAutofit/>
+          </a:bodyPr>
+          <a:lstStyle/>
+          <a:p>
             <a:pPr>
               <a:buNone/>
               <a:defRPr sz="3300" b="1">
@@ -4925,7 +4663,7 @@
                 <a:ea typeface="Helvetica Neue"/>
                 <a:cs typeface="Helvetica Neue"/>
               </a:rPr>
-              <a:t>Why check twice?</a:t>
+              <a:t>Admission and live authorization</a:t>
             </a:r>
           </a:p>
         </p:txBody>
@@ -4957,12 +4695,12 @@
             <a:noFill/>
           </a:ln>
         </p:spPr>
-        <p:txBody>
-          <a:bodyPr xmlns:a="http://schemas.openxmlformats.org/drawingml/2006/main">
-            <a:noAutofit/>
-          </a:bodyPr>
-          <a:lstStyle xmlns:a="http://schemas.openxmlformats.org/drawingml/2006/main"/>
-          <a:p xmlns:a="http://schemas.openxmlformats.org/drawingml/2006/main">
+        <p:txBody xmlns:a="http://schemas.openxmlformats.org/drawingml/2006/main">
+          <a:bodyPr wrap="square">
+            <a:noAutofit/>
+          </a:bodyPr>
+          <a:lstStyle/>
+          <a:p>
             <a:pPr>
               <a:buNone/>
               <a:defRPr sz="2550" b="1">
@@ -4983,7 +4721,7 @@
                 <a:ea typeface="Helvetica Neue"/>
                 <a:cs typeface="Helvetica Neue"/>
               </a:rPr>
-              <a:t>Before execution</a:t>
+              <a:t>Before any stage runs</a:t>
             </a:r>
           </a:p>
         </p:txBody>
@@ -5005,22 +4743,22 @@
         <p:spPr>
           <a:xfrm xmlns:a="http://schemas.openxmlformats.org/drawingml/2006/main">
             <a:off x="609600" y="2428875"/>
-            <a:ext cx="4905375" cy="1190625"/>
-          </a:xfrm>
-          <a:prstGeom xmlns:a="http://schemas.openxmlformats.org/drawingml/2006/main" prst="rect">
-            <a:avLst/>
-          </a:prstGeom>
-          <a:noFill xmlns:a="http://schemas.openxmlformats.org/drawingml/2006/main"/>
-          <a:ln xmlns:a="http://schemas.openxmlformats.org/drawingml/2006/main" w="0">
-            <a:noFill/>
-          </a:ln>
-        </p:spPr>
-        <p:txBody>
-          <a:bodyPr xmlns:a="http://schemas.openxmlformats.org/drawingml/2006/main">
-            <a:noAutofit/>
-          </a:bodyPr>
-          <a:lstStyle xmlns:a="http://schemas.openxmlformats.org/drawingml/2006/main"/>
-          <a:p xmlns:a="http://schemas.openxmlformats.org/drawingml/2006/main">
+            <a:ext cx="4905375" cy="1381125"/>
+          </a:xfrm>
+          <a:prstGeom xmlns:a="http://schemas.openxmlformats.org/drawingml/2006/main" prst="rect">
+            <a:avLst/>
+          </a:prstGeom>
+          <a:noFill xmlns:a="http://schemas.openxmlformats.org/drawingml/2006/main"/>
+          <a:ln xmlns:a="http://schemas.openxmlformats.org/drawingml/2006/main" w="0">
+            <a:noFill/>
+          </a:ln>
+        </p:spPr>
+        <p:txBody xmlns:a="http://schemas.openxmlformats.org/drawingml/2006/main">
+          <a:bodyPr wrap="square">
+            <a:noAutofit/>
+          </a:bodyPr>
+          <a:lstStyle/>
+          <a:p>
             <a:pPr>
               <a:buNone/>
               <a:defRPr sz="2400" b="0">
@@ -5041,7 +4779,7 @@
                 <a:ea typeface="Helvetica Neue"/>
                 <a:cs typeface="Helvetica Neue"/>
               </a:rPr>
-              <a:t>Admission checks the entire program against one permission snapshot.</a:t>
+              <a:t>Policy admits every stage against one consistent permission snapshot.</a:t>
             </a:r>
           </a:p>
         </p:txBody>
@@ -5063,22 +4801,22 @@
         <p:spPr>
           <a:xfrm xmlns:a="http://schemas.openxmlformats.org/drawingml/2006/main">
             <a:off x="609600" y="4057650"/>
-            <a:ext cx="4905375" cy="1104900"/>
-          </a:xfrm>
-          <a:prstGeom xmlns:a="http://schemas.openxmlformats.org/drawingml/2006/main" prst="rect">
-            <a:avLst/>
-          </a:prstGeom>
-          <a:noFill xmlns:a="http://schemas.openxmlformats.org/drawingml/2006/main"/>
-          <a:ln xmlns:a="http://schemas.openxmlformats.org/drawingml/2006/main" w="0">
-            <a:noFill/>
-          </a:ln>
-        </p:spPr>
-        <p:txBody>
-          <a:bodyPr xmlns:a="http://schemas.openxmlformats.org/drawingml/2006/main">
-            <a:noAutofit/>
-          </a:bodyPr>
-          <a:lstStyle xmlns:a="http://schemas.openxmlformats.org/drawingml/2006/main"/>
-          <a:p xmlns:a="http://schemas.openxmlformats.org/drawingml/2006/main">
+            <a:ext cx="4905375" cy="1381125"/>
+          </a:xfrm>
+          <a:prstGeom xmlns:a="http://schemas.openxmlformats.org/drawingml/2006/main" prst="rect">
+            <a:avLst/>
+          </a:prstGeom>
+          <a:noFill xmlns:a="http://schemas.openxmlformats.org/drawingml/2006/main"/>
+          <a:ln xmlns:a="http://schemas.openxmlformats.org/drawingml/2006/main" w="0">
+            <a:noFill/>
+          </a:ln>
+        </p:spPr>
+        <p:txBody xmlns:a="http://schemas.openxmlformats.org/drawingml/2006/main">
+          <a:bodyPr wrap="square">
+            <a:noAutofit/>
+          </a:bodyPr>
+          <a:lstStyle/>
+          <a:p>
             <a:pPr>
               <a:buNone/>
               <a:defRPr sz="2100" b="0">
@@ -5099,7 +4837,31 @@
                 <a:ea typeface="Helvetica Neue"/>
                 <a:cs typeface="Helvetica Neue"/>
               </a:rPr>
-              <a:t>This catches a later denied function before earlier API calls begin.</a:t>
+              <a:t>A denied stage blocks the whole run.</a:t>
+            </a:r>
+          </a:p>
+          <a:p>
+            <a:pPr>
+              <a:buNone/>
+              <a:defRPr sz="2100" b="0">
+                <a:solidFill>
+                  <a:srgbClr val="53645D"/>
+                </a:solidFill>
+                <a:latin typeface="Helvetica Neue"/>
+                <a:ea typeface="Helvetica Neue"/>
+                <a:cs typeface="Helvetica Neue"/>
+              </a:defRPr>
+            </a:pPr>
+            <a:r>
+              <a:rPr sz="2100" b="0">
+                <a:solidFill>
+                  <a:srgbClr val="53645D"/>
+                </a:solidFill>
+                <a:latin typeface="Helvetica Neue"/>
+                <a:ea typeface="Helvetica Neue"/>
+                <a:cs typeface="Helvetica Neue"/>
+              </a:rPr>
+              <a:t>External writes are not atomic.</a:t>
             </a:r>
           </a:p>
         </p:txBody>
@@ -5131,12 +4893,12 @@
             <a:noFill/>
           </a:ln>
         </p:spPr>
-        <p:txBody>
-          <a:bodyPr xmlns:a="http://schemas.openxmlformats.org/drawingml/2006/main">
-            <a:noAutofit/>
-          </a:bodyPr>
-          <a:lstStyle xmlns:a="http://schemas.openxmlformats.org/drawingml/2006/main"/>
-          <a:p xmlns:a="http://schemas.openxmlformats.org/drawingml/2006/main">
+        <p:txBody xmlns:a="http://schemas.openxmlformats.org/drawingml/2006/main">
+          <a:bodyPr wrap="square">
+            <a:noAutofit/>
+          </a:bodyPr>
+          <a:lstStyle/>
+          <a:p>
             <a:pPr>
               <a:buNone/>
               <a:defRPr sz="2550" b="1">
@@ -5157,7 +4919,7 @@
                 <a:ea typeface="Helvetica Neue"/>
                 <a:cs typeface="Helvetica Neue"/>
               </a:rPr>
-              <a:t>At each protected call</a:t>
+              <a:t>Before each effect</a:t>
             </a:r>
           </a:p>
         </p:txBody>
@@ -5189,12 +4951,12 @@
             <a:noFill/>
           </a:ln>
         </p:spPr>
-        <p:txBody>
-          <a:bodyPr xmlns:a="http://schemas.openxmlformats.org/drawingml/2006/main">
-            <a:noAutofit/>
-          </a:bodyPr>
-          <a:lstStyle xmlns:a="http://schemas.openxmlformats.org/drawingml/2006/main"/>
-          <a:p xmlns:a="http://schemas.openxmlformats.org/drawingml/2006/main">
+        <p:txBody xmlns:a="http://schemas.openxmlformats.org/drawingml/2006/main">
+          <a:bodyPr wrap="square">
+            <a:noAutofit/>
+          </a:bodyPr>
+          <a:lstStyle/>
+          <a:p>
             <a:pPr>
               <a:buNone/>
               <a:defRPr sz="2400" b="0">
@@ -5215,7 +4977,7 @@
                 <a:ea typeface="Helvetica Neue"/>
                 <a:cs typeface="Helvetica Neue"/>
               </a:rPr>
-              <a:t>Policy checks live access. The broker checks the exact operation and payload.</a:t>
+              <a:t>Broker asks Policy again before every provider request or signature.</a:t>
             </a:r>
           </a:p>
         </p:txBody>
@@ -5237,22 +4999,22 @@
         <p:spPr>
           <a:xfrm xmlns:a="http://schemas.openxmlformats.org/drawingml/2006/main">
             <a:off x="6477000" y="4057650"/>
-            <a:ext cx="4953000" cy="1104900"/>
-          </a:xfrm>
-          <a:prstGeom xmlns:a="http://schemas.openxmlformats.org/drawingml/2006/main" prst="rect">
-            <a:avLst/>
-          </a:prstGeom>
-          <a:noFill xmlns:a="http://schemas.openxmlformats.org/drawingml/2006/main"/>
-          <a:ln xmlns:a="http://schemas.openxmlformats.org/drawingml/2006/main" w="0">
-            <a:noFill/>
-          </a:ln>
-        </p:spPr>
-        <p:txBody>
-          <a:bodyPr xmlns:a="http://schemas.openxmlformats.org/drawingml/2006/main">
-            <a:noAutofit/>
-          </a:bodyPr>
-          <a:lstStyle xmlns:a="http://schemas.openxmlformats.org/drawingml/2006/main"/>
-          <a:p xmlns:a="http://schemas.openxmlformats.org/drawingml/2006/main">
+            <a:ext cx="4953000" cy="1428750"/>
+          </a:xfrm>
+          <a:prstGeom xmlns:a="http://schemas.openxmlformats.org/drawingml/2006/main" prst="rect">
+            <a:avLst/>
+          </a:prstGeom>
+          <a:noFill xmlns:a="http://schemas.openxmlformats.org/drawingml/2006/main"/>
+          <a:ln xmlns:a="http://schemas.openxmlformats.org/drawingml/2006/main" w="0">
+            <a:noFill/>
+          </a:ln>
+        </p:spPr>
+        <p:txBody xmlns:a="http://schemas.openxmlformats.org/drawingml/2006/main">
+          <a:bodyPr wrap="square">
+            <a:noAutofit/>
+          </a:bodyPr>
+          <a:lstStyle/>
+          <a:p>
             <a:pPr>
               <a:buNone/>
               <a:defRPr sz="2100" b="0">
@@ -5273,7 +5035,65 @@
                 <a:ea typeface="Helvetica Neue"/>
                 <a:cs typeface="Helvetica Neue"/>
               </a:rPr>
-              <a:t>This limits stale permissions and prevents a token from authorizing different arguments.</a:t>
+              <a:t>Revocation before the check blocks authorization. Dispatched effects may finish.</a:t>
+            </a:r>
+          </a:p>
+        </p:txBody>
+      </p:sp>
+      <p:sp>
+        <p:nvSpPr>
+          <p:cNvPr id="30" name="">
+            <a:extLst xmlns:a="http://schemas.openxmlformats.org/drawingml/2006/main">
+              <a:ext uri="{FF2B5EF4-FFF2-40B4-BE49-F238E27FC236}">
+                <a16:creationId xmlns:a16="http://schemas.microsoft.com/office/drawing/2014/main" id="{5CECE574-2B5A-469A-91B3-3DDD65EBA747}"/>
+              </a:ext>
+            </a:extLst>
+          </p:cNvPr>
+          <p:cNvSpPr>
+            <a:spLocks xmlns:a="http://schemas.openxmlformats.org/drawingml/2006/main" noGrp="1"/>
+          </p:cNvSpPr>
+          <p:nvPr/>
+        </p:nvSpPr>
+        <p:spPr>
+          <a:xfrm xmlns:a="http://schemas.openxmlformats.org/drawingml/2006/main">
+            <a:off x="609600" y="6000750"/>
+            <a:ext cx="10858500" cy="571500"/>
+          </a:xfrm>
+          <a:prstGeom xmlns:a="http://schemas.openxmlformats.org/drawingml/2006/main" prst="rect">
+            <a:avLst/>
+          </a:prstGeom>
+          <a:noFill xmlns:a="http://schemas.openxmlformats.org/drawingml/2006/main"/>
+          <a:ln xmlns:a="http://schemas.openxmlformats.org/drawingml/2006/main" w="0">
+            <a:noFill/>
+          </a:ln>
+        </p:spPr>
+        <p:txBody xmlns:a="http://schemas.openxmlformats.org/drawingml/2006/main">
+          <a:bodyPr wrap="square">
+            <a:noAutofit/>
+          </a:bodyPr>
+          <a:lstStyle/>
+          <a:p>
+            <a:pPr>
+              <a:buNone/>
+              <a:defRPr sz="1650" b="0">
+                <a:solidFill>
+                  <a:srgbClr val="56645F"/>
+                </a:solidFill>
+                <a:latin typeface="Helvetica Neue"/>
+                <a:ea typeface="Helvetica Neue"/>
+                <a:cs typeface="Helvetica Neue"/>
+              </a:defRPr>
+            </a:pPr>
+            <a:r>
+              <a:rPr sz="1650" b="0">
+                <a:solidFill>
+                  <a:srgbClr val="56645F"/>
+                </a:solidFill>
+                <a:latin typeface="Helvetica Neue"/>
+                <a:ea typeface="Helvetica Neue"/>
+                <a:cs typeface="Helvetica Neue"/>
+              </a:rPr>
+              <a:t>Issued browser sessions follow the provider’s documented lifetime and revocation rules.</a:t>
             </a:r>
           </a:p>
         </p:txBody>
@@ -5782,23 +5602,23 @@
         </p:nvSpPr>
         <p:spPr>
           <a:xfrm xmlns:a="http://schemas.openxmlformats.org/drawingml/2006/main">
-            <a:off x="609600" y="6000750"/>
-            <a:ext cx="10477500" cy="352425"/>
-          </a:xfrm>
-          <a:prstGeom xmlns:a="http://schemas.openxmlformats.org/drawingml/2006/main" prst="rect">
-            <a:avLst/>
-          </a:prstGeom>
-          <a:noFill xmlns:a="http://schemas.openxmlformats.org/drawingml/2006/main"/>
-          <a:ln xmlns:a="http://schemas.openxmlformats.org/drawingml/2006/main" w="0">
-            <a:noFill/>
-          </a:ln>
-        </p:spPr>
-        <p:txBody>
-          <a:bodyPr xmlns:a="http://schemas.openxmlformats.org/drawingml/2006/main">
-            <a:noAutofit/>
-          </a:bodyPr>
-          <a:lstStyle xmlns:a="http://schemas.openxmlformats.org/drawingml/2006/main"/>
-          <a:p xmlns:a="http://schemas.openxmlformats.org/drawingml/2006/main">
+            <a:off x="609600" y="5857875"/>
+            <a:ext cx="10820400" cy="742950"/>
+          </a:xfrm>
+          <a:prstGeom xmlns:a="http://schemas.openxmlformats.org/drawingml/2006/main" prst="rect">
+            <a:avLst/>
+          </a:prstGeom>
+          <a:noFill xmlns:a="http://schemas.openxmlformats.org/drawingml/2006/main"/>
+          <a:ln xmlns:a="http://schemas.openxmlformats.org/drawingml/2006/main" w="0">
+            <a:noFill/>
+          </a:ln>
+        </p:spPr>
+        <p:txBody xmlns:a="http://schemas.openxmlformats.org/drawingml/2006/main">
+          <a:bodyPr wrap="square">
+            <a:noAutofit/>
+          </a:bodyPr>
+          <a:lstStyle/>
+          <a:p>
             <a:pPr>
               <a:buNone/>
               <a:defRPr sz="1650" b="0">
@@ -5819,7 +5639,31 @@
                 <a:ea typeface="Helvetica Neue"/>
                 <a:cs typeface="Helvetica Neue"/>
               </a:rPr>
-              <a:t>Current scope is a function on a connection. Grants do not yet restrict individual items.</a:t>
+              <a:t>Grants cover functions on a connection, not individual items.</a:t>
+            </a:r>
+          </a:p>
+          <a:p>
+            <a:pPr>
+              <a:buNone/>
+              <a:defRPr sz="1650" b="0">
+                <a:solidFill>
+                  <a:srgbClr val="53645D"/>
+                </a:solidFill>
+                <a:latin typeface="Helvetica Neue"/>
+                <a:ea typeface="Helvetica Neue"/>
+                <a:cs typeface="Helvetica Neue"/>
+              </a:defRPr>
+            </a:pPr>
+            <a:r>
+              <a:rPr sz="1650" b="0">
+                <a:solidFill>
+                  <a:srgbClr val="53645D"/>
+                </a:solidFill>
+                <a:latin typeface="Helvetica Neue"/>
+                <a:ea typeface="Helvetica Neue"/>
+                <a:cs typeface="Helvetica Neue"/>
+              </a:rPr>
+              <a:t>Author signing stays disabled until provider validation passes, including for owners.</a:t>
             </a:r>
           </a:p>
         </p:txBody>
@@ -5880,12 +5724,12 @@
             <a:noFill/>
           </a:ln>
         </p:spPr>
-        <p:txBody>
-          <a:bodyPr xmlns:a="http://schemas.openxmlformats.org/drawingml/2006/main">
-            <a:noAutofit/>
-          </a:bodyPr>
-          <a:lstStyle xmlns:a="http://schemas.openxmlformats.org/drawingml/2006/main"/>
-          <a:p xmlns:a="http://schemas.openxmlformats.org/drawingml/2006/main">
+        <p:txBody xmlns:a="http://schemas.openxmlformats.org/drawingml/2006/main">
+          <a:bodyPr wrap="square">
+            <a:noAutofit/>
+          </a:bodyPr>
+          <a:lstStyle/>
+          <a:p>
             <a:pPr>
               <a:buNone/>
               <a:defRPr sz="3300" b="1">
@@ -5906,7 +5750,7 @@
                 <a:ea typeface="Helvetica Neue"/>
                 <a:cs typeface="Helvetica Neue"/>
               </a:rPr>
-              <a:t>Graffiticode security model</a:t>
+              <a:t>Enforced security boundaries</a:t>
             </a:r>
           </a:p>
         </p:txBody>
@@ -5938,12 +5782,12 @@
             <a:noFill/>
           </a:ln>
         </p:spPr>
-        <p:txBody>
-          <a:bodyPr xmlns:a="http://schemas.openxmlformats.org/drawingml/2006/main">
-            <a:noAutofit/>
-          </a:bodyPr>
-          <a:lstStyle xmlns:a="http://schemas.openxmlformats.org/drawingml/2006/main"/>
-          <a:p xmlns:a="http://schemas.openxmlformats.org/drawingml/2006/main">
+        <p:txBody xmlns:a="http://schemas.openxmlformats.org/drawingml/2006/main">
+          <a:bodyPr wrap="square">
+            <a:noAutofit/>
+          </a:bodyPr>
+          <a:lstStyle/>
+          <a:p>
             <a:pPr>
               <a:buNone/>
               <a:defRPr sz="2250" b="0">
@@ -5964,7 +5808,7 @@
                 <a:ea typeface="Helvetica Neue"/>
                 <a:cs typeface="Helvetica Neue"/>
               </a:rPr>
-              <a:t>Owners control access. Policy scopes authority. The broker enforces it.</a:t>
+              <a:t>The gateway coordinates admission. Broker enforces each operation.</a:t>
             </a:r>
           </a:p>
         </p:txBody>
@@ -6107,26 +5951,26 @@
         </p:nvSpPr>
         <p:spPr>
           <a:xfrm xmlns:a="http://schemas.openxmlformats.org/drawingml/2006/main">
-            <a:off x="752475" y="3810000"/>
-            <a:ext cx="1905000" cy="723900"/>
-          </a:xfrm>
-          <a:prstGeom xmlns:a="http://schemas.openxmlformats.org/drawingml/2006/main" prst="rect">
-            <a:avLst/>
-          </a:prstGeom>
-          <a:noFill xmlns:a="http://schemas.openxmlformats.org/drawingml/2006/main"/>
-          <a:ln xmlns:a="http://schemas.openxmlformats.org/drawingml/2006/main" w="0">
-            <a:noFill/>
-          </a:ln>
-        </p:spPr>
-        <p:txBody>
-          <a:bodyPr xmlns:a="http://schemas.openxmlformats.org/drawingml/2006/main">
-            <a:noAutofit/>
-          </a:bodyPr>
-          <a:lstStyle xmlns:a="http://schemas.openxmlformats.org/drawingml/2006/main"/>
-          <a:p xmlns:a="http://schemas.openxmlformats.org/drawingml/2006/main">
-            <a:pPr>
-              <a:buNone/>
-              <a:defRPr sz="2100" b="1">
+            <a:off x="752475" y="3714750"/>
+            <a:ext cx="1952625" cy="781050"/>
+          </a:xfrm>
+          <a:prstGeom xmlns:a="http://schemas.openxmlformats.org/drawingml/2006/main" prst="rect">
+            <a:avLst/>
+          </a:prstGeom>
+          <a:noFill xmlns:a="http://schemas.openxmlformats.org/drawingml/2006/main"/>
+          <a:ln xmlns:a="http://schemas.openxmlformats.org/drawingml/2006/main" w="0">
+            <a:noFill/>
+          </a:ln>
+        </p:spPr>
+        <p:txBody xmlns:a="http://schemas.openxmlformats.org/drawingml/2006/main">
+          <a:bodyPr wrap="square">
+            <a:noAutofit/>
+          </a:bodyPr>
+          <a:lstStyle/>
+          <a:p>
+            <a:pPr>
+              <a:buNone/>
+              <a:defRPr sz="2000" b="1">
                 <a:solidFill>
                   <a:srgbClr val="FFFFFF"/>
                 </a:solidFill>
@@ -6136,7 +5980,7 @@
               </a:defRPr>
             </a:pPr>
             <a:r>
-              <a:rPr sz="2100" b="1">
+              <a:rPr sz="2000" b="1">
                 <a:solidFill>
                   <a:srgbClr val="FFFFFF"/>
                 </a:solidFill>
@@ -6144,7 +5988,31 @@
                 <a:ea typeface="Helvetica Neue"/>
                 <a:cs typeface="Helvetica Neue"/>
               </a:rPr>
-              <a:t>Compiler</a:t>
+              <a:t>Gateway +</a:t>
+            </a:r>
+          </a:p>
+          <a:p>
+            <a:pPr>
+              <a:buNone/>
+              <a:defRPr sz="2000" b="1">
+                <a:solidFill>
+                  <a:srgbClr val="FFFFFF"/>
+                </a:solidFill>
+                <a:latin typeface="Helvetica Neue"/>
+                <a:ea typeface="Helvetica Neue"/>
+                <a:cs typeface="Helvetica Neue"/>
+              </a:defRPr>
+            </a:pPr>
+            <a:r>
+              <a:rPr sz="2000" b="1">
+                <a:solidFill>
+                  <a:srgbClr val="FFFFFF"/>
+                </a:solidFill>
+                <a:latin typeface="Helvetica Neue"/>
+                <a:ea typeface="Helvetica Neue"/>
+                <a:cs typeface="Helvetica Neue"/>
+              </a:rPr>
+              <a:t>compilers</a:t>
             </a:r>
           </a:p>
         </p:txBody>
@@ -6490,6 +6358,7 @@
             <a:solidFill>
               <a:srgbClr val="A7E1C7"/>
             </a:solidFill>
+            <a:headEnd type="triangle" w="med" len="med"/>
             <a:tailEnd type="triangle" w="med" len="med"/>
           </a:ln>
         </p:spPr>
@@ -6604,12 +6473,12 @@
             <a:noFill/>
           </a:ln>
         </p:spPr>
-        <p:txBody>
-          <a:bodyPr xmlns:a="http://schemas.openxmlformats.org/drawingml/2006/main">
-            <a:noAutofit/>
-          </a:bodyPr>
-          <a:lstStyle xmlns:a="http://schemas.openxmlformats.org/drawingml/2006/main"/>
-          <a:p xmlns:a="http://schemas.openxmlformats.org/drawingml/2006/main">
+        <p:txBody xmlns:a="http://schemas.openxmlformats.org/drawingml/2006/main">
+          <a:bodyPr wrap="square">
+            <a:noAutofit/>
+          </a:bodyPr>
+          <a:lstStyle/>
+          <a:p>
             <a:pPr>
               <a:buNone/>
               <a:defRPr sz="1800" b="0">
@@ -6630,10 +6499,10 @@
                 <a:ea typeface="Helvetica Neue"/>
                 <a:cs typeface="Helvetica Neue"/>
               </a:rPr>
-              <a:t>Checks the program</a:t>
-            </a:r>
-          </a:p>
-          <a:p xmlns:a="http://schemas.openxmlformats.org/drawingml/2006/main">
+              <a:t>Preflight all stages</a:t>
+            </a:r>
+          </a:p>
+          <a:p>
             <a:pPr>
               <a:buNone/>
               <a:defRPr sz="1800" b="0">
@@ -6654,7 +6523,7 @@
                 <a:ea typeface="Helvetica Neue"/>
                 <a:cs typeface="Helvetica Neue"/>
               </a:rPr>
-              <a:t>before execution</a:t>
+              <a:t>and bind the plan</a:t>
             </a:r>
           </a:p>
         </p:txBody>
@@ -6686,12 +6555,12 @@
             <a:noFill/>
           </a:ln>
         </p:spPr>
-        <p:txBody>
-          <a:bodyPr xmlns:a="http://schemas.openxmlformats.org/drawingml/2006/main">
-            <a:noAutofit/>
-          </a:bodyPr>
-          <a:lstStyle xmlns:a="http://schemas.openxmlformats.org/drawingml/2006/main"/>
-          <a:p xmlns:a="http://schemas.openxmlformats.org/drawingml/2006/main">
+        <p:txBody xmlns:a="http://schemas.openxmlformats.org/drawingml/2006/main">
+          <a:bodyPr wrap="square">
+            <a:noAutofit/>
+          </a:bodyPr>
+          <a:lstStyle/>
+          <a:p>
             <a:pPr>
               <a:buNone/>
               <a:defRPr sz="1800" b="0">
@@ -6712,10 +6581,10 @@
                 <a:ea typeface="Helvetica Neue"/>
                 <a:cs typeface="Helvetica Neue"/>
               </a:rPr>
-              <a:t>Checks live grants</a:t>
-            </a:r>
-          </a:p>
-          <a:p xmlns:a="http://schemas.openxmlformats.org/drawingml/2006/main">
+              <a:t>Admit the chain</a:t>
+            </a:r>
+          </a:p>
+          <a:p>
             <a:pPr>
               <a:buNone/>
               <a:defRPr sz="1800" b="0">
@@ -6736,7 +6605,7 @@
                 <a:ea typeface="Helvetica Neue"/>
                 <a:cs typeface="Helvetica Neue"/>
               </a:rPr>
-              <a:t>and mints a call token</a:t>
+              <a:t>and check live access</a:t>
             </a:r>
           </a:p>
         </p:txBody>
@@ -6768,12 +6637,12 @@
             <a:noFill/>
           </a:ln>
         </p:spPr>
-        <p:txBody>
-          <a:bodyPr xmlns:a="http://schemas.openxmlformats.org/drawingml/2006/main">
-            <a:noAutofit/>
-          </a:bodyPr>
-          <a:lstStyle xmlns:a="http://schemas.openxmlformats.org/drawingml/2006/main"/>
-          <a:p xmlns:a="http://schemas.openxmlformats.org/drawingml/2006/main">
+        <p:txBody xmlns:a="http://schemas.openxmlformats.org/drawingml/2006/main">
+          <a:bodyPr wrap="square">
+            <a:noAutofit/>
+          </a:bodyPr>
+          <a:lstStyle/>
+          <a:p>
             <a:pPr>
               <a:buNone/>
               <a:defRPr sz="1800" b="0">
@@ -6794,10 +6663,10 @@
                 <a:ea typeface="Helvetica Neue"/>
                 <a:cs typeface="Helvetica Neue"/>
               </a:rPr>
-              <a:t>Verifies the token</a:t>
-            </a:r>
-          </a:p>
-          <a:p xmlns:a="http://schemas.openxmlformats.org/drawingml/2006/main">
+              <a:t>Verify proof and</a:t>
+            </a:r>
+          </a:p>
+          <a:p>
             <a:pPr>
               <a:buNone/>
               <a:defRPr sz="1800" b="0">
@@ -6818,7 +6687,7 @@
                 <a:ea typeface="Helvetica Neue"/>
                 <a:cs typeface="Helvetica Neue"/>
               </a:rPr>
-              <a:t>and holds the key</a:t>
+              <a:t>recheck each effect</a:t>
             </a:r>
           </a:p>
         </p:txBody>
@@ -6850,15 +6719,15 @@
             <a:noFill/>
           </a:ln>
         </p:spPr>
-        <p:txBody>
-          <a:bodyPr xmlns:a="http://schemas.openxmlformats.org/drawingml/2006/main">
-            <a:noAutofit/>
-          </a:bodyPr>
-          <a:lstStyle xmlns:a="http://schemas.openxmlformats.org/drawingml/2006/main"/>
-          <a:p xmlns:a="http://schemas.openxmlformats.org/drawingml/2006/main">
-            <a:pPr>
-              <a:buNone/>
-              <a:defRPr sz="1800" b="0">
+        <p:txBody xmlns:a="http://schemas.openxmlformats.org/drawingml/2006/main">
+          <a:bodyPr wrap="square">
+            <a:noAutofit/>
+          </a:bodyPr>
+          <a:lstStyle/>
+          <a:p>
+            <a:pPr>
+              <a:buNone/>
+              <a:defRPr sz="1700" b="0">
                 <a:solidFill>
                   <a:srgbClr val="B8CCC3"/>
                 </a:solidFill>
@@ -6868,7 +6737,7 @@
               </a:defRPr>
             </a:pPr>
             <a:r>
-              <a:rPr sz="1800" b="0">
+              <a:rPr sz="1700" b="0">
                 <a:solidFill>
                   <a:srgbClr val="B8CCC3"/>
                 </a:solidFill>
@@ -6876,13 +6745,13 @@
                 <a:ea typeface="Helvetica Neue"/>
                 <a:cs typeface="Helvetica Neue"/>
               </a:rPr>
-              <a:t>Performs the named</a:t>
-            </a:r>
-          </a:p>
-          <a:p xmlns:a="http://schemas.openxmlformats.org/drawingml/2006/main">
-            <a:pPr>
-              <a:buNone/>
-              <a:defRPr sz="1800" b="0">
+              <a:t>Handle writes and</a:t>
+            </a:r>
+          </a:p>
+          <a:p>
+            <a:pPr>
+              <a:buNone/>
+              <a:defRPr sz="1700" b="0">
                 <a:solidFill>
                   <a:srgbClr val="B8CCC3"/>
                 </a:solidFill>
@@ -6892,7 +6761,7 @@
               </a:defRPr>
             </a:pPr>
             <a:r>
-              <a:rPr sz="1800" b="0">
+              <a:rPr sz="1700" b="0">
                 <a:solidFill>
                   <a:srgbClr val="B8CCC3"/>
                 </a:solidFill>
@@ -6900,7 +6769,7 @@
                 <a:ea typeface="Helvetica Neue"/>
                 <a:cs typeface="Helvetica Neue"/>
               </a:rPr>
-              <a:t>provider operation</a:t>
+              <a:t>signed requests</a:t>
             </a:r>
           </a:p>
         </p:txBody>
@@ -6921,23 +6790,23 @@
         </p:nvSpPr>
         <p:spPr>
           <a:xfrm xmlns:a="http://schemas.openxmlformats.org/drawingml/2006/main">
-            <a:off x="609600" y="5734050"/>
-            <a:ext cx="10953750" cy="952500"/>
-          </a:xfrm>
-          <a:prstGeom xmlns:a="http://schemas.openxmlformats.org/drawingml/2006/main" prst="rect">
-            <a:avLst/>
-          </a:prstGeom>
-          <a:noFill xmlns:a="http://schemas.openxmlformats.org/drawingml/2006/main"/>
-          <a:ln xmlns:a="http://schemas.openxmlformats.org/drawingml/2006/main" w="0">
-            <a:noFill/>
-          </a:ln>
-        </p:spPr>
-        <p:txBody>
-          <a:bodyPr xmlns:a="http://schemas.openxmlformats.org/drawingml/2006/main">
-            <a:noAutofit/>
-          </a:bodyPr>
-          <a:lstStyle xmlns:a="http://schemas.openxmlformats.org/drawingml/2006/main"/>
-          <a:p xmlns:a="http://schemas.openxmlformats.org/drawingml/2006/main">
+            <a:off x="609600" y="5772150"/>
+            <a:ext cx="10953750" cy="866775"/>
+          </a:xfrm>
+          <a:prstGeom xmlns:a="http://schemas.openxmlformats.org/drawingml/2006/main" prst="rect">
+            <a:avLst/>
+          </a:prstGeom>
+          <a:noFill xmlns:a="http://schemas.openxmlformats.org/drawingml/2006/main"/>
+          <a:ln xmlns:a="http://schemas.openxmlformats.org/drawingml/2006/main" w="0">
+            <a:noFill/>
+          </a:ln>
+        </p:spPr>
+        <p:txBody xmlns:a="http://schemas.openxmlformats.org/drawingml/2006/main">
+          <a:bodyPr wrap="square">
+            <a:noAutofit/>
+          </a:bodyPr>
+          <a:lstStyle/>
+          <a:p>
             <a:pPr>
               <a:buNone/>
               <a:defRPr sz="1650" b="0">
@@ -6958,10 +6827,10 @@
                 <a:ea typeface="Helvetica Neue"/>
                 <a:cs typeface="Helvetica Neue"/>
               </a:rPr>
-              <a:t>Connection secrets are stored only in Broker. Its API supports create, rotate and delete, with no read-back.</a:t>
-            </a:r>
-          </a:p>
-          <a:p xmlns:a="http://schemas.openxmlformats.org/drawingml/2006/main">
+              <a:t>Only Broker stores secrets. Enforced egress blocks compiler access to protected providers.</a:t>
+            </a:r>
+          </a:p>
+          <a:p>
             <a:pPr>
               <a:buNone/>
               <a:defRPr sz="1650" b="0">
@@ -6982,7 +6851,7 @@
                 <a:ea typeface="Helvetica Neue"/>
                 <a:cs typeface="Helvetica Neue"/>
               </a:rPr>
-              <a:t>The compiler forwards scoped tokens. Broker uses the secrets internally to call external services.</a:t>
+              <a:t>System previews cannot write. Published views sign stored results without rerunning saves.</a:t>
             </a:r>
           </a:p>
         </p:txBody>

</xml_diff>